<commit_message>
Add process walkthrough video evidence
</commit_message>
<xml_diff>
--- a/unterlagen/Moodle-to-LLM Study Planner - Schlusspräsentation.pptx
+++ b/unterlagen/Moodle-to-LLM Study Planner - Schlusspräsentation.pptx
@@ -2,25 +2,25 @@
 <file path=ppt/presentation.xml><?xml version="1.0" encoding="utf-8"?>
 <p:presentation xmlns:p="http://schemas.openxmlformats.org/presentationml/2006/main">
   <p:sldMasterIdLst>
-    <p:sldMasterId xmlns:r="http://schemas.openxmlformats.org/officeDocument/2006/relationships" id="2147483648" r:id="R6361ee4919a147dd"/>
+    <p:sldMasterId xmlns:r="http://schemas.openxmlformats.org/officeDocument/2006/relationships" id="2147483648" r:id="Ra2c1f601d6f947e7"/>
   </p:sldMasterIdLst>
   <p:notesMasterIdLst>
-    <p:notesMasterId xmlns:r="http://schemas.openxmlformats.org/officeDocument/2006/relationships" r:id="R6b956d1bcf2741ea"/>
+    <p:notesMasterId xmlns:r="http://schemas.openxmlformats.org/officeDocument/2006/relationships" r:id="R22ef729e57b540b3"/>
   </p:notesMasterIdLst>
   <p:sldIdLst>
-    <p:sldId xmlns:r="http://schemas.openxmlformats.org/officeDocument/2006/relationships" id="256" r:id="R0ea2f9005f954b75"/>
-    <p:sldId xmlns:r="http://schemas.openxmlformats.org/officeDocument/2006/relationships" id="257" r:id="Rcec990aba4dc4463"/>
-    <p:sldId xmlns:r="http://schemas.openxmlformats.org/officeDocument/2006/relationships" id="258" r:id="R30daf3c4ec734659"/>
-    <p:sldId xmlns:r="http://schemas.openxmlformats.org/officeDocument/2006/relationships" id="259" r:id="Re2fdf66faf20420f"/>
-    <p:sldId xmlns:r="http://schemas.openxmlformats.org/officeDocument/2006/relationships" id="260" r:id="R606f131ff355496e"/>
-    <p:sldId xmlns:r="http://schemas.openxmlformats.org/officeDocument/2006/relationships" id="261" r:id="R27589701ce40434c"/>
-    <p:sldId xmlns:r="http://schemas.openxmlformats.org/officeDocument/2006/relationships" id="262" r:id="R61e1f6ef6d2e4feb"/>
-    <p:sldId xmlns:r="http://schemas.openxmlformats.org/officeDocument/2006/relationships" id="263" r:id="R3a5798e3ded84224"/>
-    <p:sldId xmlns:r="http://schemas.openxmlformats.org/officeDocument/2006/relationships" id="264" r:id="R0b626d6476bc44ae"/>
-    <p:sldId xmlns:r="http://schemas.openxmlformats.org/officeDocument/2006/relationships" id="265" r:id="Rc42ca289145447c1"/>
-    <p:sldId xmlns:r="http://schemas.openxmlformats.org/officeDocument/2006/relationships" id="266" r:id="R023999348a194786"/>
-    <p:sldId xmlns:r="http://schemas.openxmlformats.org/officeDocument/2006/relationships" id="267" r:id="Rf942122e353f4681"/>
-    <p:sldId xmlns:r="http://schemas.openxmlformats.org/officeDocument/2006/relationships" id="268" r:id="R305c406955b64bcc"/>
+    <p:sldId xmlns:r="http://schemas.openxmlformats.org/officeDocument/2006/relationships" id="256" r:id="R0fd43b25194e4e7c"/>
+    <p:sldId xmlns:r="http://schemas.openxmlformats.org/officeDocument/2006/relationships" id="257" r:id="R6af1f7cf2ee047b5"/>
+    <p:sldId xmlns:r="http://schemas.openxmlformats.org/officeDocument/2006/relationships" id="258" r:id="R38626e7e826441cf"/>
+    <p:sldId xmlns:r="http://schemas.openxmlformats.org/officeDocument/2006/relationships" id="259" r:id="Rc0dd13cee0f748a8"/>
+    <p:sldId xmlns:r="http://schemas.openxmlformats.org/officeDocument/2006/relationships" id="260" r:id="R8488d8392e3e4a92"/>
+    <p:sldId xmlns:r="http://schemas.openxmlformats.org/officeDocument/2006/relationships" id="261" r:id="R6061f2ad5814420f"/>
+    <p:sldId xmlns:r="http://schemas.openxmlformats.org/officeDocument/2006/relationships" id="262" r:id="R1901c74175b54aab"/>
+    <p:sldId xmlns:r="http://schemas.openxmlformats.org/officeDocument/2006/relationships" id="263" r:id="R7ed65a8d5bc54e8e"/>
+    <p:sldId xmlns:r="http://schemas.openxmlformats.org/officeDocument/2006/relationships" id="264" r:id="Rb5ab53858e734787"/>
+    <p:sldId xmlns:r="http://schemas.openxmlformats.org/officeDocument/2006/relationships" id="265" r:id="R957bac55b5ba49a0"/>
+    <p:sldId xmlns:r="http://schemas.openxmlformats.org/officeDocument/2006/relationships" id="266" r:id="R9103b5d022a04765"/>
+    <p:sldId xmlns:r="http://schemas.openxmlformats.org/officeDocument/2006/relationships" id="267" r:id="R669c4cb966a647a6"/>
+    <p:sldId xmlns:r="http://schemas.openxmlformats.org/officeDocument/2006/relationships" id="268" r:id="R3b940b3920e64218"/>
   </p:sldIdLst>
   <p:sldSz cx="12192000" cy="6858000"/>
   <p:notesSz cx="6858000" cy="9144000"/>
@@ -1359,7 +1359,7 @@
   </p:cSld>
   <p:clrMap bg1="lt1" tx1="dk1" bg2="lt2" tx2="dk2" accent1="accent1" accent2="accent2" accent3="accent3" accent4="accent4" accent5="accent5" accent6="accent6" hlink="hlink" folHlink="folHlink"/>
   <p:sldLayoutIdLst>
-    <p:sldLayoutId xmlns:r="http://schemas.openxmlformats.org/officeDocument/2006/relationships" id="2147483649" r:id="R76317554f485448d"/>
+    <p:sldLayoutId xmlns:r="http://schemas.openxmlformats.org/officeDocument/2006/relationships" id="2147483649" r:id="R56b1556f6e884139"/>
   </p:sldLayoutIdLst>
   <p:txStyles>
     <p:titleStyle>
@@ -1658,7 +1658,7 @@
           <p:cNvPr id="1" name="">
             <a:extLst xmlns:a="http://schemas.openxmlformats.org/drawingml/2006/main">
               <a:ext uri="{FF2B5EF4-FFF2-40B4-BE49-F238E27FC236}">
-                <a16:creationId xmlns:a16="http://schemas.microsoft.com/office/drawing/2014/main" id="{AF3303E0-C89A-4E9D-9539-F7F08EA55A0F}"/>
+                <a16:creationId xmlns:a16="http://schemas.microsoft.com/office/drawing/2014/main" id="{0ADB4ADC-EE1C-42A5-BF98-515F414A89D0}"/>
               </a:ext>
             </a:extLst>
           </p:cNvPr>
@@ -1693,7 +1693,7 @@
           <p:cNvPr id="2" name="">
             <a:extLst xmlns:a="http://schemas.openxmlformats.org/drawingml/2006/main">
               <a:ext uri="{FF2B5EF4-FFF2-40B4-BE49-F238E27FC236}">
-                <a16:creationId xmlns:a16="http://schemas.microsoft.com/office/drawing/2014/main" id="{65C9FD22-429B-40E5-B161-D0417B3F4670}"/>
+                <a16:creationId xmlns:a16="http://schemas.microsoft.com/office/drawing/2014/main" id="{DE630650-985B-4849-B96B-CE35492F9628}"/>
               </a:ext>
             </a:extLst>
           </p:cNvPr>
@@ -1728,7 +1728,7 @@
           <p:cNvPr id="3" name="">
             <a:extLst xmlns:a="http://schemas.openxmlformats.org/drawingml/2006/main">
               <a:ext uri="{FF2B5EF4-FFF2-40B4-BE49-F238E27FC236}">
-                <a16:creationId xmlns:a16="http://schemas.microsoft.com/office/drawing/2014/main" id="{E0CC3B78-E23B-4B97-9E8F-EAEF33A36278}"/>
+                <a16:creationId xmlns:a16="http://schemas.microsoft.com/office/drawing/2014/main" id="{078B1FF8-1F6D-434D-9E25-D92F098994DE}"/>
               </a:ext>
             </a:extLst>
           </p:cNvPr>
@@ -1792,7 +1792,7 @@
           <p:cNvPr id="4" name="">
             <a:extLst xmlns:a="http://schemas.openxmlformats.org/drawingml/2006/main">
               <a:ext uri="{FF2B5EF4-FFF2-40B4-BE49-F238E27FC236}">
-                <a16:creationId xmlns:a16="http://schemas.microsoft.com/office/drawing/2014/main" id="{C69D79B0-5EB9-4EB4-8B83-F7373716A9A2}"/>
+                <a16:creationId xmlns:a16="http://schemas.microsoft.com/office/drawing/2014/main" id="{05B5E8EE-3747-4206-AC71-3344337E20C1}"/>
               </a:ext>
             </a:extLst>
           </p:cNvPr>
@@ -1856,7 +1856,7 @@
           <p:cNvPr id="5" name="">
             <a:extLst xmlns:a="http://schemas.openxmlformats.org/drawingml/2006/main">
               <a:ext uri="{FF2B5EF4-FFF2-40B4-BE49-F238E27FC236}">
-                <a16:creationId xmlns:a16="http://schemas.microsoft.com/office/drawing/2014/main" id="{41412C36-8DD8-438E-8AF0-DE2D4CB270FD}"/>
+                <a16:creationId xmlns:a16="http://schemas.microsoft.com/office/drawing/2014/main" id="{AED63360-0241-4A7E-9EE0-B5DD5E24B4EC}"/>
               </a:ext>
             </a:extLst>
           </p:cNvPr>
@@ -1920,7 +1920,7 @@
           <p:cNvPr id="6" name="">
             <a:extLst xmlns:a="http://schemas.openxmlformats.org/drawingml/2006/main">
               <a:ext uri="{FF2B5EF4-FFF2-40B4-BE49-F238E27FC236}">
-                <a16:creationId xmlns:a16="http://schemas.microsoft.com/office/drawing/2014/main" id="{40DD9BC5-F61B-4914-BC0F-B39E38A684AF}"/>
+                <a16:creationId xmlns:a16="http://schemas.microsoft.com/office/drawing/2014/main" id="{433568DD-3F22-4A20-9A7C-3B8785187458}"/>
               </a:ext>
             </a:extLst>
           </p:cNvPr>
@@ -1988,7 +1988,7 @@
           <p:nvPr/>
         </p:nvPicPr>
         <p:blipFill>
-          <a:blip xmlns:r="http://schemas.openxmlformats.org/officeDocument/2006/relationships" xmlns:a="http://schemas.openxmlformats.org/drawingml/2006/main" r:embed="Rdcabb13f50634208"/>
+          <a:blip xmlns:r="http://schemas.openxmlformats.org/officeDocument/2006/relationships" xmlns:a="http://schemas.openxmlformats.org/drawingml/2006/main" r:embed="R16d79602126a41ec"/>
           <a:stretch xmlns:a="http://schemas.openxmlformats.org/drawingml/2006/main"/>
         </p:blipFill>
         <p:spPr>
@@ -2006,7 +2006,7 @@
           <p:cNvPr id="8" name="">
             <a:extLst xmlns:a="http://schemas.openxmlformats.org/drawingml/2006/main">
               <a:ext uri="{FF2B5EF4-FFF2-40B4-BE49-F238E27FC236}">
-                <a16:creationId xmlns:a16="http://schemas.microsoft.com/office/drawing/2014/main" id="{23BE40E5-FDFE-4110-AFFE-CB3D7BE1E51C}"/>
+                <a16:creationId xmlns:a16="http://schemas.microsoft.com/office/drawing/2014/main" id="{00DE4DC7-F78E-493F-B3D1-3B1C4FADC4DC}"/>
               </a:ext>
             </a:extLst>
           </p:cNvPr>
@@ -2039,7 +2039,7 @@
           <p:cNvPr id="9" name="">
             <a:extLst xmlns:a="http://schemas.openxmlformats.org/drawingml/2006/main">
               <a:ext uri="{FF2B5EF4-FFF2-40B4-BE49-F238E27FC236}">
-                <a16:creationId xmlns:a16="http://schemas.microsoft.com/office/drawing/2014/main" id="{051BDF59-17B7-4130-8BCE-0ACEF91F2F2F}"/>
+                <a16:creationId xmlns:a16="http://schemas.microsoft.com/office/drawing/2014/main" id="{06CF65E8-3519-4997-8382-831F16637C5E}"/>
               </a:ext>
             </a:extLst>
           </p:cNvPr>
@@ -2103,7 +2103,7 @@
           <p:cNvPr id="10" name="">
             <a:extLst xmlns:a="http://schemas.openxmlformats.org/drawingml/2006/main">
               <a:ext uri="{FF2B5EF4-FFF2-40B4-BE49-F238E27FC236}">
-                <a16:creationId xmlns:a16="http://schemas.microsoft.com/office/drawing/2014/main" id="{65386626-4E6C-497B-AB6D-4563A0E8C7BE}"/>
+                <a16:creationId xmlns:a16="http://schemas.microsoft.com/office/drawing/2014/main" id="{1CB000F3-CD85-4CA7-9197-BE58A615F119}"/>
               </a:ext>
             </a:extLst>
           </p:cNvPr>
@@ -2167,7 +2167,7 @@
           <p:cNvPr id="11" name="">
             <a:extLst xmlns:a="http://schemas.openxmlformats.org/drawingml/2006/main">
               <a:ext uri="{FF2B5EF4-FFF2-40B4-BE49-F238E27FC236}">
-                <a16:creationId xmlns:a16="http://schemas.microsoft.com/office/drawing/2014/main" id="{16D9E51E-998C-444C-BB25-90922581E44F}"/>
+                <a16:creationId xmlns:a16="http://schemas.microsoft.com/office/drawing/2014/main" id="{DDECD7E9-FCE9-4920-B5DE-21E3D97819C4}"/>
               </a:ext>
             </a:extLst>
           </p:cNvPr>
@@ -2231,7 +2231,7 @@
           <p:cNvPr id="12" name="">
             <a:extLst xmlns:a="http://schemas.openxmlformats.org/drawingml/2006/main">
               <a:ext uri="{FF2B5EF4-FFF2-40B4-BE49-F238E27FC236}">
-                <a16:creationId xmlns:a16="http://schemas.microsoft.com/office/drawing/2014/main" id="{51CE8EC4-AB73-4B9A-B196-B1D03723B88B}"/>
+                <a16:creationId xmlns:a16="http://schemas.microsoft.com/office/drawing/2014/main" id="{251BAAB5-9BE6-4E7B-A5C0-AEE2D46895A1}"/>
               </a:ext>
             </a:extLst>
           </p:cNvPr>
@@ -2264,7 +2264,7 @@
           <p:cNvPr id="13" name="">
             <a:extLst xmlns:a="http://schemas.openxmlformats.org/drawingml/2006/main">
               <a:ext uri="{FF2B5EF4-FFF2-40B4-BE49-F238E27FC236}">
-                <a16:creationId xmlns:a16="http://schemas.microsoft.com/office/drawing/2014/main" id="{868AC05D-F405-4E12-AE86-12D33F44C60A}"/>
+                <a16:creationId xmlns:a16="http://schemas.microsoft.com/office/drawing/2014/main" id="{9A547B6E-D3D0-4E6D-BDFB-9EA6D4ABEC1C}"/>
               </a:ext>
             </a:extLst>
           </p:cNvPr>
@@ -2328,7 +2328,7 @@
           <p:cNvPr id="14" name="">
             <a:extLst xmlns:a="http://schemas.openxmlformats.org/drawingml/2006/main">
               <a:ext uri="{FF2B5EF4-FFF2-40B4-BE49-F238E27FC236}">
-                <a16:creationId xmlns:a16="http://schemas.microsoft.com/office/drawing/2014/main" id="{22B16ACC-9ACE-412D-8B8B-DEA54D26226D}"/>
+                <a16:creationId xmlns:a16="http://schemas.microsoft.com/office/drawing/2014/main" id="{2EFC0976-8847-438F-ABB7-4A023913A73B}"/>
               </a:ext>
             </a:extLst>
           </p:cNvPr>
@@ -2392,7 +2392,7 @@
           <p:cNvPr id="15" name="">
             <a:extLst xmlns:a="http://schemas.openxmlformats.org/drawingml/2006/main">
               <a:ext uri="{FF2B5EF4-FFF2-40B4-BE49-F238E27FC236}">
-                <a16:creationId xmlns:a16="http://schemas.microsoft.com/office/drawing/2014/main" id="{83725E1D-D972-4E8D-97A5-2DABF846A434}"/>
+                <a16:creationId xmlns:a16="http://schemas.microsoft.com/office/drawing/2014/main" id="{B97C9F8F-A73E-4484-9ABF-78292B41B4A6}"/>
               </a:ext>
             </a:extLst>
           </p:cNvPr>
@@ -2456,7 +2456,7 @@
           <p:cNvPr id="16" name="">
             <a:extLst xmlns:a="http://schemas.openxmlformats.org/drawingml/2006/main">
               <a:ext uri="{FF2B5EF4-FFF2-40B4-BE49-F238E27FC236}">
-                <a16:creationId xmlns:a16="http://schemas.microsoft.com/office/drawing/2014/main" id="{BFEC86D0-2FE9-441C-8EA4-5F9D0D972EC6}"/>
+                <a16:creationId xmlns:a16="http://schemas.microsoft.com/office/drawing/2014/main" id="{C4E92760-191B-40C3-86D1-F1326C7D1E0A}"/>
               </a:ext>
             </a:extLst>
           </p:cNvPr>
@@ -2489,7 +2489,7 @@
           <p:cNvPr id="17" name="">
             <a:extLst xmlns:a="http://schemas.openxmlformats.org/drawingml/2006/main">
               <a:ext uri="{FF2B5EF4-FFF2-40B4-BE49-F238E27FC236}">
-                <a16:creationId xmlns:a16="http://schemas.microsoft.com/office/drawing/2014/main" id="{4C4042E8-5183-449F-AB1F-EA2751ED3ECB}"/>
+                <a16:creationId xmlns:a16="http://schemas.microsoft.com/office/drawing/2014/main" id="{0A7340B2-E20C-45D8-AF77-777A541F17E1}"/>
               </a:ext>
             </a:extLst>
           </p:cNvPr>
@@ -2553,7 +2553,7 @@
           <p:cNvPr id="18" name="">
             <a:extLst xmlns:a="http://schemas.openxmlformats.org/drawingml/2006/main">
               <a:ext uri="{FF2B5EF4-FFF2-40B4-BE49-F238E27FC236}">
-                <a16:creationId xmlns:a16="http://schemas.microsoft.com/office/drawing/2014/main" id="{6BAA9528-AF96-4401-8EAC-99351F4902EE}"/>
+                <a16:creationId xmlns:a16="http://schemas.microsoft.com/office/drawing/2014/main" id="{961DADDD-6EEF-433D-B682-E1370AC67145}"/>
               </a:ext>
             </a:extLst>
           </p:cNvPr>
@@ -2617,7 +2617,7 @@
           <p:cNvPr id="19" name="">
             <a:extLst xmlns:a="http://schemas.openxmlformats.org/drawingml/2006/main">
               <a:ext uri="{FF2B5EF4-FFF2-40B4-BE49-F238E27FC236}">
-                <a16:creationId xmlns:a16="http://schemas.microsoft.com/office/drawing/2014/main" id="{E13CE8C1-131C-4566-BA57-27744F9F9CA8}"/>
+                <a16:creationId xmlns:a16="http://schemas.microsoft.com/office/drawing/2014/main" id="{9775B5A6-92D2-4DBC-AF2D-8B7DED73798F}"/>
               </a:ext>
             </a:extLst>
           </p:cNvPr>
@@ -2681,7 +2681,7 @@
           <p:cNvPr id="20" name="">
             <a:extLst xmlns:a="http://schemas.openxmlformats.org/drawingml/2006/main">
               <a:ext uri="{FF2B5EF4-FFF2-40B4-BE49-F238E27FC236}">
-                <a16:creationId xmlns:a16="http://schemas.microsoft.com/office/drawing/2014/main" id="{E341AC5D-3A62-4137-8A2E-AA1B7E7CFC47}"/>
+                <a16:creationId xmlns:a16="http://schemas.microsoft.com/office/drawing/2014/main" id="{9DA2D96A-7746-4A99-8533-F0152A374AAF}"/>
               </a:ext>
             </a:extLst>
           </p:cNvPr>
@@ -2743,7 +2743,7 @@
     </p:spTree>
     <p:extLst>
       <p:ext uri="{BB962C8B-B14F-4D97-AF65-F5344CB8AC3E}">
-        <p14:creationId xmlns:p14="http://schemas.microsoft.com/office/powerpoint/2010/main" val="1077668948"/>
+        <p14:creationId xmlns:p14="http://schemas.microsoft.com/office/powerpoint/2010/main" val="430081972"/>
       </p:ext>
     </p:extLst>
   </p:cSld>
@@ -2767,7 +2767,7 @@
           <p:cNvPr id="1" name="">
             <a:extLst xmlns:a="http://schemas.openxmlformats.org/drawingml/2006/main">
               <a:ext uri="{FF2B5EF4-FFF2-40B4-BE49-F238E27FC236}">
-                <a16:creationId xmlns:a16="http://schemas.microsoft.com/office/drawing/2014/main" id="{41720673-8090-460A-9CF5-B5B5789CFEDE}"/>
+                <a16:creationId xmlns:a16="http://schemas.microsoft.com/office/drawing/2014/main" id="{6D327093-2EC2-47F7-997E-C2798990535F}"/>
               </a:ext>
             </a:extLst>
           </p:cNvPr>
@@ -2802,7 +2802,7 @@
           <p:cNvPr id="2" name="">
             <a:extLst xmlns:a="http://schemas.openxmlformats.org/drawingml/2006/main">
               <a:ext uri="{FF2B5EF4-FFF2-40B4-BE49-F238E27FC236}">
-                <a16:creationId xmlns:a16="http://schemas.microsoft.com/office/drawing/2014/main" id="{695CFC91-26B4-47C7-99C2-D9C719F1DE4B}"/>
+                <a16:creationId xmlns:a16="http://schemas.microsoft.com/office/drawing/2014/main" id="{F6ED9D0D-48ED-46C0-9169-E70E52E3FC28}"/>
               </a:ext>
             </a:extLst>
           </p:cNvPr>
@@ -2837,7 +2837,7 @@
           <p:cNvPr id="3" name="">
             <a:extLst xmlns:a="http://schemas.openxmlformats.org/drawingml/2006/main">
               <a:ext uri="{FF2B5EF4-FFF2-40B4-BE49-F238E27FC236}">
-                <a16:creationId xmlns:a16="http://schemas.microsoft.com/office/drawing/2014/main" id="{048B3D50-1049-4E70-BCD3-8AAEE3F8589F}"/>
+                <a16:creationId xmlns:a16="http://schemas.microsoft.com/office/drawing/2014/main" id="{CE7BD99C-FA25-484C-92D3-DE1FBBCFFA91}"/>
               </a:ext>
             </a:extLst>
           </p:cNvPr>
@@ -2901,7 +2901,7 @@
           <p:cNvPr id="4" name="">
             <a:extLst xmlns:a="http://schemas.openxmlformats.org/drawingml/2006/main">
               <a:ext uri="{FF2B5EF4-FFF2-40B4-BE49-F238E27FC236}">
-                <a16:creationId xmlns:a16="http://schemas.microsoft.com/office/drawing/2014/main" id="{3A6270D6-479C-48E6-98FD-6366D27FD1A3}"/>
+                <a16:creationId xmlns:a16="http://schemas.microsoft.com/office/drawing/2014/main" id="{5A305F26-077E-49B4-96E2-191EA12078BD}"/>
               </a:ext>
             </a:extLst>
           </p:cNvPr>
@@ -2965,7 +2965,7 @@
           <p:cNvPr id="5" name="">
             <a:extLst xmlns:a="http://schemas.openxmlformats.org/drawingml/2006/main">
               <a:ext uri="{FF2B5EF4-FFF2-40B4-BE49-F238E27FC236}">
-                <a16:creationId xmlns:a16="http://schemas.microsoft.com/office/drawing/2014/main" id="{59E6BED4-368D-4EFA-B251-35C4349D281B}"/>
+                <a16:creationId xmlns:a16="http://schemas.microsoft.com/office/drawing/2014/main" id="{EAF634DB-2191-4FB1-A47F-020C04BC9B15}"/>
               </a:ext>
             </a:extLst>
           </p:cNvPr>
@@ -3029,7 +3029,7 @@
           <p:cNvPr id="6" name="">
             <a:extLst xmlns:a="http://schemas.openxmlformats.org/drawingml/2006/main">
               <a:ext uri="{FF2B5EF4-FFF2-40B4-BE49-F238E27FC236}">
-                <a16:creationId xmlns:a16="http://schemas.microsoft.com/office/drawing/2014/main" id="{CCBC609F-344F-420E-8FE3-E700DE4B277D}"/>
+                <a16:creationId xmlns:a16="http://schemas.microsoft.com/office/drawing/2014/main" id="{1B45298F-72D0-48E9-949F-EA05F23744E8}"/>
               </a:ext>
             </a:extLst>
           </p:cNvPr>
@@ -3097,7 +3097,7 @@
           <p:nvPr/>
         </p:nvPicPr>
         <p:blipFill>
-          <a:blip xmlns:r="http://schemas.openxmlformats.org/officeDocument/2006/relationships" xmlns:a="http://schemas.openxmlformats.org/drawingml/2006/main" r:embed="Rcd504a49ce3d43bb"/>
+          <a:blip xmlns:r="http://schemas.openxmlformats.org/officeDocument/2006/relationships" xmlns:a="http://schemas.openxmlformats.org/drawingml/2006/main" r:embed="Ref83be5170e94486"/>
           <a:stretch xmlns:a="http://schemas.openxmlformats.org/drawingml/2006/main"/>
         </p:blipFill>
         <p:spPr>
@@ -3119,7 +3119,7 @@
           <p:nvPr/>
         </p:nvPicPr>
         <p:blipFill>
-          <a:blip xmlns:r="http://schemas.openxmlformats.org/officeDocument/2006/relationships" xmlns:a="http://schemas.openxmlformats.org/drawingml/2006/main" r:embed="Rf6d35c5071ab4c22"/>
+          <a:blip xmlns:r="http://schemas.openxmlformats.org/officeDocument/2006/relationships" xmlns:a="http://schemas.openxmlformats.org/drawingml/2006/main" r:embed="R745b0e26346a41b0"/>
           <a:stretch xmlns:a="http://schemas.openxmlformats.org/drawingml/2006/main"/>
         </p:blipFill>
         <p:spPr>
@@ -3137,7 +3137,7 @@
           <p:cNvPr id="9" name="">
             <a:extLst xmlns:a="http://schemas.openxmlformats.org/drawingml/2006/main">
               <a:ext uri="{FF2B5EF4-FFF2-40B4-BE49-F238E27FC236}">
-                <a16:creationId xmlns:a16="http://schemas.microsoft.com/office/drawing/2014/main" id="{37FA126D-C264-4E2D-9F79-EE8DA07D36F6}"/>
+                <a16:creationId xmlns:a16="http://schemas.microsoft.com/office/drawing/2014/main" id="{03003FD6-5FCA-4384-AF9D-D20227890BA6}"/>
               </a:ext>
             </a:extLst>
           </p:cNvPr>
@@ -3201,7 +3201,7 @@
           <p:cNvPr id="10" name="">
             <a:extLst xmlns:a="http://schemas.openxmlformats.org/drawingml/2006/main">
               <a:ext uri="{FF2B5EF4-FFF2-40B4-BE49-F238E27FC236}">
-                <a16:creationId xmlns:a16="http://schemas.microsoft.com/office/drawing/2014/main" id="{0004B949-F3E0-426C-9120-7A08F30163A6}"/>
+                <a16:creationId xmlns:a16="http://schemas.microsoft.com/office/drawing/2014/main" id="{181C230A-C173-43E3-93F6-22E31503802E}"/>
               </a:ext>
             </a:extLst>
           </p:cNvPr>
@@ -3263,7 +3263,7 @@
     </p:spTree>
     <p:extLst>
       <p:ext uri="{BB962C8B-B14F-4D97-AF65-F5344CB8AC3E}">
-        <p14:creationId xmlns:p14="http://schemas.microsoft.com/office/powerpoint/2010/main" val="686781187"/>
+        <p14:creationId xmlns:p14="http://schemas.microsoft.com/office/powerpoint/2010/main" val="261663501"/>
       </p:ext>
     </p:extLst>
   </p:cSld>
@@ -3287,7 +3287,7 @@
           <p:cNvPr id="1" name="">
             <a:extLst xmlns:a="http://schemas.openxmlformats.org/drawingml/2006/main">
               <a:ext uri="{FF2B5EF4-FFF2-40B4-BE49-F238E27FC236}">
-                <a16:creationId xmlns:a16="http://schemas.microsoft.com/office/drawing/2014/main" id="{FB249A7E-BC84-4E15-B21E-2E5AAE91A2FF}"/>
+                <a16:creationId xmlns:a16="http://schemas.microsoft.com/office/drawing/2014/main" id="{38749AA9-AF4C-4765-8695-BC267B5E22CB}"/>
               </a:ext>
             </a:extLst>
           </p:cNvPr>
@@ -3322,7 +3322,7 @@
           <p:cNvPr id="2" name="">
             <a:extLst xmlns:a="http://schemas.openxmlformats.org/drawingml/2006/main">
               <a:ext uri="{FF2B5EF4-FFF2-40B4-BE49-F238E27FC236}">
-                <a16:creationId xmlns:a16="http://schemas.microsoft.com/office/drawing/2014/main" id="{5426733E-C2DC-4B84-841A-8E6914D89D0C}"/>
+                <a16:creationId xmlns:a16="http://schemas.microsoft.com/office/drawing/2014/main" id="{9F3B09CF-B62E-4C83-B55D-B77E331B7567}"/>
               </a:ext>
             </a:extLst>
           </p:cNvPr>
@@ -3357,7 +3357,7 @@
           <p:cNvPr id="3" name="">
             <a:extLst xmlns:a="http://schemas.openxmlformats.org/drawingml/2006/main">
               <a:ext uri="{FF2B5EF4-FFF2-40B4-BE49-F238E27FC236}">
-                <a16:creationId xmlns:a16="http://schemas.microsoft.com/office/drawing/2014/main" id="{282346A0-2125-46F3-A01B-D995D06703D0}"/>
+                <a16:creationId xmlns:a16="http://schemas.microsoft.com/office/drawing/2014/main" id="{69C97356-0535-4BAE-B5B3-AF269621F577}"/>
               </a:ext>
             </a:extLst>
           </p:cNvPr>
@@ -3421,7 +3421,7 @@
           <p:cNvPr id="4" name="">
             <a:extLst xmlns:a="http://schemas.openxmlformats.org/drawingml/2006/main">
               <a:ext uri="{FF2B5EF4-FFF2-40B4-BE49-F238E27FC236}">
-                <a16:creationId xmlns:a16="http://schemas.microsoft.com/office/drawing/2014/main" id="{E97F7007-4A03-4834-85F2-AEA901A2F241}"/>
+                <a16:creationId xmlns:a16="http://schemas.microsoft.com/office/drawing/2014/main" id="{90AB448C-6158-4844-A24E-7F076FCB86A8}"/>
               </a:ext>
             </a:extLst>
           </p:cNvPr>
@@ -3485,7 +3485,7 @@
           <p:cNvPr id="5" name="">
             <a:extLst xmlns:a="http://schemas.openxmlformats.org/drawingml/2006/main">
               <a:ext uri="{FF2B5EF4-FFF2-40B4-BE49-F238E27FC236}">
-                <a16:creationId xmlns:a16="http://schemas.microsoft.com/office/drawing/2014/main" id="{BBB77647-1A1B-44B1-8553-0BC34D57FF93}"/>
+                <a16:creationId xmlns:a16="http://schemas.microsoft.com/office/drawing/2014/main" id="{6478049E-5B6B-4BFA-BF52-4D9CBE372523}"/>
               </a:ext>
             </a:extLst>
           </p:cNvPr>
@@ -3549,7 +3549,7 @@
           <p:cNvPr id="6" name="">
             <a:extLst xmlns:a="http://schemas.openxmlformats.org/drawingml/2006/main">
               <a:ext uri="{FF2B5EF4-FFF2-40B4-BE49-F238E27FC236}">
-                <a16:creationId xmlns:a16="http://schemas.microsoft.com/office/drawing/2014/main" id="{D627C04A-EB5E-45FF-89A0-89F579CC1377}"/>
+                <a16:creationId xmlns:a16="http://schemas.microsoft.com/office/drawing/2014/main" id="{EEC1ECE7-33A2-4E04-A3C8-2254405EDC95}"/>
               </a:ext>
             </a:extLst>
           </p:cNvPr>
@@ -3613,7 +3613,7 @@
           <p:cNvPr id="7" name="">
             <a:extLst xmlns:a="http://schemas.openxmlformats.org/drawingml/2006/main">
               <a:ext uri="{FF2B5EF4-FFF2-40B4-BE49-F238E27FC236}">
-                <a16:creationId xmlns:a16="http://schemas.microsoft.com/office/drawing/2014/main" id="{AAF2122E-1D58-4C85-BD2B-79434EF955F0}"/>
+                <a16:creationId xmlns:a16="http://schemas.microsoft.com/office/drawing/2014/main" id="{23E88168-477A-4B95-BF1B-8D24F9B21D79}"/>
               </a:ext>
             </a:extLst>
           </p:cNvPr>
@@ -3646,7 +3646,7 @@
           <p:cNvPr id="8" name="">
             <a:extLst xmlns:a="http://schemas.openxmlformats.org/drawingml/2006/main">
               <a:ext uri="{FF2B5EF4-FFF2-40B4-BE49-F238E27FC236}">
-                <a16:creationId xmlns:a16="http://schemas.microsoft.com/office/drawing/2014/main" id="{AAC6631E-5ABB-4C9F-BB99-AFC3FBF7793A}"/>
+                <a16:creationId xmlns:a16="http://schemas.microsoft.com/office/drawing/2014/main" id="{6AAA8585-6390-4A54-8D82-32A10C27BCE6}"/>
               </a:ext>
             </a:extLst>
           </p:cNvPr>
@@ -3710,7 +3710,7 @@
           <p:cNvPr id="9" name="">
             <a:extLst xmlns:a="http://schemas.openxmlformats.org/drawingml/2006/main">
               <a:ext uri="{FF2B5EF4-FFF2-40B4-BE49-F238E27FC236}">
-                <a16:creationId xmlns:a16="http://schemas.microsoft.com/office/drawing/2014/main" id="{8610DCBA-1538-4273-9B58-911ED80BE7FA}"/>
+                <a16:creationId xmlns:a16="http://schemas.microsoft.com/office/drawing/2014/main" id="{632A539E-C2A2-4FF3-A135-CF480AB76143}"/>
               </a:ext>
             </a:extLst>
           </p:cNvPr>
@@ -3774,7 +3774,7 @@
           <p:cNvPr id="10" name="">
             <a:extLst xmlns:a="http://schemas.openxmlformats.org/drawingml/2006/main">
               <a:ext uri="{FF2B5EF4-FFF2-40B4-BE49-F238E27FC236}">
-                <a16:creationId xmlns:a16="http://schemas.microsoft.com/office/drawing/2014/main" id="{C955B777-EA45-47DE-92EF-0732F023AE2F}"/>
+                <a16:creationId xmlns:a16="http://schemas.microsoft.com/office/drawing/2014/main" id="{A36C0357-D649-46A3-B1F7-DB41D5F88AC6}"/>
               </a:ext>
             </a:extLst>
           </p:cNvPr>
@@ -3838,7 +3838,7 @@
           <p:cNvPr id="11" name="">
             <a:extLst xmlns:a="http://schemas.openxmlformats.org/drawingml/2006/main">
               <a:ext uri="{FF2B5EF4-FFF2-40B4-BE49-F238E27FC236}">
-                <a16:creationId xmlns:a16="http://schemas.microsoft.com/office/drawing/2014/main" id="{B2255E52-33E2-43D4-9477-CAA4137188C3}"/>
+                <a16:creationId xmlns:a16="http://schemas.microsoft.com/office/drawing/2014/main" id="{00E6016E-E440-48AD-900A-6C60AB72CF3A}"/>
               </a:ext>
             </a:extLst>
           </p:cNvPr>
@@ -3871,7 +3871,7 @@
           <p:cNvPr id="12" name="">
             <a:extLst xmlns:a="http://schemas.openxmlformats.org/drawingml/2006/main">
               <a:ext uri="{FF2B5EF4-FFF2-40B4-BE49-F238E27FC236}">
-                <a16:creationId xmlns:a16="http://schemas.microsoft.com/office/drawing/2014/main" id="{C10C1AC3-1D68-4248-A66D-3F758C1F3D96}"/>
+                <a16:creationId xmlns:a16="http://schemas.microsoft.com/office/drawing/2014/main" id="{B85C2809-A659-4B07-824D-6FC798895BF6}"/>
               </a:ext>
             </a:extLst>
           </p:cNvPr>
@@ -3935,7 +3935,7 @@
           <p:cNvPr id="13" name="">
             <a:extLst xmlns:a="http://schemas.openxmlformats.org/drawingml/2006/main">
               <a:ext uri="{FF2B5EF4-FFF2-40B4-BE49-F238E27FC236}">
-                <a16:creationId xmlns:a16="http://schemas.microsoft.com/office/drawing/2014/main" id="{2E2BBEB8-3CD8-4A80-98AD-B93AA9AF36BB}"/>
+                <a16:creationId xmlns:a16="http://schemas.microsoft.com/office/drawing/2014/main" id="{70BA833C-FA14-4B75-859D-9D7FE02B2804}"/>
               </a:ext>
             </a:extLst>
           </p:cNvPr>
@@ -3999,7 +3999,7 @@
           <p:cNvPr id="14" name="">
             <a:extLst xmlns:a="http://schemas.openxmlformats.org/drawingml/2006/main">
               <a:ext uri="{FF2B5EF4-FFF2-40B4-BE49-F238E27FC236}">
-                <a16:creationId xmlns:a16="http://schemas.microsoft.com/office/drawing/2014/main" id="{819D9305-3707-4FBB-A2B0-639B61A964BE}"/>
+                <a16:creationId xmlns:a16="http://schemas.microsoft.com/office/drawing/2014/main" id="{96149592-03A6-44C1-8D2C-1D835C9BFCE2}"/>
               </a:ext>
             </a:extLst>
           </p:cNvPr>
@@ -4063,7 +4063,7 @@
           <p:cNvPr id="15" name="">
             <a:extLst xmlns:a="http://schemas.openxmlformats.org/drawingml/2006/main">
               <a:ext uri="{FF2B5EF4-FFF2-40B4-BE49-F238E27FC236}">
-                <a16:creationId xmlns:a16="http://schemas.microsoft.com/office/drawing/2014/main" id="{3777BAA7-E6AF-4660-8AA7-287C306C057A}"/>
+                <a16:creationId xmlns:a16="http://schemas.microsoft.com/office/drawing/2014/main" id="{2EB7CAA4-6CF9-4FB7-A66D-6F3CD3D53CFF}"/>
               </a:ext>
             </a:extLst>
           </p:cNvPr>
@@ -4096,7 +4096,7 @@
           <p:cNvPr id="16" name="">
             <a:extLst xmlns:a="http://schemas.openxmlformats.org/drawingml/2006/main">
               <a:ext uri="{FF2B5EF4-FFF2-40B4-BE49-F238E27FC236}">
-                <a16:creationId xmlns:a16="http://schemas.microsoft.com/office/drawing/2014/main" id="{2CB3FCEF-E785-4FFE-B6D5-9E026924318D}"/>
+                <a16:creationId xmlns:a16="http://schemas.microsoft.com/office/drawing/2014/main" id="{CD2BCBB7-7121-4C05-A011-7FC1006A976D}"/>
               </a:ext>
             </a:extLst>
           </p:cNvPr>
@@ -4160,7 +4160,7 @@
           <p:cNvPr id="17" name="">
             <a:extLst xmlns:a="http://schemas.openxmlformats.org/drawingml/2006/main">
               <a:ext uri="{FF2B5EF4-FFF2-40B4-BE49-F238E27FC236}">
-                <a16:creationId xmlns:a16="http://schemas.microsoft.com/office/drawing/2014/main" id="{DA051B49-FF99-42CD-A8BC-C6B7C523C8E8}"/>
+                <a16:creationId xmlns:a16="http://schemas.microsoft.com/office/drawing/2014/main" id="{D01FE734-62F2-493E-A2BE-B96E1245C9F7}"/>
               </a:ext>
             </a:extLst>
           </p:cNvPr>
@@ -4224,7 +4224,7 @@
           <p:cNvPr id="18" name="">
             <a:extLst xmlns:a="http://schemas.openxmlformats.org/drawingml/2006/main">
               <a:ext uri="{FF2B5EF4-FFF2-40B4-BE49-F238E27FC236}">
-                <a16:creationId xmlns:a16="http://schemas.microsoft.com/office/drawing/2014/main" id="{316FD11F-4087-4A18-BA64-566446DE4B89}"/>
+                <a16:creationId xmlns:a16="http://schemas.microsoft.com/office/drawing/2014/main" id="{BD7A9F12-AD3C-4C88-8C0D-BDE489C51895}"/>
               </a:ext>
             </a:extLst>
           </p:cNvPr>
@@ -4288,7 +4288,7 @@
           <p:cNvPr id="19" name="">
             <a:extLst xmlns:a="http://schemas.openxmlformats.org/drawingml/2006/main">
               <a:ext uri="{FF2B5EF4-FFF2-40B4-BE49-F238E27FC236}">
-                <a16:creationId xmlns:a16="http://schemas.microsoft.com/office/drawing/2014/main" id="{6D02F8C3-E463-4B0E-9599-BD1AF3C3596F}"/>
+                <a16:creationId xmlns:a16="http://schemas.microsoft.com/office/drawing/2014/main" id="{6C656D5D-988C-4FCC-BEC5-7B050B6356C8}"/>
               </a:ext>
             </a:extLst>
           </p:cNvPr>
@@ -4321,7 +4321,7 @@
           <p:cNvPr id="20" name="">
             <a:extLst xmlns:a="http://schemas.openxmlformats.org/drawingml/2006/main">
               <a:ext uri="{FF2B5EF4-FFF2-40B4-BE49-F238E27FC236}">
-                <a16:creationId xmlns:a16="http://schemas.microsoft.com/office/drawing/2014/main" id="{35B08F54-A2A8-4806-939C-FFD0E8C19B4D}"/>
+                <a16:creationId xmlns:a16="http://schemas.microsoft.com/office/drawing/2014/main" id="{326B002E-9589-43E6-A88E-6D0CC0D881E1}"/>
               </a:ext>
             </a:extLst>
           </p:cNvPr>
@@ -4385,7 +4385,7 @@
           <p:cNvPr id="21" name="">
             <a:extLst xmlns:a="http://schemas.openxmlformats.org/drawingml/2006/main">
               <a:ext uri="{FF2B5EF4-FFF2-40B4-BE49-F238E27FC236}">
-                <a16:creationId xmlns:a16="http://schemas.microsoft.com/office/drawing/2014/main" id="{CA550C6B-7029-4DA1-9F3B-D72998FF379C}"/>
+                <a16:creationId xmlns:a16="http://schemas.microsoft.com/office/drawing/2014/main" id="{7967C4EB-C435-47E9-A235-37F9A2905E2B}"/>
               </a:ext>
             </a:extLst>
           </p:cNvPr>
@@ -4449,7 +4449,7 @@
           <p:cNvPr id="22" name="">
             <a:extLst xmlns:a="http://schemas.openxmlformats.org/drawingml/2006/main">
               <a:ext uri="{FF2B5EF4-FFF2-40B4-BE49-F238E27FC236}">
-                <a16:creationId xmlns:a16="http://schemas.microsoft.com/office/drawing/2014/main" id="{023A5F92-C9E4-4BBC-ABF5-B31D11407D53}"/>
+                <a16:creationId xmlns:a16="http://schemas.microsoft.com/office/drawing/2014/main" id="{F873ABF7-C233-4D83-88AF-C2FF91AB7037}"/>
               </a:ext>
             </a:extLst>
           </p:cNvPr>
@@ -4513,7 +4513,7 @@
           <p:cNvPr id="23" name="">
             <a:extLst xmlns:a="http://schemas.openxmlformats.org/drawingml/2006/main">
               <a:ext uri="{FF2B5EF4-FFF2-40B4-BE49-F238E27FC236}">
-                <a16:creationId xmlns:a16="http://schemas.microsoft.com/office/drawing/2014/main" id="{733FDA1D-2AE9-4A18-9784-E473C9F296BD}"/>
+                <a16:creationId xmlns:a16="http://schemas.microsoft.com/office/drawing/2014/main" id="{03F44756-1B90-496E-AAD9-0B034A9E614D}"/>
               </a:ext>
             </a:extLst>
           </p:cNvPr>
@@ -4546,7 +4546,7 @@
           <p:cNvPr id="24" name="">
             <a:extLst xmlns:a="http://schemas.openxmlformats.org/drawingml/2006/main">
               <a:ext uri="{FF2B5EF4-FFF2-40B4-BE49-F238E27FC236}">
-                <a16:creationId xmlns:a16="http://schemas.microsoft.com/office/drawing/2014/main" id="{46F0A442-E2AA-4823-A68C-05CD246E5B16}"/>
+                <a16:creationId xmlns:a16="http://schemas.microsoft.com/office/drawing/2014/main" id="{694E7741-3F90-4D5D-AC09-CDD0FA57F1B5}"/>
               </a:ext>
             </a:extLst>
           </p:cNvPr>
@@ -4610,7 +4610,7 @@
           <p:cNvPr id="25" name="">
             <a:extLst xmlns:a="http://schemas.openxmlformats.org/drawingml/2006/main">
               <a:ext uri="{FF2B5EF4-FFF2-40B4-BE49-F238E27FC236}">
-                <a16:creationId xmlns:a16="http://schemas.microsoft.com/office/drawing/2014/main" id="{97DF2756-DA73-4FBE-8EB5-D1211AD2F4CB}"/>
+                <a16:creationId xmlns:a16="http://schemas.microsoft.com/office/drawing/2014/main" id="{69B06AB8-078E-4E00-BE13-A450B7235895}"/>
               </a:ext>
             </a:extLst>
           </p:cNvPr>
@@ -4672,7 +4672,7 @@
     </p:spTree>
     <p:extLst>
       <p:ext uri="{BB962C8B-B14F-4D97-AF65-F5344CB8AC3E}">
-        <p14:creationId xmlns:p14="http://schemas.microsoft.com/office/powerpoint/2010/main" val="692924471"/>
+        <p14:creationId xmlns:p14="http://schemas.microsoft.com/office/powerpoint/2010/main" val="1280371432"/>
       </p:ext>
     </p:extLst>
   </p:cSld>
@@ -4696,7 +4696,7 @@
           <p:cNvPr id="1" name="">
             <a:extLst xmlns:a="http://schemas.openxmlformats.org/drawingml/2006/main">
               <a:ext uri="{FF2B5EF4-FFF2-40B4-BE49-F238E27FC236}">
-                <a16:creationId xmlns:a16="http://schemas.microsoft.com/office/drawing/2014/main" id="{3A37FB78-3DED-44D2-835B-CD3C16B58D63}"/>
+                <a16:creationId xmlns:a16="http://schemas.microsoft.com/office/drawing/2014/main" id="{6C146FDB-7F11-4CAD-BB68-27D0F3B7492B}"/>
               </a:ext>
             </a:extLst>
           </p:cNvPr>
@@ -4731,7 +4731,7 @@
           <p:cNvPr id="2" name="">
             <a:extLst xmlns:a="http://schemas.openxmlformats.org/drawingml/2006/main">
               <a:ext uri="{FF2B5EF4-FFF2-40B4-BE49-F238E27FC236}">
-                <a16:creationId xmlns:a16="http://schemas.microsoft.com/office/drawing/2014/main" id="{0D9A3FD4-3A74-4697-A6ED-9394AD7C7977}"/>
+                <a16:creationId xmlns:a16="http://schemas.microsoft.com/office/drawing/2014/main" id="{C6D1A98D-9ADD-4FEE-AAD2-8B6780718B8A}"/>
               </a:ext>
             </a:extLst>
           </p:cNvPr>
@@ -4766,7 +4766,7 @@
           <p:cNvPr id="3" name="">
             <a:extLst xmlns:a="http://schemas.openxmlformats.org/drawingml/2006/main">
               <a:ext uri="{FF2B5EF4-FFF2-40B4-BE49-F238E27FC236}">
-                <a16:creationId xmlns:a16="http://schemas.microsoft.com/office/drawing/2014/main" id="{BC206AED-7129-4D6C-B738-D8F7E5ECF0BD}"/>
+                <a16:creationId xmlns:a16="http://schemas.microsoft.com/office/drawing/2014/main" id="{8B58CC05-B6AB-466B-8C68-39E2F425FA68}"/>
               </a:ext>
             </a:extLst>
           </p:cNvPr>
@@ -4830,7 +4830,7 @@
           <p:cNvPr id="4" name="">
             <a:extLst xmlns:a="http://schemas.openxmlformats.org/drawingml/2006/main">
               <a:ext uri="{FF2B5EF4-FFF2-40B4-BE49-F238E27FC236}">
-                <a16:creationId xmlns:a16="http://schemas.microsoft.com/office/drawing/2014/main" id="{6B600413-1A26-437E-8DF0-E6E4C63B1632}"/>
+                <a16:creationId xmlns:a16="http://schemas.microsoft.com/office/drawing/2014/main" id="{6EE35478-4E50-44D5-97AD-C6CC6A65C71E}"/>
               </a:ext>
             </a:extLst>
           </p:cNvPr>
@@ -4894,7 +4894,7 @@
           <p:cNvPr id="5" name="">
             <a:extLst xmlns:a="http://schemas.openxmlformats.org/drawingml/2006/main">
               <a:ext uri="{FF2B5EF4-FFF2-40B4-BE49-F238E27FC236}">
-                <a16:creationId xmlns:a16="http://schemas.microsoft.com/office/drawing/2014/main" id="{AA018561-293A-4673-9555-FD6DC65D49EC}"/>
+                <a16:creationId xmlns:a16="http://schemas.microsoft.com/office/drawing/2014/main" id="{148D760D-8982-4058-8720-A96575E92DD9}"/>
               </a:ext>
             </a:extLst>
           </p:cNvPr>
@@ -4958,7 +4958,7 @@
           <p:cNvPr id="6" name="">
             <a:extLst xmlns:a="http://schemas.openxmlformats.org/drawingml/2006/main">
               <a:ext uri="{FF2B5EF4-FFF2-40B4-BE49-F238E27FC236}">
-                <a16:creationId xmlns:a16="http://schemas.microsoft.com/office/drawing/2014/main" id="{C0DC4388-AFD7-468C-B5F0-3DB3B0853BE0}"/>
+                <a16:creationId xmlns:a16="http://schemas.microsoft.com/office/drawing/2014/main" id="{873B5709-1690-4067-A01D-57338B13BFBE}"/>
               </a:ext>
             </a:extLst>
           </p:cNvPr>
@@ -5022,7 +5022,7 @@
           <p:cNvPr id="7" name="">
             <a:extLst xmlns:a="http://schemas.openxmlformats.org/drawingml/2006/main">
               <a:ext uri="{FF2B5EF4-FFF2-40B4-BE49-F238E27FC236}">
-                <a16:creationId xmlns:a16="http://schemas.microsoft.com/office/drawing/2014/main" id="{0DFB780D-F93B-4C2F-80A5-7716000768FC}"/>
+                <a16:creationId xmlns:a16="http://schemas.microsoft.com/office/drawing/2014/main" id="{DF62F64B-BC84-4F88-A4BB-7D085563C03E}"/>
               </a:ext>
             </a:extLst>
           </p:cNvPr>
@@ -5055,7 +5055,7 @@
           <p:cNvPr id="8" name="">
             <a:extLst xmlns:a="http://schemas.openxmlformats.org/drawingml/2006/main">
               <a:ext uri="{FF2B5EF4-FFF2-40B4-BE49-F238E27FC236}">
-                <a16:creationId xmlns:a16="http://schemas.microsoft.com/office/drawing/2014/main" id="{970CEF22-FA5A-4511-81A9-9CC19061BA30}"/>
+                <a16:creationId xmlns:a16="http://schemas.microsoft.com/office/drawing/2014/main" id="{E59CACB1-DF70-414A-9A61-803A34CEF96D}"/>
               </a:ext>
             </a:extLst>
           </p:cNvPr>
@@ -5090,7 +5090,7 @@
           <p:cNvPr id="9" name="">
             <a:extLst xmlns:a="http://schemas.openxmlformats.org/drawingml/2006/main">
               <a:ext uri="{FF2B5EF4-FFF2-40B4-BE49-F238E27FC236}">
-                <a16:creationId xmlns:a16="http://schemas.microsoft.com/office/drawing/2014/main" id="{D231ADF7-BDE5-47A0-B095-8546338E3FF6}"/>
+                <a16:creationId xmlns:a16="http://schemas.microsoft.com/office/drawing/2014/main" id="{B95D2E30-FAA4-4789-BF14-7A91C8C5A5E4}"/>
               </a:ext>
             </a:extLst>
           </p:cNvPr>
@@ -5154,7 +5154,7 @@
           <p:cNvPr id="10" name="">
             <a:extLst xmlns:a="http://schemas.openxmlformats.org/drawingml/2006/main">
               <a:ext uri="{FF2B5EF4-FFF2-40B4-BE49-F238E27FC236}">
-                <a16:creationId xmlns:a16="http://schemas.microsoft.com/office/drawing/2014/main" id="{69AA8F56-D9D9-47A7-A275-24F6408E4516}"/>
+                <a16:creationId xmlns:a16="http://schemas.microsoft.com/office/drawing/2014/main" id="{BEF31DDA-B4B9-4696-880E-F570E2F8E0C5}"/>
               </a:ext>
             </a:extLst>
           </p:cNvPr>
@@ -5218,7 +5218,7 @@
           <p:cNvPr id="11" name="">
             <a:extLst xmlns:a="http://schemas.openxmlformats.org/drawingml/2006/main">
               <a:ext uri="{FF2B5EF4-FFF2-40B4-BE49-F238E27FC236}">
-                <a16:creationId xmlns:a16="http://schemas.microsoft.com/office/drawing/2014/main" id="{EA825363-7439-47D0-ABE6-58688A785AFD}"/>
+                <a16:creationId xmlns:a16="http://schemas.microsoft.com/office/drawing/2014/main" id="{7FEF3A1E-1201-4A0C-A339-D3E66127FC58}"/>
               </a:ext>
             </a:extLst>
           </p:cNvPr>
@@ -5251,7 +5251,7 @@
           <p:cNvPr id="12" name="">
             <a:extLst xmlns:a="http://schemas.openxmlformats.org/drawingml/2006/main">
               <a:ext uri="{FF2B5EF4-FFF2-40B4-BE49-F238E27FC236}">
-                <a16:creationId xmlns:a16="http://schemas.microsoft.com/office/drawing/2014/main" id="{3551269A-C713-459D-AE4A-F0DFC55B9FA9}"/>
+                <a16:creationId xmlns:a16="http://schemas.microsoft.com/office/drawing/2014/main" id="{F912A5EF-2B2B-45F7-B3FF-9883A2568131}"/>
               </a:ext>
             </a:extLst>
           </p:cNvPr>
@@ -5286,7 +5286,7 @@
           <p:cNvPr id="13" name="">
             <a:extLst xmlns:a="http://schemas.openxmlformats.org/drawingml/2006/main">
               <a:ext uri="{FF2B5EF4-FFF2-40B4-BE49-F238E27FC236}">
-                <a16:creationId xmlns:a16="http://schemas.microsoft.com/office/drawing/2014/main" id="{8F53D3C6-EFE5-413E-89EB-33830980D4CE}"/>
+                <a16:creationId xmlns:a16="http://schemas.microsoft.com/office/drawing/2014/main" id="{FED13595-BF81-40D1-83AE-FCB47AF2184D}"/>
               </a:ext>
             </a:extLst>
           </p:cNvPr>
@@ -5350,7 +5350,7 @@
           <p:cNvPr id="14" name="">
             <a:extLst xmlns:a="http://schemas.openxmlformats.org/drawingml/2006/main">
               <a:ext uri="{FF2B5EF4-FFF2-40B4-BE49-F238E27FC236}">
-                <a16:creationId xmlns:a16="http://schemas.microsoft.com/office/drawing/2014/main" id="{3191A281-0F26-47E5-9C67-59E3D20226F4}"/>
+                <a16:creationId xmlns:a16="http://schemas.microsoft.com/office/drawing/2014/main" id="{FF1FE059-1F6A-4440-8F87-3F29E39DA380}"/>
               </a:ext>
             </a:extLst>
           </p:cNvPr>
@@ -5414,7 +5414,7 @@
           <p:cNvPr id="15" name="">
             <a:extLst xmlns:a="http://schemas.openxmlformats.org/drawingml/2006/main">
               <a:ext uri="{FF2B5EF4-FFF2-40B4-BE49-F238E27FC236}">
-                <a16:creationId xmlns:a16="http://schemas.microsoft.com/office/drawing/2014/main" id="{52059791-F15F-47EA-B4F1-41BDA1D54917}"/>
+                <a16:creationId xmlns:a16="http://schemas.microsoft.com/office/drawing/2014/main" id="{61F1601D-8606-4E0F-BACF-21BC973B7CDA}"/>
               </a:ext>
             </a:extLst>
           </p:cNvPr>
@@ -5447,7 +5447,7 @@
           <p:cNvPr id="16" name="">
             <a:extLst xmlns:a="http://schemas.openxmlformats.org/drawingml/2006/main">
               <a:ext uri="{FF2B5EF4-FFF2-40B4-BE49-F238E27FC236}">
-                <a16:creationId xmlns:a16="http://schemas.microsoft.com/office/drawing/2014/main" id="{8E4CF47E-BE9E-4C95-B414-32961AFA5E84}"/>
+                <a16:creationId xmlns:a16="http://schemas.microsoft.com/office/drawing/2014/main" id="{4EAD0E9A-A102-4ACB-877C-1D30142BC4F7}"/>
               </a:ext>
             </a:extLst>
           </p:cNvPr>
@@ -5482,7 +5482,7 @@
           <p:cNvPr id="17" name="">
             <a:extLst xmlns:a="http://schemas.openxmlformats.org/drawingml/2006/main">
               <a:ext uri="{FF2B5EF4-FFF2-40B4-BE49-F238E27FC236}">
-                <a16:creationId xmlns:a16="http://schemas.microsoft.com/office/drawing/2014/main" id="{9BF8165C-5878-4441-A70D-23DE438CC2DF}"/>
+                <a16:creationId xmlns:a16="http://schemas.microsoft.com/office/drawing/2014/main" id="{95DEDC6E-0B15-40A5-A432-36344E1607D7}"/>
               </a:ext>
             </a:extLst>
           </p:cNvPr>
@@ -5546,7 +5546,7 @@
           <p:cNvPr id="18" name="">
             <a:extLst xmlns:a="http://schemas.openxmlformats.org/drawingml/2006/main">
               <a:ext uri="{FF2B5EF4-FFF2-40B4-BE49-F238E27FC236}">
-                <a16:creationId xmlns:a16="http://schemas.microsoft.com/office/drawing/2014/main" id="{41B9DFC3-A479-4C03-B290-16EC1B7D5FF5}"/>
+                <a16:creationId xmlns:a16="http://schemas.microsoft.com/office/drawing/2014/main" id="{F93372B8-A9CC-457D-8ABF-6AE783C53350}"/>
               </a:ext>
             </a:extLst>
           </p:cNvPr>
@@ -5610,7 +5610,7 @@
           <p:cNvPr id="19" name="">
             <a:extLst xmlns:a="http://schemas.openxmlformats.org/drawingml/2006/main">
               <a:ext uri="{FF2B5EF4-FFF2-40B4-BE49-F238E27FC236}">
-                <a16:creationId xmlns:a16="http://schemas.microsoft.com/office/drawing/2014/main" id="{363068F5-D10A-498A-B8F8-B6E83F2D3873}"/>
+                <a16:creationId xmlns:a16="http://schemas.microsoft.com/office/drawing/2014/main" id="{B2AD4D51-F351-49E4-8F72-03D289E5222B}"/>
               </a:ext>
             </a:extLst>
           </p:cNvPr>
@@ -5643,7 +5643,7 @@
           <p:cNvPr id="20" name="">
             <a:extLst xmlns:a="http://schemas.openxmlformats.org/drawingml/2006/main">
               <a:ext uri="{FF2B5EF4-FFF2-40B4-BE49-F238E27FC236}">
-                <a16:creationId xmlns:a16="http://schemas.microsoft.com/office/drawing/2014/main" id="{0F9C635C-4F26-4BB2-BFF6-AEA347FEDD1C}"/>
+                <a16:creationId xmlns:a16="http://schemas.microsoft.com/office/drawing/2014/main" id="{33E6A54D-5482-46CF-8D1C-CBB4AB15239E}"/>
               </a:ext>
             </a:extLst>
           </p:cNvPr>
@@ -5678,7 +5678,7 @@
           <p:cNvPr id="21" name="">
             <a:extLst xmlns:a="http://schemas.openxmlformats.org/drawingml/2006/main">
               <a:ext uri="{FF2B5EF4-FFF2-40B4-BE49-F238E27FC236}">
-                <a16:creationId xmlns:a16="http://schemas.microsoft.com/office/drawing/2014/main" id="{BF88D9EB-11AB-4026-BAB8-97D3C9476118}"/>
+                <a16:creationId xmlns:a16="http://schemas.microsoft.com/office/drawing/2014/main" id="{DC4EEAE7-4508-4767-AE38-78642A1F9DF4}"/>
               </a:ext>
             </a:extLst>
           </p:cNvPr>
@@ -5742,7 +5742,7 @@
           <p:cNvPr id="22" name="">
             <a:extLst xmlns:a="http://schemas.openxmlformats.org/drawingml/2006/main">
               <a:ext uri="{FF2B5EF4-FFF2-40B4-BE49-F238E27FC236}">
-                <a16:creationId xmlns:a16="http://schemas.microsoft.com/office/drawing/2014/main" id="{7EF64828-0DEC-4531-8E6E-74FAA60D9152}"/>
+                <a16:creationId xmlns:a16="http://schemas.microsoft.com/office/drawing/2014/main" id="{F24C1EA6-9C28-4CE0-B0A2-84E1A86E6F05}"/>
               </a:ext>
             </a:extLst>
           </p:cNvPr>
@@ -5806,7 +5806,7 @@
           <p:cNvPr id="23" name="">
             <a:extLst xmlns:a="http://schemas.openxmlformats.org/drawingml/2006/main">
               <a:ext uri="{FF2B5EF4-FFF2-40B4-BE49-F238E27FC236}">
-                <a16:creationId xmlns:a16="http://schemas.microsoft.com/office/drawing/2014/main" id="{BA56F45A-4F4A-405A-8DEA-5AE34E439370}"/>
+                <a16:creationId xmlns:a16="http://schemas.microsoft.com/office/drawing/2014/main" id="{D4FDF11E-A2C8-4A07-9697-D293BF7A9B39}"/>
               </a:ext>
             </a:extLst>
           </p:cNvPr>
@@ -5839,7 +5839,7 @@
           <p:cNvPr id="24" name="">
             <a:extLst xmlns:a="http://schemas.openxmlformats.org/drawingml/2006/main">
               <a:ext uri="{FF2B5EF4-FFF2-40B4-BE49-F238E27FC236}">
-                <a16:creationId xmlns:a16="http://schemas.microsoft.com/office/drawing/2014/main" id="{D683C337-5D4D-4BAD-BB8E-AA0CCECD719F}"/>
+                <a16:creationId xmlns:a16="http://schemas.microsoft.com/office/drawing/2014/main" id="{CD660815-8FA3-44AB-B285-A8CC215C10AF}"/>
               </a:ext>
             </a:extLst>
           </p:cNvPr>
@@ -5874,7 +5874,7 @@
           <p:cNvPr id="25" name="">
             <a:extLst xmlns:a="http://schemas.openxmlformats.org/drawingml/2006/main">
               <a:ext uri="{FF2B5EF4-FFF2-40B4-BE49-F238E27FC236}">
-                <a16:creationId xmlns:a16="http://schemas.microsoft.com/office/drawing/2014/main" id="{B47A0989-5734-4EA0-A498-993D58E050EC}"/>
+                <a16:creationId xmlns:a16="http://schemas.microsoft.com/office/drawing/2014/main" id="{40CD3B7B-57F2-4D27-B28B-4335FCC884B6}"/>
               </a:ext>
             </a:extLst>
           </p:cNvPr>
@@ -5938,7 +5938,7 @@
           <p:cNvPr id="26" name="">
             <a:extLst xmlns:a="http://schemas.openxmlformats.org/drawingml/2006/main">
               <a:ext uri="{FF2B5EF4-FFF2-40B4-BE49-F238E27FC236}">
-                <a16:creationId xmlns:a16="http://schemas.microsoft.com/office/drawing/2014/main" id="{79A6C76C-06F2-4420-9D1E-FA98ABE2C1CC}"/>
+                <a16:creationId xmlns:a16="http://schemas.microsoft.com/office/drawing/2014/main" id="{A559D9DF-69F7-4978-B817-3180DC97F3E2}"/>
               </a:ext>
             </a:extLst>
           </p:cNvPr>
@@ -6000,7 +6000,7 @@
     </p:spTree>
     <p:extLst>
       <p:ext uri="{BB962C8B-B14F-4D97-AF65-F5344CB8AC3E}">
-        <p14:creationId xmlns:p14="http://schemas.microsoft.com/office/powerpoint/2010/main" val="1640208576"/>
+        <p14:creationId xmlns:p14="http://schemas.microsoft.com/office/powerpoint/2010/main" val="533706167"/>
       </p:ext>
     </p:extLst>
   </p:cSld>
@@ -6024,7 +6024,7 @@
           <p:cNvPr id="1" name="">
             <a:extLst xmlns:a="http://schemas.openxmlformats.org/drawingml/2006/main">
               <a:ext uri="{FF2B5EF4-FFF2-40B4-BE49-F238E27FC236}">
-                <a16:creationId xmlns:a16="http://schemas.microsoft.com/office/drawing/2014/main" id="{73C7F691-047C-4B74-98FD-1D88AC2FB378}"/>
+                <a16:creationId xmlns:a16="http://schemas.microsoft.com/office/drawing/2014/main" id="{49D13C26-21E5-471C-B00D-8D6F687A9724}"/>
               </a:ext>
             </a:extLst>
           </p:cNvPr>
@@ -6059,7 +6059,7 @@
           <p:cNvPr id="2" name="">
             <a:extLst xmlns:a="http://schemas.openxmlformats.org/drawingml/2006/main">
               <a:ext uri="{FF2B5EF4-FFF2-40B4-BE49-F238E27FC236}">
-                <a16:creationId xmlns:a16="http://schemas.microsoft.com/office/drawing/2014/main" id="{2C63F995-EE5C-414A-8AE4-98B48CE0707B}"/>
+                <a16:creationId xmlns:a16="http://schemas.microsoft.com/office/drawing/2014/main" id="{0F3E0AEC-AF91-44C5-8FDB-DEFD26238A6B}"/>
               </a:ext>
             </a:extLst>
           </p:cNvPr>
@@ -6094,7 +6094,7 @@
           <p:cNvPr id="3" name="">
             <a:extLst xmlns:a="http://schemas.openxmlformats.org/drawingml/2006/main">
               <a:ext uri="{FF2B5EF4-FFF2-40B4-BE49-F238E27FC236}">
-                <a16:creationId xmlns:a16="http://schemas.microsoft.com/office/drawing/2014/main" id="{30E85294-B254-4F5A-A97D-E0581CC13B5F}"/>
+                <a16:creationId xmlns:a16="http://schemas.microsoft.com/office/drawing/2014/main" id="{BBB61B77-332C-473C-99B0-42194720C171}"/>
               </a:ext>
             </a:extLst>
           </p:cNvPr>
@@ -6158,7 +6158,7 @@
           <p:cNvPr id="4" name="">
             <a:extLst xmlns:a="http://schemas.openxmlformats.org/drawingml/2006/main">
               <a:ext uri="{FF2B5EF4-FFF2-40B4-BE49-F238E27FC236}">
-                <a16:creationId xmlns:a16="http://schemas.microsoft.com/office/drawing/2014/main" id="{610CD7B0-4900-4893-A6B3-AA6D356AAC98}"/>
+                <a16:creationId xmlns:a16="http://schemas.microsoft.com/office/drawing/2014/main" id="{7E913ACF-0455-42B2-B019-CC2AA352226B}"/>
               </a:ext>
             </a:extLst>
           </p:cNvPr>
@@ -6222,7 +6222,7 @@
           <p:cNvPr id="5" name="">
             <a:extLst xmlns:a="http://schemas.openxmlformats.org/drawingml/2006/main">
               <a:ext uri="{FF2B5EF4-FFF2-40B4-BE49-F238E27FC236}">
-                <a16:creationId xmlns:a16="http://schemas.microsoft.com/office/drawing/2014/main" id="{2B55A652-7C0B-4D05-8037-2110E213A420}"/>
+                <a16:creationId xmlns:a16="http://schemas.microsoft.com/office/drawing/2014/main" id="{C9690857-F4E9-435A-A11F-3416EE2599BF}"/>
               </a:ext>
             </a:extLst>
           </p:cNvPr>
@@ -6286,7 +6286,7 @@
           <p:cNvPr id="6" name="">
             <a:extLst xmlns:a="http://schemas.openxmlformats.org/drawingml/2006/main">
               <a:ext uri="{FF2B5EF4-FFF2-40B4-BE49-F238E27FC236}">
-                <a16:creationId xmlns:a16="http://schemas.microsoft.com/office/drawing/2014/main" id="{E4AF3E96-78AF-4E28-A611-82C9673CC1AC}"/>
+                <a16:creationId xmlns:a16="http://schemas.microsoft.com/office/drawing/2014/main" id="{6ABA30F0-88FD-48B4-A4E7-9B981AE10DC5}"/>
               </a:ext>
             </a:extLst>
           </p:cNvPr>
@@ -6350,7 +6350,7 @@
           <p:cNvPr id="7" name="">
             <a:extLst xmlns:a="http://schemas.openxmlformats.org/drawingml/2006/main">
               <a:ext uri="{FF2B5EF4-FFF2-40B4-BE49-F238E27FC236}">
-                <a16:creationId xmlns:a16="http://schemas.microsoft.com/office/drawing/2014/main" id="{C765234F-F251-4389-BD9F-BABD9724C66F}"/>
+                <a16:creationId xmlns:a16="http://schemas.microsoft.com/office/drawing/2014/main" id="{EE5C32AD-0676-42FA-83DB-C2C356D85BF2}"/>
               </a:ext>
             </a:extLst>
           </p:cNvPr>
@@ -6383,7 +6383,7 @@
           <p:cNvPr id="8" name="">
             <a:extLst xmlns:a="http://schemas.openxmlformats.org/drawingml/2006/main">
               <a:ext uri="{FF2B5EF4-FFF2-40B4-BE49-F238E27FC236}">
-                <a16:creationId xmlns:a16="http://schemas.microsoft.com/office/drawing/2014/main" id="{BDC04C82-2D83-455F-AD3E-FEEC4F73C198}"/>
+                <a16:creationId xmlns:a16="http://schemas.microsoft.com/office/drawing/2014/main" id="{CED53E60-4C39-4ECA-B48E-6F767BD6D0CB}"/>
               </a:ext>
             </a:extLst>
           </p:cNvPr>
@@ -6447,7 +6447,7 @@
           <p:cNvPr id="9" name="">
             <a:extLst xmlns:a="http://schemas.openxmlformats.org/drawingml/2006/main">
               <a:ext uri="{FF2B5EF4-FFF2-40B4-BE49-F238E27FC236}">
-                <a16:creationId xmlns:a16="http://schemas.microsoft.com/office/drawing/2014/main" id="{DB35586C-240A-4A80-8165-434A299F1DF4}"/>
+                <a16:creationId xmlns:a16="http://schemas.microsoft.com/office/drawing/2014/main" id="{50B41A84-1FF5-4DA3-A56A-C3FEABF3B1D6}"/>
               </a:ext>
             </a:extLst>
           </p:cNvPr>
@@ -6482,7 +6482,7 @@
           <p:cNvPr id="10" name="">
             <a:extLst xmlns:a="http://schemas.openxmlformats.org/drawingml/2006/main">
               <a:ext uri="{FF2B5EF4-FFF2-40B4-BE49-F238E27FC236}">
-                <a16:creationId xmlns:a16="http://schemas.microsoft.com/office/drawing/2014/main" id="{2C38EEEC-4FBA-4C54-AA31-8992919E6DC1}"/>
+                <a16:creationId xmlns:a16="http://schemas.microsoft.com/office/drawing/2014/main" id="{9BDC5E3B-9D11-42E0-A4B0-3DE795008283}"/>
               </a:ext>
             </a:extLst>
           </p:cNvPr>
@@ -6546,7 +6546,7 @@
           <p:cNvPr id="11" name="">
             <a:extLst xmlns:a="http://schemas.openxmlformats.org/drawingml/2006/main">
               <a:ext uri="{FF2B5EF4-FFF2-40B4-BE49-F238E27FC236}">
-                <a16:creationId xmlns:a16="http://schemas.microsoft.com/office/drawing/2014/main" id="{CABD9517-AAD4-45CA-9F92-D5EB76856DD8}"/>
+                <a16:creationId xmlns:a16="http://schemas.microsoft.com/office/drawing/2014/main" id="{97E10343-2001-4D88-82F2-8DFB88704489}"/>
               </a:ext>
             </a:extLst>
           </p:cNvPr>
@@ -6581,7 +6581,7 @@
           <p:cNvPr id="12" name="">
             <a:extLst xmlns:a="http://schemas.openxmlformats.org/drawingml/2006/main">
               <a:ext uri="{FF2B5EF4-FFF2-40B4-BE49-F238E27FC236}">
-                <a16:creationId xmlns:a16="http://schemas.microsoft.com/office/drawing/2014/main" id="{A41C9A01-0851-4241-8132-ED6C43349FB9}"/>
+                <a16:creationId xmlns:a16="http://schemas.microsoft.com/office/drawing/2014/main" id="{00A6F40A-E017-4DDD-9300-585C9ACA4406}"/>
               </a:ext>
             </a:extLst>
           </p:cNvPr>
@@ -6645,7 +6645,7 @@
           <p:cNvPr id="13" name="">
             <a:extLst xmlns:a="http://schemas.openxmlformats.org/drawingml/2006/main">
               <a:ext uri="{FF2B5EF4-FFF2-40B4-BE49-F238E27FC236}">
-                <a16:creationId xmlns:a16="http://schemas.microsoft.com/office/drawing/2014/main" id="{68D2522E-36BB-426A-87F5-A3EB9426D1FB}"/>
+                <a16:creationId xmlns:a16="http://schemas.microsoft.com/office/drawing/2014/main" id="{15F86843-80E0-40F3-8581-3539BCC770D9}"/>
               </a:ext>
             </a:extLst>
           </p:cNvPr>
@@ -6680,7 +6680,7 @@
           <p:cNvPr id="14" name="">
             <a:extLst xmlns:a="http://schemas.openxmlformats.org/drawingml/2006/main">
               <a:ext uri="{FF2B5EF4-FFF2-40B4-BE49-F238E27FC236}">
-                <a16:creationId xmlns:a16="http://schemas.microsoft.com/office/drawing/2014/main" id="{EBFA8D94-65E7-4239-BE84-869CCEB7C330}"/>
+                <a16:creationId xmlns:a16="http://schemas.microsoft.com/office/drawing/2014/main" id="{885A03FB-30C8-4DB5-A2A8-4EC0307AD3CE}"/>
               </a:ext>
             </a:extLst>
           </p:cNvPr>
@@ -6744,7 +6744,7 @@
           <p:cNvPr id="15" name="">
             <a:extLst xmlns:a="http://schemas.openxmlformats.org/drawingml/2006/main">
               <a:ext uri="{FF2B5EF4-FFF2-40B4-BE49-F238E27FC236}">
-                <a16:creationId xmlns:a16="http://schemas.microsoft.com/office/drawing/2014/main" id="{81C4A34C-49E5-419F-AA7D-7704C8718557}"/>
+                <a16:creationId xmlns:a16="http://schemas.microsoft.com/office/drawing/2014/main" id="{BD7B44F3-F934-40C7-B308-A1386715BA23}"/>
               </a:ext>
             </a:extLst>
           </p:cNvPr>
@@ -6779,7 +6779,7 @@
           <p:cNvPr id="16" name="">
             <a:extLst xmlns:a="http://schemas.openxmlformats.org/drawingml/2006/main">
               <a:ext uri="{FF2B5EF4-FFF2-40B4-BE49-F238E27FC236}">
-                <a16:creationId xmlns:a16="http://schemas.microsoft.com/office/drawing/2014/main" id="{A2999D4E-674D-4D44-B161-C59A18A3C97A}"/>
+                <a16:creationId xmlns:a16="http://schemas.microsoft.com/office/drawing/2014/main" id="{2CAF9F0E-3CB7-4B8E-97DB-C0EF1CD9EBBB}"/>
               </a:ext>
             </a:extLst>
           </p:cNvPr>
@@ -6833,7 +6833,7 @@
                 <a:ea typeface="Aptos"/>
                 <a:cs typeface="Aptos"/>
               </a:rPr>
-              <a:t>Screenshots für Folien erzeugt</a:t>
+              <a:t>Screenshots und Walkthrough-Video erzeugt</a:t>
             </a:r>
           </a:p>
         </p:txBody>
@@ -6843,7 +6843,7 @@
           <p:cNvPr id="17" name="">
             <a:extLst xmlns:a="http://schemas.openxmlformats.org/drawingml/2006/main">
               <a:ext uri="{FF2B5EF4-FFF2-40B4-BE49-F238E27FC236}">
-                <a16:creationId xmlns:a16="http://schemas.microsoft.com/office/drawing/2014/main" id="{5971E046-A2F5-42EB-8096-C266267B5E75}"/>
+                <a16:creationId xmlns:a16="http://schemas.microsoft.com/office/drawing/2014/main" id="{61413718-27B1-4409-BA1F-2FE7BAA7EADE}"/>
               </a:ext>
             </a:extLst>
           </p:cNvPr>
@@ -6876,7 +6876,7 @@
           <p:cNvPr id="18" name="">
             <a:extLst xmlns:a="http://schemas.openxmlformats.org/drawingml/2006/main">
               <a:ext uri="{FF2B5EF4-FFF2-40B4-BE49-F238E27FC236}">
-                <a16:creationId xmlns:a16="http://schemas.microsoft.com/office/drawing/2014/main" id="{09967513-A22C-4B52-B29F-EE134D3ECFE2}"/>
+                <a16:creationId xmlns:a16="http://schemas.microsoft.com/office/drawing/2014/main" id="{D45C382A-6059-4DB5-8131-933649106665}"/>
               </a:ext>
             </a:extLst>
           </p:cNvPr>
@@ -6940,7 +6940,7 @@
           <p:cNvPr id="19" name="">
             <a:extLst xmlns:a="http://schemas.openxmlformats.org/drawingml/2006/main">
               <a:ext uri="{FF2B5EF4-FFF2-40B4-BE49-F238E27FC236}">
-                <a16:creationId xmlns:a16="http://schemas.microsoft.com/office/drawing/2014/main" id="{D4F4562B-F891-430A-BEE5-DFC9BF070DAC}"/>
+                <a16:creationId xmlns:a16="http://schemas.microsoft.com/office/drawing/2014/main" id="{62A13F41-B4AE-4E6A-84ED-EA45ADCCB25E}"/>
               </a:ext>
             </a:extLst>
           </p:cNvPr>
@@ -6975,7 +6975,7 @@
           <p:cNvPr id="20" name="">
             <a:extLst xmlns:a="http://schemas.openxmlformats.org/drawingml/2006/main">
               <a:ext uri="{FF2B5EF4-FFF2-40B4-BE49-F238E27FC236}">
-                <a16:creationId xmlns:a16="http://schemas.microsoft.com/office/drawing/2014/main" id="{44059B6E-FA18-4CE9-839E-6C6293FD5CDA}"/>
+                <a16:creationId xmlns:a16="http://schemas.microsoft.com/office/drawing/2014/main" id="{FEAC4319-DD73-4684-A9E7-D8729C255E3C}"/>
               </a:ext>
             </a:extLst>
           </p:cNvPr>
@@ -7039,7 +7039,7 @@
           <p:cNvPr id="21" name="">
             <a:extLst xmlns:a="http://schemas.openxmlformats.org/drawingml/2006/main">
               <a:ext uri="{FF2B5EF4-FFF2-40B4-BE49-F238E27FC236}">
-                <a16:creationId xmlns:a16="http://schemas.microsoft.com/office/drawing/2014/main" id="{AD0008FD-FB30-4CF5-A5B9-5F812145239B}"/>
+                <a16:creationId xmlns:a16="http://schemas.microsoft.com/office/drawing/2014/main" id="{E0DD61FC-321C-4C36-819C-A0D9FFBEAC08}"/>
               </a:ext>
             </a:extLst>
           </p:cNvPr>
@@ -7074,7 +7074,7 @@
           <p:cNvPr id="22" name="">
             <a:extLst xmlns:a="http://schemas.openxmlformats.org/drawingml/2006/main">
               <a:ext uri="{FF2B5EF4-FFF2-40B4-BE49-F238E27FC236}">
-                <a16:creationId xmlns:a16="http://schemas.microsoft.com/office/drawing/2014/main" id="{4A60474E-9BAE-49CD-87FE-43D5DF38DDC4}"/>
+                <a16:creationId xmlns:a16="http://schemas.microsoft.com/office/drawing/2014/main" id="{23C3D3DF-AA46-4531-BC09-0DB9EC6AA692}"/>
               </a:ext>
             </a:extLst>
           </p:cNvPr>
@@ -7128,7 +7128,7 @@
                 <a:ea typeface="Aptos"/>
                 <a:cs typeface="Aptos"/>
               </a:rPr>
-              <a:t>durchgehendes Prozessvideo aufnehmen</a:t>
+              <a:t>Live-Prozessvideo aufnehmen</a:t>
             </a:r>
           </a:p>
         </p:txBody>
@@ -7138,7 +7138,7 @@
           <p:cNvPr id="23" name="">
             <a:extLst xmlns:a="http://schemas.openxmlformats.org/drawingml/2006/main">
               <a:ext uri="{FF2B5EF4-FFF2-40B4-BE49-F238E27FC236}">
-                <a16:creationId xmlns:a16="http://schemas.microsoft.com/office/drawing/2014/main" id="{1AE9EFCE-4977-4F61-8935-F53605B8400B}"/>
+                <a16:creationId xmlns:a16="http://schemas.microsoft.com/office/drawing/2014/main" id="{42920DD7-4C92-4CCC-BC58-8E2817B5CC38}"/>
               </a:ext>
             </a:extLst>
           </p:cNvPr>
@@ -7173,7 +7173,7 @@
           <p:cNvPr id="24" name="">
             <a:extLst xmlns:a="http://schemas.openxmlformats.org/drawingml/2006/main">
               <a:ext uri="{FF2B5EF4-FFF2-40B4-BE49-F238E27FC236}">
-                <a16:creationId xmlns:a16="http://schemas.microsoft.com/office/drawing/2014/main" id="{CA329F7C-74C9-4D9B-99BC-942A89F894BE}"/>
+                <a16:creationId xmlns:a16="http://schemas.microsoft.com/office/drawing/2014/main" id="{1538BA1F-E0E0-4F42-9D27-EC26928FBF9F}"/>
               </a:ext>
             </a:extLst>
           </p:cNvPr>
@@ -7237,7 +7237,7 @@
           <p:cNvPr id="25" name="">
             <a:extLst xmlns:a="http://schemas.openxmlformats.org/drawingml/2006/main">
               <a:ext uri="{FF2B5EF4-FFF2-40B4-BE49-F238E27FC236}">
-                <a16:creationId xmlns:a16="http://schemas.microsoft.com/office/drawing/2014/main" id="{43E1AA38-C401-48BF-880A-1AC7102CED98}"/>
+                <a16:creationId xmlns:a16="http://schemas.microsoft.com/office/drawing/2014/main" id="{E2BF4656-F896-4F76-911A-C0386DFDDD50}"/>
               </a:ext>
             </a:extLst>
           </p:cNvPr>
@@ -7272,7 +7272,7 @@
           <p:cNvPr id="26" name="">
             <a:extLst xmlns:a="http://schemas.openxmlformats.org/drawingml/2006/main">
               <a:ext uri="{FF2B5EF4-FFF2-40B4-BE49-F238E27FC236}">
-                <a16:creationId xmlns:a16="http://schemas.microsoft.com/office/drawing/2014/main" id="{2E63618A-EDE5-4BB8-80D1-5BE73B79DE5D}"/>
+                <a16:creationId xmlns:a16="http://schemas.microsoft.com/office/drawing/2014/main" id="{48B52928-EFD6-4F0D-8047-E87DF974DC6C}"/>
               </a:ext>
             </a:extLst>
           </p:cNvPr>
@@ -7336,7 +7336,7 @@
           <p:cNvPr id="27" name="">
             <a:extLst xmlns:a="http://schemas.openxmlformats.org/drawingml/2006/main">
               <a:ext uri="{FF2B5EF4-FFF2-40B4-BE49-F238E27FC236}">
-                <a16:creationId xmlns:a16="http://schemas.microsoft.com/office/drawing/2014/main" id="{C4F68108-D44A-48E3-8794-4E7DBACD5767}"/>
+                <a16:creationId xmlns:a16="http://schemas.microsoft.com/office/drawing/2014/main" id="{28CCBB39-E7E7-42B7-8DDF-BB0BD5EC05B6}"/>
               </a:ext>
             </a:extLst>
           </p:cNvPr>
@@ -7398,7 +7398,7 @@
     </p:spTree>
     <p:extLst>
       <p:ext uri="{BB962C8B-B14F-4D97-AF65-F5344CB8AC3E}">
-        <p14:creationId xmlns:p14="http://schemas.microsoft.com/office/powerpoint/2010/main" val="1134193173"/>
+        <p14:creationId xmlns:p14="http://schemas.microsoft.com/office/powerpoint/2010/main" val="905672396"/>
       </p:ext>
     </p:extLst>
   </p:cSld>
@@ -7422,7 +7422,7 @@
           <p:cNvPr id="1" name="">
             <a:extLst xmlns:a="http://schemas.openxmlformats.org/drawingml/2006/main">
               <a:ext uri="{FF2B5EF4-FFF2-40B4-BE49-F238E27FC236}">
-                <a16:creationId xmlns:a16="http://schemas.microsoft.com/office/drawing/2014/main" id="{D9B0DE3D-1397-4B5B-B903-D5A67A6C0F79}"/>
+                <a16:creationId xmlns:a16="http://schemas.microsoft.com/office/drawing/2014/main" id="{DA5A0C92-6879-43C4-B69C-8A502E4B1FB5}"/>
               </a:ext>
             </a:extLst>
           </p:cNvPr>
@@ -7457,7 +7457,7 @@
           <p:cNvPr id="2" name="">
             <a:extLst xmlns:a="http://schemas.openxmlformats.org/drawingml/2006/main">
               <a:ext uri="{FF2B5EF4-FFF2-40B4-BE49-F238E27FC236}">
-                <a16:creationId xmlns:a16="http://schemas.microsoft.com/office/drawing/2014/main" id="{3F9DDD52-E9C2-493D-AE57-F17AA853B49B}"/>
+                <a16:creationId xmlns:a16="http://schemas.microsoft.com/office/drawing/2014/main" id="{4CF7D0CD-ACCE-4F8B-AD7C-C3BC47BBDCBA}"/>
               </a:ext>
             </a:extLst>
           </p:cNvPr>
@@ -7492,7 +7492,7 @@
           <p:cNvPr id="3" name="">
             <a:extLst xmlns:a="http://schemas.openxmlformats.org/drawingml/2006/main">
               <a:ext uri="{FF2B5EF4-FFF2-40B4-BE49-F238E27FC236}">
-                <a16:creationId xmlns:a16="http://schemas.microsoft.com/office/drawing/2014/main" id="{4E44E221-9464-454E-9200-ED14C2027208}"/>
+                <a16:creationId xmlns:a16="http://schemas.microsoft.com/office/drawing/2014/main" id="{D4A0D30F-9387-4416-BC8E-576C60FB8476}"/>
               </a:ext>
             </a:extLst>
           </p:cNvPr>
@@ -7556,7 +7556,7 @@
           <p:cNvPr id="4" name="">
             <a:extLst xmlns:a="http://schemas.openxmlformats.org/drawingml/2006/main">
               <a:ext uri="{FF2B5EF4-FFF2-40B4-BE49-F238E27FC236}">
-                <a16:creationId xmlns:a16="http://schemas.microsoft.com/office/drawing/2014/main" id="{27C0CAC9-0542-4B54-AD2F-925A82347162}"/>
+                <a16:creationId xmlns:a16="http://schemas.microsoft.com/office/drawing/2014/main" id="{620E52F3-2751-4086-BA26-58B9F4BDA920}"/>
               </a:ext>
             </a:extLst>
           </p:cNvPr>
@@ -7620,7 +7620,7 @@
           <p:cNvPr id="5" name="">
             <a:extLst xmlns:a="http://schemas.openxmlformats.org/drawingml/2006/main">
               <a:ext uri="{FF2B5EF4-FFF2-40B4-BE49-F238E27FC236}">
-                <a16:creationId xmlns:a16="http://schemas.microsoft.com/office/drawing/2014/main" id="{DAB5F045-B4EB-4B91-937D-6B1CDCBC48C1}"/>
+                <a16:creationId xmlns:a16="http://schemas.microsoft.com/office/drawing/2014/main" id="{719748B2-82E6-4D19-A8A7-D83B657F47F5}"/>
               </a:ext>
             </a:extLst>
           </p:cNvPr>
@@ -7684,7 +7684,7 @@
           <p:cNvPr id="6" name="">
             <a:extLst xmlns:a="http://schemas.openxmlformats.org/drawingml/2006/main">
               <a:ext uri="{FF2B5EF4-FFF2-40B4-BE49-F238E27FC236}">
-                <a16:creationId xmlns:a16="http://schemas.microsoft.com/office/drawing/2014/main" id="{607D1B58-2DE8-4A57-AE97-3E648D1A05E8}"/>
+                <a16:creationId xmlns:a16="http://schemas.microsoft.com/office/drawing/2014/main" id="{5C01384E-B0AE-48EC-8BE3-90EF774EFD5B}"/>
               </a:ext>
             </a:extLst>
           </p:cNvPr>
@@ -7748,7 +7748,7 @@
           <p:cNvPr id="7" name="">
             <a:extLst xmlns:a="http://schemas.openxmlformats.org/drawingml/2006/main">
               <a:ext uri="{FF2B5EF4-FFF2-40B4-BE49-F238E27FC236}">
-                <a16:creationId xmlns:a16="http://schemas.microsoft.com/office/drawing/2014/main" id="{200B223F-5493-441B-9CEE-6913669C8EC3}"/>
+                <a16:creationId xmlns:a16="http://schemas.microsoft.com/office/drawing/2014/main" id="{D8A3A92D-4055-4194-8723-A526E04E6A42}"/>
               </a:ext>
             </a:extLst>
           </p:cNvPr>
@@ -7781,7 +7781,7 @@
           <p:cNvPr id="8" name="">
             <a:extLst xmlns:a="http://schemas.openxmlformats.org/drawingml/2006/main">
               <a:ext uri="{FF2B5EF4-FFF2-40B4-BE49-F238E27FC236}">
-                <a16:creationId xmlns:a16="http://schemas.microsoft.com/office/drawing/2014/main" id="{70A1FA22-63E6-410C-8ACE-B4A6BE211FAF}"/>
+                <a16:creationId xmlns:a16="http://schemas.microsoft.com/office/drawing/2014/main" id="{0550B4D4-1651-4372-B671-8ED8D552E4AE}"/>
               </a:ext>
             </a:extLst>
           </p:cNvPr>
@@ -7816,7 +7816,7 @@
           <p:cNvPr id="9" name="">
             <a:extLst xmlns:a="http://schemas.openxmlformats.org/drawingml/2006/main">
               <a:ext uri="{FF2B5EF4-FFF2-40B4-BE49-F238E27FC236}">
-                <a16:creationId xmlns:a16="http://schemas.microsoft.com/office/drawing/2014/main" id="{6EC509C8-E00C-45A5-92EA-2EC7C1D87152}"/>
+                <a16:creationId xmlns:a16="http://schemas.microsoft.com/office/drawing/2014/main" id="{1D1E3F7E-F1BF-42BC-B631-9FC50F308D19}"/>
               </a:ext>
             </a:extLst>
           </p:cNvPr>
@@ -7880,7 +7880,7 @@
           <p:cNvPr id="10" name="">
             <a:extLst xmlns:a="http://schemas.openxmlformats.org/drawingml/2006/main">
               <a:ext uri="{FF2B5EF4-FFF2-40B4-BE49-F238E27FC236}">
-                <a16:creationId xmlns:a16="http://schemas.microsoft.com/office/drawing/2014/main" id="{D1EF764A-9FFB-4356-A64F-8FAC0880820A}"/>
+                <a16:creationId xmlns:a16="http://schemas.microsoft.com/office/drawing/2014/main" id="{BE0CBB57-7AFF-43E8-8D0A-D8C19A8EF104}"/>
               </a:ext>
             </a:extLst>
           </p:cNvPr>
@@ -7944,7 +7944,7 @@
           <p:cNvPr id="11" name="">
             <a:extLst xmlns:a="http://schemas.openxmlformats.org/drawingml/2006/main">
               <a:ext uri="{FF2B5EF4-FFF2-40B4-BE49-F238E27FC236}">
-                <a16:creationId xmlns:a16="http://schemas.microsoft.com/office/drawing/2014/main" id="{944DBC13-96B9-4F5E-B412-F80073EE89C2}"/>
+                <a16:creationId xmlns:a16="http://schemas.microsoft.com/office/drawing/2014/main" id="{7DCDFD3A-BA4B-48CF-A949-5E6D73B970B9}"/>
               </a:ext>
             </a:extLst>
           </p:cNvPr>
@@ -7977,7 +7977,7 @@
           <p:cNvPr id="12" name="">
             <a:extLst xmlns:a="http://schemas.openxmlformats.org/drawingml/2006/main">
               <a:ext uri="{FF2B5EF4-FFF2-40B4-BE49-F238E27FC236}">
-                <a16:creationId xmlns:a16="http://schemas.microsoft.com/office/drawing/2014/main" id="{BBAE8E80-A201-471C-A95F-E245120D7BBD}"/>
+                <a16:creationId xmlns:a16="http://schemas.microsoft.com/office/drawing/2014/main" id="{41E736A5-E41F-4C4E-A099-0413BE5062A7}"/>
               </a:ext>
             </a:extLst>
           </p:cNvPr>
@@ -8012,7 +8012,7 @@
           <p:cNvPr id="13" name="">
             <a:extLst xmlns:a="http://schemas.openxmlformats.org/drawingml/2006/main">
               <a:ext uri="{FF2B5EF4-FFF2-40B4-BE49-F238E27FC236}">
-                <a16:creationId xmlns:a16="http://schemas.microsoft.com/office/drawing/2014/main" id="{4ADC669F-B347-4E8F-8126-341B9445B9F6}"/>
+                <a16:creationId xmlns:a16="http://schemas.microsoft.com/office/drawing/2014/main" id="{DDF82426-A718-4209-8AD6-DD9AB57B4C17}"/>
               </a:ext>
             </a:extLst>
           </p:cNvPr>
@@ -8076,7 +8076,7 @@
           <p:cNvPr id="14" name="">
             <a:extLst xmlns:a="http://schemas.openxmlformats.org/drawingml/2006/main">
               <a:ext uri="{FF2B5EF4-FFF2-40B4-BE49-F238E27FC236}">
-                <a16:creationId xmlns:a16="http://schemas.microsoft.com/office/drawing/2014/main" id="{B7988CD2-ADC7-41D8-B157-34CA8E7A8A59}"/>
+                <a16:creationId xmlns:a16="http://schemas.microsoft.com/office/drawing/2014/main" id="{1429F1F6-214D-4C8E-A04F-5A0BAC6FA2B8}"/>
               </a:ext>
             </a:extLst>
           </p:cNvPr>
@@ -8140,7 +8140,7 @@
           <p:cNvPr id="15" name="">
             <a:extLst xmlns:a="http://schemas.openxmlformats.org/drawingml/2006/main">
               <a:ext uri="{FF2B5EF4-FFF2-40B4-BE49-F238E27FC236}">
-                <a16:creationId xmlns:a16="http://schemas.microsoft.com/office/drawing/2014/main" id="{339B1B8C-952F-4CD3-944F-D9B69389579B}"/>
+                <a16:creationId xmlns:a16="http://schemas.microsoft.com/office/drawing/2014/main" id="{4BED9D46-FA53-42B8-8C45-213E9E98F002}"/>
               </a:ext>
             </a:extLst>
           </p:cNvPr>
@@ -8173,7 +8173,7 @@
           <p:cNvPr id="16" name="">
             <a:extLst xmlns:a="http://schemas.openxmlformats.org/drawingml/2006/main">
               <a:ext uri="{FF2B5EF4-FFF2-40B4-BE49-F238E27FC236}">
-                <a16:creationId xmlns:a16="http://schemas.microsoft.com/office/drawing/2014/main" id="{8285E7C2-7FFC-48C4-9D95-28ED35FC062D}"/>
+                <a16:creationId xmlns:a16="http://schemas.microsoft.com/office/drawing/2014/main" id="{38A6585D-BB1C-465E-98FE-8D7ECFF48090}"/>
               </a:ext>
             </a:extLst>
           </p:cNvPr>
@@ -8208,7 +8208,7 @@
           <p:cNvPr id="17" name="">
             <a:extLst xmlns:a="http://schemas.openxmlformats.org/drawingml/2006/main">
               <a:ext uri="{FF2B5EF4-FFF2-40B4-BE49-F238E27FC236}">
-                <a16:creationId xmlns:a16="http://schemas.microsoft.com/office/drawing/2014/main" id="{EA60200B-5922-43C3-9A08-24C4F5BE959B}"/>
+                <a16:creationId xmlns:a16="http://schemas.microsoft.com/office/drawing/2014/main" id="{F9A1D63F-8F86-4149-9995-444821A533F7}"/>
               </a:ext>
             </a:extLst>
           </p:cNvPr>
@@ -8272,7 +8272,7 @@
           <p:cNvPr id="18" name="">
             <a:extLst xmlns:a="http://schemas.openxmlformats.org/drawingml/2006/main">
               <a:ext uri="{FF2B5EF4-FFF2-40B4-BE49-F238E27FC236}">
-                <a16:creationId xmlns:a16="http://schemas.microsoft.com/office/drawing/2014/main" id="{B1E2C081-C78F-4294-874A-C9A96C953BAE}"/>
+                <a16:creationId xmlns:a16="http://schemas.microsoft.com/office/drawing/2014/main" id="{F0F77CE9-1226-44B7-A9C1-75670A1CD6AC}"/>
               </a:ext>
             </a:extLst>
           </p:cNvPr>
@@ -8336,7 +8336,7 @@
           <p:cNvPr id="19" name="">
             <a:extLst xmlns:a="http://schemas.openxmlformats.org/drawingml/2006/main">
               <a:ext uri="{FF2B5EF4-FFF2-40B4-BE49-F238E27FC236}">
-                <a16:creationId xmlns:a16="http://schemas.microsoft.com/office/drawing/2014/main" id="{18C4BE14-DC85-4728-A476-67EA971EA17B}"/>
+                <a16:creationId xmlns:a16="http://schemas.microsoft.com/office/drawing/2014/main" id="{9D26C6AD-31EA-4635-9394-BCBFD63295E4}"/>
               </a:ext>
             </a:extLst>
           </p:cNvPr>
@@ -8369,7 +8369,7 @@
           <p:cNvPr id="20" name="">
             <a:extLst xmlns:a="http://schemas.openxmlformats.org/drawingml/2006/main">
               <a:ext uri="{FF2B5EF4-FFF2-40B4-BE49-F238E27FC236}">
-                <a16:creationId xmlns:a16="http://schemas.microsoft.com/office/drawing/2014/main" id="{4F6D12DC-3CFD-41A0-B6DB-C16C85915A82}"/>
+                <a16:creationId xmlns:a16="http://schemas.microsoft.com/office/drawing/2014/main" id="{691B27DD-B170-4248-ABD9-C8437DEFF7C0}"/>
               </a:ext>
             </a:extLst>
           </p:cNvPr>
@@ -8404,7 +8404,7 @@
           <p:cNvPr id="21" name="">
             <a:extLst xmlns:a="http://schemas.openxmlformats.org/drawingml/2006/main">
               <a:ext uri="{FF2B5EF4-FFF2-40B4-BE49-F238E27FC236}">
-                <a16:creationId xmlns:a16="http://schemas.microsoft.com/office/drawing/2014/main" id="{832F73DF-4C84-4671-93F6-53A06CF0ED00}"/>
+                <a16:creationId xmlns:a16="http://schemas.microsoft.com/office/drawing/2014/main" id="{266E6BB2-1EEA-45E7-BAF2-5A04D9DE747F}"/>
               </a:ext>
             </a:extLst>
           </p:cNvPr>
@@ -8468,7 +8468,7 @@
           <p:cNvPr id="22" name="">
             <a:extLst xmlns:a="http://schemas.openxmlformats.org/drawingml/2006/main">
               <a:ext uri="{FF2B5EF4-FFF2-40B4-BE49-F238E27FC236}">
-                <a16:creationId xmlns:a16="http://schemas.microsoft.com/office/drawing/2014/main" id="{3A08223F-D92A-41AE-8F6C-9E7950E24D9B}"/>
+                <a16:creationId xmlns:a16="http://schemas.microsoft.com/office/drawing/2014/main" id="{4B57E806-4834-4616-9797-56D5362C273B}"/>
               </a:ext>
             </a:extLst>
           </p:cNvPr>
@@ -8532,7 +8532,7 @@
           <p:cNvPr id="23" name="">
             <a:extLst xmlns:a="http://schemas.openxmlformats.org/drawingml/2006/main">
               <a:ext uri="{FF2B5EF4-FFF2-40B4-BE49-F238E27FC236}">
-                <a16:creationId xmlns:a16="http://schemas.microsoft.com/office/drawing/2014/main" id="{C82E2982-2253-4B9D-8B38-7FF7D8F4CF2D}"/>
+                <a16:creationId xmlns:a16="http://schemas.microsoft.com/office/drawing/2014/main" id="{84D4805C-3C5A-4AA8-B0BD-4AD7F618EEB9}"/>
               </a:ext>
             </a:extLst>
           </p:cNvPr>
@@ -8565,7 +8565,7 @@
           <p:cNvPr id="24" name="">
             <a:extLst xmlns:a="http://schemas.openxmlformats.org/drawingml/2006/main">
               <a:ext uri="{FF2B5EF4-FFF2-40B4-BE49-F238E27FC236}">
-                <a16:creationId xmlns:a16="http://schemas.microsoft.com/office/drawing/2014/main" id="{1A2EC14E-AD89-45E3-9E73-AECAC64938B9}"/>
+                <a16:creationId xmlns:a16="http://schemas.microsoft.com/office/drawing/2014/main" id="{5A0C0845-4A6C-482E-B943-E358D9F44A8C}"/>
               </a:ext>
             </a:extLst>
           </p:cNvPr>
@@ -8600,7 +8600,7 @@
           <p:cNvPr id="25" name="">
             <a:extLst xmlns:a="http://schemas.openxmlformats.org/drawingml/2006/main">
               <a:ext uri="{FF2B5EF4-FFF2-40B4-BE49-F238E27FC236}">
-                <a16:creationId xmlns:a16="http://schemas.microsoft.com/office/drawing/2014/main" id="{86157D12-E9BF-4E7B-83A0-8B2003615BB7}"/>
+                <a16:creationId xmlns:a16="http://schemas.microsoft.com/office/drawing/2014/main" id="{45C21FBF-5CF2-4428-8E5D-B3891B74660C}"/>
               </a:ext>
             </a:extLst>
           </p:cNvPr>
@@ -8664,7 +8664,7 @@
           <p:cNvPr id="26" name="">
             <a:extLst xmlns:a="http://schemas.openxmlformats.org/drawingml/2006/main">
               <a:ext uri="{FF2B5EF4-FFF2-40B4-BE49-F238E27FC236}">
-                <a16:creationId xmlns:a16="http://schemas.microsoft.com/office/drawing/2014/main" id="{54D3DBF4-4074-4481-A221-67229B0CE71F}"/>
+                <a16:creationId xmlns:a16="http://schemas.microsoft.com/office/drawing/2014/main" id="{AF9D2FFE-7078-436E-89E4-AAF76B7590F9}"/>
               </a:ext>
             </a:extLst>
           </p:cNvPr>
@@ -8726,7 +8726,7 @@
     </p:spTree>
     <p:extLst>
       <p:ext uri="{BB962C8B-B14F-4D97-AF65-F5344CB8AC3E}">
-        <p14:creationId xmlns:p14="http://schemas.microsoft.com/office/powerpoint/2010/main" val="2102856881"/>
+        <p14:creationId xmlns:p14="http://schemas.microsoft.com/office/powerpoint/2010/main" val="47537293"/>
       </p:ext>
     </p:extLst>
   </p:cSld>
@@ -8750,7 +8750,7 @@
           <p:cNvPr id="1" name="">
             <a:extLst xmlns:a="http://schemas.openxmlformats.org/drawingml/2006/main">
               <a:ext uri="{FF2B5EF4-FFF2-40B4-BE49-F238E27FC236}">
-                <a16:creationId xmlns:a16="http://schemas.microsoft.com/office/drawing/2014/main" id="{7ADBAC7F-69A9-4692-851F-8A03E04A9FC8}"/>
+                <a16:creationId xmlns:a16="http://schemas.microsoft.com/office/drawing/2014/main" id="{D52EF616-2157-4DA9-9785-CEDB03E7BE90}"/>
               </a:ext>
             </a:extLst>
           </p:cNvPr>
@@ -8785,7 +8785,7 @@
           <p:cNvPr id="2" name="">
             <a:extLst xmlns:a="http://schemas.openxmlformats.org/drawingml/2006/main">
               <a:ext uri="{FF2B5EF4-FFF2-40B4-BE49-F238E27FC236}">
-                <a16:creationId xmlns:a16="http://schemas.microsoft.com/office/drawing/2014/main" id="{475714D7-4620-47D8-82E0-05C5F0954D13}"/>
+                <a16:creationId xmlns:a16="http://schemas.microsoft.com/office/drawing/2014/main" id="{073340E4-7E8D-4A84-9390-9E0749455738}"/>
               </a:ext>
             </a:extLst>
           </p:cNvPr>
@@ -8820,7 +8820,7 @@
           <p:cNvPr id="3" name="">
             <a:extLst xmlns:a="http://schemas.openxmlformats.org/drawingml/2006/main">
               <a:ext uri="{FF2B5EF4-FFF2-40B4-BE49-F238E27FC236}">
-                <a16:creationId xmlns:a16="http://schemas.microsoft.com/office/drawing/2014/main" id="{466EC0BB-3F8F-49ED-BAA7-6C5943569619}"/>
+                <a16:creationId xmlns:a16="http://schemas.microsoft.com/office/drawing/2014/main" id="{F6A10326-3F67-4C42-AE3D-D7B36BB90FAD}"/>
               </a:ext>
             </a:extLst>
           </p:cNvPr>
@@ -8884,7 +8884,7 @@
           <p:cNvPr id="4" name="">
             <a:extLst xmlns:a="http://schemas.openxmlformats.org/drawingml/2006/main">
               <a:ext uri="{FF2B5EF4-FFF2-40B4-BE49-F238E27FC236}">
-                <a16:creationId xmlns:a16="http://schemas.microsoft.com/office/drawing/2014/main" id="{33096A70-0632-4D3F-9063-2892BF460F20}"/>
+                <a16:creationId xmlns:a16="http://schemas.microsoft.com/office/drawing/2014/main" id="{396292C1-0053-4AD4-A3B8-AD2EC46B5E74}"/>
               </a:ext>
             </a:extLst>
           </p:cNvPr>
@@ -8948,7 +8948,7 @@
           <p:cNvPr id="5" name="">
             <a:extLst xmlns:a="http://schemas.openxmlformats.org/drawingml/2006/main">
               <a:ext uri="{FF2B5EF4-FFF2-40B4-BE49-F238E27FC236}">
-                <a16:creationId xmlns:a16="http://schemas.microsoft.com/office/drawing/2014/main" id="{45BE648C-E83B-4898-9A9A-059A54CD9BE8}"/>
+                <a16:creationId xmlns:a16="http://schemas.microsoft.com/office/drawing/2014/main" id="{A0AF703C-AC0B-4CA9-9347-2EC7C10F589E}"/>
               </a:ext>
             </a:extLst>
           </p:cNvPr>
@@ -9012,7 +9012,7 @@
           <p:cNvPr id="6" name="">
             <a:extLst xmlns:a="http://schemas.openxmlformats.org/drawingml/2006/main">
               <a:ext uri="{FF2B5EF4-FFF2-40B4-BE49-F238E27FC236}">
-                <a16:creationId xmlns:a16="http://schemas.microsoft.com/office/drawing/2014/main" id="{534DF3F5-F5DA-4004-9BB2-F4A0B975AC9D}"/>
+                <a16:creationId xmlns:a16="http://schemas.microsoft.com/office/drawing/2014/main" id="{0228FC85-411E-4057-9555-F67D79A511C0}"/>
               </a:ext>
             </a:extLst>
           </p:cNvPr>
@@ -9076,7 +9076,7 @@
           <p:cNvPr id="7" name="">
             <a:extLst xmlns:a="http://schemas.openxmlformats.org/drawingml/2006/main">
               <a:ext uri="{FF2B5EF4-FFF2-40B4-BE49-F238E27FC236}">
-                <a16:creationId xmlns:a16="http://schemas.microsoft.com/office/drawing/2014/main" id="{1837F915-47FB-4A63-B9D5-2AE8E893F78F}"/>
+                <a16:creationId xmlns:a16="http://schemas.microsoft.com/office/drawing/2014/main" id="{2C8E31DE-FD1C-47BF-9135-0B663FC11C15}"/>
               </a:ext>
             </a:extLst>
           </p:cNvPr>
@@ -9109,7 +9109,7 @@
           <p:cNvPr id="8" name="">
             <a:extLst xmlns:a="http://schemas.openxmlformats.org/drawingml/2006/main">
               <a:ext uri="{FF2B5EF4-FFF2-40B4-BE49-F238E27FC236}">
-                <a16:creationId xmlns:a16="http://schemas.microsoft.com/office/drawing/2014/main" id="{1BA8AFE1-14EC-4510-9E2A-764E8ED17370}"/>
+                <a16:creationId xmlns:a16="http://schemas.microsoft.com/office/drawing/2014/main" id="{2C8B9C1E-F7B3-4069-BE79-0C3E933DDA24}"/>
               </a:ext>
             </a:extLst>
           </p:cNvPr>
@@ -9173,7 +9173,7 @@
           <p:cNvPr id="9" name="">
             <a:extLst xmlns:a="http://schemas.openxmlformats.org/drawingml/2006/main">
               <a:ext uri="{FF2B5EF4-FFF2-40B4-BE49-F238E27FC236}">
-                <a16:creationId xmlns:a16="http://schemas.microsoft.com/office/drawing/2014/main" id="{63100831-9C0E-49F9-A37E-72182856F854}"/>
+                <a16:creationId xmlns:a16="http://schemas.microsoft.com/office/drawing/2014/main" id="{58B7FA90-A426-42FA-95A2-6C9145AFBBD5}"/>
               </a:ext>
             </a:extLst>
           </p:cNvPr>
@@ -9237,7 +9237,7 @@
           <p:cNvPr id="10" name="">
             <a:extLst xmlns:a="http://schemas.openxmlformats.org/drawingml/2006/main">
               <a:ext uri="{FF2B5EF4-FFF2-40B4-BE49-F238E27FC236}">
-                <a16:creationId xmlns:a16="http://schemas.microsoft.com/office/drawing/2014/main" id="{2D6B1AE6-A25B-4066-88BB-416322B07D74}"/>
+                <a16:creationId xmlns:a16="http://schemas.microsoft.com/office/drawing/2014/main" id="{0A18C59D-66D9-435D-B8D4-F24526143A0F}"/>
               </a:ext>
             </a:extLst>
           </p:cNvPr>
@@ -9301,7 +9301,7 @@
           <p:cNvPr id="11" name="">
             <a:extLst xmlns:a="http://schemas.openxmlformats.org/drawingml/2006/main">
               <a:ext uri="{FF2B5EF4-FFF2-40B4-BE49-F238E27FC236}">
-                <a16:creationId xmlns:a16="http://schemas.microsoft.com/office/drawing/2014/main" id="{45F4F26B-4468-46DF-A6BB-BD978F441686}"/>
+                <a16:creationId xmlns:a16="http://schemas.microsoft.com/office/drawing/2014/main" id="{005D2567-C796-4989-B41E-96328C293D55}"/>
               </a:ext>
             </a:extLst>
           </p:cNvPr>
@@ -9334,7 +9334,7 @@
           <p:cNvPr id="12" name="">
             <a:extLst xmlns:a="http://schemas.openxmlformats.org/drawingml/2006/main">
               <a:ext uri="{FF2B5EF4-FFF2-40B4-BE49-F238E27FC236}">
-                <a16:creationId xmlns:a16="http://schemas.microsoft.com/office/drawing/2014/main" id="{FBB39862-9DEA-44B2-8E8E-3F62EA48D042}"/>
+                <a16:creationId xmlns:a16="http://schemas.microsoft.com/office/drawing/2014/main" id="{BCF116A5-02A8-473F-B539-1AA44D49CD4A}"/>
               </a:ext>
             </a:extLst>
           </p:cNvPr>
@@ -9398,7 +9398,7 @@
           <p:cNvPr id="13" name="">
             <a:extLst xmlns:a="http://schemas.openxmlformats.org/drawingml/2006/main">
               <a:ext uri="{FF2B5EF4-FFF2-40B4-BE49-F238E27FC236}">
-                <a16:creationId xmlns:a16="http://schemas.microsoft.com/office/drawing/2014/main" id="{E96CFC67-08CB-488B-9228-832EFFF41579}"/>
+                <a16:creationId xmlns:a16="http://schemas.microsoft.com/office/drawing/2014/main" id="{2722C3A0-2D7D-4D28-A8DB-71D4B4841A44}"/>
               </a:ext>
             </a:extLst>
           </p:cNvPr>
@@ -9462,7 +9462,7 @@
           <p:cNvPr id="14" name="">
             <a:extLst xmlns:a="http://schemas.openxmlformats.org/drawingml/2006/main">
               <a:ext uri="{FF2B5EF4-FFF2-40B4-BE49-F238E27FC236}">
-                <a16:creationId xmlns:a16="http://schemas.microsoft.com/office/drawing/2014/main" id="{9F083480-6929-4DCA-9A21-9EA50D2C4A42}"/>
+                <a16:creationId xmlns:a16="http://schemas.microsoft.com/office/drawing/2014/main" id="{ED742255-7587-4F92-B9F6-4697AF0B9534}"/>
               </a:ext>
             </a:extLst>
           </p:cNvPr>
@@ -9526,7 +9526,7 @@
           <p:cNvPr id="15" name="">
             <a:extLst xmlns:a="http://schemas.openxmlformats.org/drawingml/2006/main">
               <a:ext uri="{FF2B5EF4-FFF2-40B4-BE49-F238E27FC236}">
-                <a16:creationId xmlns:a16="http://schemas.microsoft.com/office/drawing/2014/main" id="{235622F5-8E14-4988-BBAC-97C0AABC1E2C}"/>
+                <a16:creationId xmlns:a16="http://schemas.microsoft.com/office/drawing/2014/main" id="{770A70B2-5BB8-41CB-9336-E238F8A01C0A}"/>
               </a:ext>
             </a:extLst>
           </p:cNvPr>
@@ -9559,7 +9559,7 @@
           <p:cNvPr id="16" name="">
             <a:extLst xmlns:a="http://schemas.openxmlformats.org/drawingml/2006/main">
               <a:ext uri="{FF2B5EF4-FFF2-40B4-BE49-F238E27FC236}">
-                <a16:creationId xmlns:a16="http://schemas.microsoft.com/office/drawing/2014/main" id="{E0F0EB78-F17B-40A9-BCC5-5AC790BD00E2}"/>
+                <a16:creationId xmlns:a16="http://schemas.microsoft.com/office/drawing/2014/main" id="{FE4F8445-E911-411C-8BC8-27F5820C5D13}"/>
               </a:ext>
             </a:extLst>
           </p:cNvPr>
@@ -9623,7 +9623,7 @@
           <p:cNvPr id="17" name="">
             <a:extLst xmlns:a="http://schemas.openxmlformats.org/drawingml/2006/main">
               <a:ext uri="{FF2B5EF4-FFF2-40B4-BE49-F238E27FC236}">
-                <a16:creationId xmlns:a16="http://schemas.microsoft.com/office/drawing/2014/main" id="{84EA4D7C-2388-4F00-B29C-36483E1E1F54}"/>
+                <a16:creationId xmlns:a16="http://schemas.microsoft.com/office/drawing/2014/main" id="{07DB01F6-5202-4C02-A076-E738BB0B72A4}"/>
               </a:ext>
             </a:extLst>
           </p:cNvPr>
@@ -9687,7 +9687,7 @@
           <p:cNvPr id="18" name="">
             <a:extLst xmlns:a="http://schemas.openxmlformats.org/drawingml/2006/main">
               <a:ext uri="{FF2B5EF4-FFF2-40B4-BE49-F238E27FC236}">
-                <a16:creationId xmlns:a16="http://schemas.microsoft.com/office/drawing/2014/main" id="{4FF9B233-EB19-4ACC-836B-68BF13B4FFCB}"/>
+                <a16:creationId xmlns:a16="http://schemas.microsoft.com/office/drawing/2014/main" id="{41EDDF6F-3C5A-4864-B9EE-13D508971879}"/>
               </a:ext>
             </a:extLst>
           </p:cNvPr>
@@ -9751,7 +9751,7 @@
           <p:cNvPr id="19" name="">
             <a:extLst xmlns:a="http://schemas.openxmlformats.org/drawingml/2006/main">
               <a:ext uri="{FF2B5EF4-FFF2-40B4-BE49-F238E27FC236}">
-                <a16:creationId xmlns:a16="http://schemas.microsoft.com/office/drawing/2014/main" id="{620B2E10-329F-4CA7-B250-1CDCD0E989D2}"/>
+                <a16:creationId xmlns:a16="http://schemas.microsoft.com/office/drawing/2014/main" id="{D69F8B43-A08B-4CE3-9C82-4A1D8385569B}"/>
               </a:ext>
             </a:extLst>
           </p:cNvPr>
@@ -9784,7 +9784,7 @@
           <p:cNvPr id="20" name="">
             <a:extLst xmlns:a="http://schemas.openxmlformats.org/drawingml/2006/main">
               <a:ext uri="{FF2B5EF4-FFF2-40B4-BE49-F238E27FC236}">
-                <a16:creationId xmlns:a16="http://schemas.microsoft.com/office/drawing/2014/main" id="{2F97C51D-8478-4015-A89D-E2E2E945A32B}"/>
+                <a16:creationId xmlns:a16="http://schemas.microsoft.com/office/drawing/2014/main" id="{E82D45FC-0EB1-4AA1-A09F-1BF5B6016C11}"/>
               </a:ext>
             </a:extLst>
           </p:cNvPr>
@@ -9848,7 +9848,7 @@
           <p:cNvPr id="21" name="">
             <a:extLst xmlns:a="http://schemas.openxmlformats.org/drawingml/2006/main">
               <a:ext uri="{FF2B5EF4-FFF2-40B4-BE49-F238E27FC236}">
-                <a16:creationId xmlns:a16="http://schemas.microsoft.com/office/drawing/2014/main" id="{C499C021-BD43-4C02-9883-DA0202F9AC72}"/>
+                <a16:creationId xmlns:a16="http://schemas.microsoft.com/office/drawing/2014/main" id="{06D0D090-F9D9-4F1B-91F8-C141CC16F0DA}"/>
               </a:ext>
             </a:extLst>
           </p:cNvPr>
@@ -9912,7 +9912,7 @@
           <p:cNvPr id="22" name="">
             <a:extLst xmlns:a="http://schemas.openxmlformats.org/drawingml/2006/main">
               <a:ext uri="{FF2B5EF4-FFF2-40B4-BE49-F238E27FC236}">
-                <a16:creationId xmlns:a16="http://schemas.microsoft.com/office/drawing/2014/main" id="{BB4F4394-5C7A-4B27-B42C-4005DACBB035}"/>
+                <a16:creationId xmlns:a16="http://schemas.microsoft.com/office/drawing/2014/main" id="{01CF3F46-3F78-4D9D-9627-54ADF360B122}"/>
               </a:ext>
             </a:extLst>
           </p:cNvPr>
@@ -9976,7 +9976,7 @@
           <p:cNvPr id="23" name="">
             <a:extLst xmlns:a="http://schemas.openxmlformats.org/drawingml/2006/main">
               <a:ext uri="{FF2B5EF4-FFF2-40B4-BE49-F238E27FC236}">
-                <a16:creationId xmlns:a16="http://schemas.microsoft.com/office/drawing/2014/main" id="{2E10246E-EF56-40CE-A696-6A8BF05E4E56}"/>
+                <a16:creationId xmlns:a16="http://schemas.microsoft.com/office/drawing/2014/main" id="{110C07C6-4BC2-49F2-A7B7-CED7E940EC9F}"/>
               </a:ext>
             </a:extLst>
           </p:cNvPr>
@@ -10040,7 +10040,7 @@
           <p:cNvPr id="24" name="">
             <a:extLst xmlns:a="http://schemas.openxmlformats.org/drawingml/2006/main">
               <a:ext uri="{FF2B5EF4-FFF2-40B4-BE49-F238E27FC236}">
-                <a16:creationId xmlns:a16="http://schemas.microsoft.com/office/drawing/2014/main" id="{C5A63325-FA38-432F-A19F-171D55FA8500}"/>
+                <a16:creationId xmlns:a16="http://schemas.microsoft.com/office/drawing/2014/main" id="{D4AEA88E-0D61-47B6-8423-F7F0B6ECC936}"/>
               </a:ext>
             </a:extLst>
           </p:cNvPr>
@@ -10075,7 +10075,7 @@
           <p:cNvPr id="25" name="">
             <a:extLst xmlns:a="http://schemas.openxmlformats.org/drawingml/2006/main">
               <a:ext uri="{FF2B5EF4-FFF2-40B4-BE49-F238E27FC236}">
-                <a16:creationId xmlns:a16="http://schemas.microsoft.com/office/drawing/2014/main" id="{CEBF6C44-6D14-4EA6-8BC8-AC2863410F07}"/>
+                <a16:creationId xmlns:a16="http://schemas.microsoft.com/office/drawing/2014/main" id="{40A54C3D-6151-4B42-AEBD-AF8E02ABB8FD}"/>
               </a:ext>
             </a:extLst>
           </p:cNvPr>
@@ -10139,7 +10139,7 @@
           <p:cNvPr id="26" name="">
             <a:extLst xmlns:a="http://schemas.openxmlformats.org/drawingml/2006/main">
               <a:ext uri="{FF2B5EF4-FFF2-40B4-BE49-F238E27FC236}">
-                <a16:creationId xmlns:a16="http://schemas.microsoft.com/office/drawing/2014/main" id="{86FD90AA-6FC4-4361-ACEB-53329872468D}"/>
+                <a16:creationId xmlns:a16="http://schemas.microsoft.com/office/drawing/2014/main" id="{2BB49049-59CD-40E7-B1CF-CFF26A22A2AB}"/>
               </a:ext>
             </a:extLst>
           </p:cNvPr>
@@ -10174,7 +10174,7 @@
           <p:cNvPr id="27" name="">
             <a:extLst xmlns:a="http://schemas.openxmlformats.org/drawingml/2006/main">
               <a:ext uri="{FF2B5EF4-FFF2-40B4-BE49-F238E27FC236}">
-                <a16:creationId xmlns:a16="http://schemas.microsoft.com/office/drawing/2014/main" id="{41DCE2DB-DD84-4F1A-AEC3-2BA41E50ABAB}"/>
+                <a16:creationId xmlns:a16="http://schemas.microsoft.com/office/drawing/2014/main" id="{2F153A5B-50BB-43CD-824B-CAEDA0CA4FB5}"/>
               </a:ext>
             </a:extLst>
           </p:cNvPr>
@@ -10238,7 +10238,7 @@
           <p:cNvPr id="28" name="">
             <a:extLst xmlns:a="http://schemas.openxmlformats.org/drawingml/2006/main">
               <a:ext uri="{FF2B5EF4-FFF2-40B4-BE49-F238E27FC236}">
-                <a16:creationId xmlns:a16="http://schemas.microsoft.com/office/drawing/2014/main" id="{FF712441-54E6-4B1A-8588-62AFADA852AA}"/>
+                <a16:creationId xmlns:a16="http://schemas.microsoft.com/office/drawing/2014/main" id="{7E086FA2-0DB4-4F02-B96A-A55A10776592}"/>
               </a:ext>
             </a:extLst>
           </p:cNvPr>
@@ -10273,7 +10273,7 @@
           <p:cNvPr id="29" name="">
             <a:extLst xmlns:a="http://schemas.openxmlformats.org/drawingml/2006/main">
               <a:ext uri="{FF2B5EF4-FFF2-40B4-BE49-F238E27FC236}">
-                <a16:creationId xmlns:a16="http://schemas.microsoft.com/office/drawing/2014/main" id="{FFD8361B-0C5B-404F-994A-34F8C0D59A73}"/>
+                <a16:creationId xmlns:a16="http://schemas.microsoft.com/office/drawing/2014/main" id="{6E5F058F-A3C5-4B81-8794-DE1C41EFE5EE}"/>
               </a:ext>
             </a:extLst>
           </p:cNvPr>
@@ -10337,7 +10337,7 @@
           <p:cNvPr id="30" name="">
             <a:extLst xmlns:a="http://schemas.openxmlformats.org/drawingml/2006/main">
               <a:ext uri="{FF2B5EF4-FFF2-40B4-BE49-F238E27FC236}">
-                <a16:creationId xmlns:a16="http://schemas.microsoft.com/office/drawing/2014/main" id="{BCBC0F74-D24D-4CCA-AD60-39815AD597AB}"/>
+                <a16:creationId xmlns:a16="http://schemas.microsoft.com/office/drawing/2014/main" id="{6C07808F-BD87-4BDC-80A3-2F0BD772290A}"/>
               </a:ext>
             </a:extLst>
           </p:cNvPr>
@@ -10372,7 +10372,7 @@
           <p:cNvPr id="31" name="">
             <a:extLst xmlns:a="http://schemas.openxmlformats.org/drawingml/2006/main">
               <a:ext uri="{FF2B5EF4-FFF2-40B4-BE49-F238E27FC236}">
-                <a16:creationId xmlns:a16="http://schemas.microsoft.com/office/drawing/2014/main" id="{8C8B956F-BDE6-4104-A948-A5BC04DEAC38}"/>
+                <a16:creationId xmlns:a16="http://schemas.microsoft.com/office/drawing/2014/main" id="{83B56025-75B6-4BBB-816C-AFCB25E0599C}"/>
               </a:ext>
             </a:extLst>
           </p:cNvPr>
@@ -10436,7 +10436,7 @@
           <p:cNvPr id="32" name="">
             <a:extLst xmlns:a="http://schemas.openxmlformats.org/drawingml/2006/main">
               <a:ext uri="{FF2B5EF4-FFF2-40B4-BE49-F238E27FC236}">
-                <a16:creationId xmlns:a16="http://schemas.microsoft.com/office/drawing/2014/main" id="{2D6B2D82-B9EE-430D-9545-EC1834661EE6}"/>
+                <a16:creationId xmlns:a16="http://schemas.microsoft.com/office/drawing/2014/main" id="{CCA98D82-306B-466C-8DC9-B8F75930067F}"/>
               </a:ext>
             </a:extLst>
           </p:cNvPr>
@@ -10469,7 +10469,7 @@
           <p:cNvPr id="33" name="">
             <a:extLst xmlns:a="http://schemas.openxmlformats.org/drawingml/2006/main">
               <a:ext uri="{FF2B5EF4-FFF2-40B4-BE49-F238E27FC236}">
-                <a16:creationId xmlns:a16="http://schemas.microsoft.com/office/drawing/2014/main" id="{BD40D039-9A8C-41C9-8B5A-EB00B897EE2D}"/>
+                <a16:creationId xmlns:a16="http://schemas.microsoft.com/office/drawing/2014/main" id="{34FE1425-3773-4CFE-B40B-45AB86B564D0}"/>
               </a:ext>
             </a:extLst>
           </p:cNvPr>
@@ -10504,7 +10504,7 @@
           <p:cNvPr id="34" name="">
             <a:extLst xmlns:a="http://schemas.openxmlformats.org/drawingml/2006/main">
               <a:ext uri="{FF2B5EF4-FFF2-40B4-BE49-F238E27FC236}">
-                <a16:creationId xmlns:a16="http://schemas.microsoft.com/office/drawing/2014/main" id="{177F1FE4-F6FF-496E-9BC7-E1D2904E1FC4}"/>
+                <a16:creationId xmlns:a16="http://schemas.microsoft.com/office/drawing/2014/main" id="{3EB849DC-F5B0-47B2-8D00-175E5C063481}"/>
               </a:ext>
             </a:extLst>
           </p:cNvPr>
@@ -10568,7 +10568,7 @@
           <p:cNvPr id="35" name="">
             <a:extLst xmlns:a="http://schemas.openxmlformats.org/drawingml/2006/main">
               <a:ext uri="{FF2B5EF4-FFF2-40B4-BE49-F238E27FC236}">
-                <a16:creationId xmlns:a16="http://schemas.microsoft.com/office/drawing/2014/main" id="{0AEAF258-E8EC-416F-93C7-F94A249D8AE5}"/>
+                <a16:creationId xmlns:a16="http://schemas.microsoft.com/office/drawing/2014/main" id="{B6712ED5-BAAE-4EEE-A131-B05D67E408A4}"/>
               </a:ext>
             </a:extLst>
           </p:cNvPr>
@@ -10630,7 +10630,7 @@
     </p:spTree>
     <p:extLst>
       <p:ext uri="{BB962C8B-B14F-4D97-AF65-F5344CB8AC3E}">
-        <p14:creationId xmlns:p14="http://schemas.microsoft.com/office/powerpoint/2010/main" val="806066714"/>
+        <p14:creationId xmlns:p14="http://schemas.microsoft.com/office/powerpoint/2010/main" val="829874003"/>
       </p:ext>
     </p:extLst>
   </p:cSld>
@@ -10654,7 +10654,7 @@
           <p:cNvPr id="1" name="">
             <a:extLst xmlns:a="http://schemas.openxmlformats.org/drawingml/2006/main">
               <a:ext uri="{FF2B5EF4-FFF2-40B4-BE49-F238E27FC236}">
-                <a16:creationId xmlns:a16="http://schemas.microsoft.com/office/drawing/2014/main" id="{E096B8AD-AAA0-4CB3-8278-86DD9BFC3B08}"/>
+                <a16:creationId xmlns:a16="http://schemas.microsoft.com/office/drawing/2014/main" id="{CA060EA1-1167-4D39-A877-1C274ECEA6B4}"/>
               </a:ext>
             </a:extLst>
           </p:cNvPr>
@@ -10689,7 +10689,7 @@
           <p:cNvPr id="2" name="">
             <a:extLst xmlns:a="http://schemas.openxmlformats.org/drawingml/2006/main">
               <a:ext uri="{FF2B5EF4-FFF2-40B4-BE49-F238E27FC236}">
-                <a16:creationId xmlns:a16="http://schemas.microsoft.com/office/drawing/2014/main" id="{06FB2FF8-24AF-4779-AFC4-239A7C1169DB}"/>
+                <a16:creationId xmlns:a16="http://schemas.microsoft.com/office/drawing/2014/main" id="{E9265E40-F5CE-4E3B-812E-EE77E4B2CD8E}"/>
               </a:ext>
             </a:extLst>
           </p:cNvPr>
@@ -10724,7 +10724,7 @@
           <p:cNvPr id="3" name="">
             <a:extLst xmlns:a="http://schemas.openxmlformats.org/drawingml/2006/main">
               <a:ext uri="{FF2B5EF4-FFF2-40B4-BE49-F238E27FC236}">
-                <a16:creationId xmlns:a16="http://schemas.microsoft.com/office/drawing/2014/main" id="{D2761BB2-76D7-4617-8FF8-B2510A2072AD}"/>
+                <a16:creationId xmlns:a16="http://schemas.microsoft.com/office/drawing/2014/main" id="{653EB0F5-8915-4A88-9113-F89F7DC8D1FA}"/>
               </a:ext>
             </a:extLst>
           </p:cNvPr>
@@ -10788,7 +10788,7 @@
           <p:cNvPr id="4" name="">
             <a:extLst xmlns:a="http://schemas.openxmlformats.org/drawingml/2006/main">
               <a:ext uri="{FF2B5EF4-FFF2-40B4-BE49-F238E27FC236}">
-                <a16:creationId xmlns:a16="http://schemas.microsoft.com/office/drawing/2014/main" id="{77404F6E-76B0-4BB2-A8EA-E32149F32FB6}"/>
+                <a16:creationId xmlns:a16="http://schemas.microsoft.com/office/drawing/2014/main" id="{422A4BCF-0B24-4E8D-9AA4-81723553E9F3}"/>
               </a:ext>
             </a:extLst>
           </p:cNvPr>
@@ -10852,7 +10852,7 @@
           <p:cNvPr id="5" name="">
             <a:extLst xmlns:a="http://schemas.openxmlformats.org/drawingml/2006/main">
               <a:ext uri="{FF2B5EF4-FFF2-40B4-BE49-F238E27FC236}">
-                <a16:creationId xmlns:a16="http://schemas.microsoft.com/office/drawing/2014/main" id="{8E2B1820-B2BB-4A5C-94FF-B999C739EBD9}"/>
+                <a16:creationId xmlns:a16="http://schemas.microsoft.com/office/drawing/2014/main" id="{96F49E63-F1B3-4F1D-A58C-F79383FC0109}"/>
               </a:ext>
             </a:extLst>
           </p:cNvPr>
@@ -10916,7 +10916,7 @@
           <p:cNvPr id="6" name="">
             <a:extLst xmlns:a="http://schemas.openxmlformats.org/drawingml/2006/main">
               <a:ext uri="{FF2B5EF4-FFF2-40B4-BE49-F238E27FC236}">
-                <a16:creationId xmlns:a16="http://schemas.microsoft.com/office/drawing/2014/main" id="{BC97FE6F-53B9-4F2E-9250-5C87B50FDB1C}"/>
+                <a16:creationId xmlns:a16="http://schemas.microsoft.com/office/drawing/2014/main" id="{6CDCC60B-352A-48BC-90AE-5F39E2299958}"/>
               </a:ext>
             </a:extLst>
           </p:cNvPr>
@@ -10980,7 +10980,7 @@
           <p:cNvPr id="7" name="">
             <a:extLst xmlns:a="http://schemas.openxmlformats.org/drawingml/2006/main">
               <a:ext uri="{FF2B5EF4-FFF2-40B4-BE49-F238E27FC236}">
-                <a16:creationId xmlns:a16="http://schemas.microsoft.com/office/drawing/2014/main" id="{7A397FA4-0850-4D97-9750-015D645849A8}"/>
+                <a16:creationId xmlns:a16="http://schemas.microsoft.com/office/drawing/2014/main" id="{8F29706F-CD72-4003-8E25-F08BC4E2F01B}"/>
               </a:ext>
             </a:extLst>
           </p:cNvPr>
@@ -11013,7 +11013,7 @@
           <p:cNvPr id="8" name="">
             <a:extLst xmlns:a="http://schemas.openxmlformats.org/drawingml/2006/main">
               <a:ext uri="{FF2B5EF4-FFF2-40B4-BE49-F238E27FC236}">
-                <a16:creationId xmlns:a16="http://schemas.microsoft.com/office/drawing/2014/main" id="{FA079991-354D-403F-9FB8-DE8E42D845F3}"/>
+                <a16:creationId xmlns:a16="http://schemas.microsoft.com/office/drawing/2014/main" id="{97630725-8C54-4007-90ED-A290D54AE8AD}"/>
               </a:ext>
             </a:extLst>
           </p:cNvPr>
@@ -11077,7 +11077,7 @@
           <p:cNvPr id="9" name="">
             <a:extLst xmlns:a="http://schemas.openxmlformats.org/drawingml/2006/main">
               <a:ext uri="{FF2B5EF4-FFF2-40B4-BE49-F238E27FC236}">
-                <a16:creationId xmlns:a16="http://schemas.microsoft.com/office/drawing/2014/main" id="{FA605746-D2BD-438B-9689-A81DCB7202D8}"/>
+                <a16:creationId xmlns:a16="http://schemas.microsoft.com/office/drawing/2014/main" id="{8894F3C8-35CC-4CE1-B939-1DFBC592EFB5}"/>
               </a:ext>
             </a:extLst>
           </p:cNvPr>
@@ -11110,7 +11110,7 @@
           <p:cNvPr id="10" name="">
             <a:extLst xmlns:a="http://schemas.openxmlformats.org/drawingml/2006/main">
               <a:ext uri="{FF2B5EF4-FFF2-40B4-BE49-F238E27FC236}">
-                <a16:creationId xmlns:a16="http://schemas.microsoft.com/office/drawing/2014/main" id="{3AFAB719-8193-4638-9E1B-D71349790637}"/>
+                <a16:creationId xmlns:a16="http://schemas.microsoft.com/office/drawing/2014/main" id="{F49B6141-C98F-41EE-A8FD-40E44B2D301D}"/>
               </a:ext>
             </a:extLst>
           </p:cNvPr>
@@ -11174,7 +11174,7 @@
           <p:cNvPr id="11" name="">
             <a:extLst xmlns:a="http://schemas.openxmlformats.org/drawingml/2006/main">
               <a:ext uri="{FF2B5EF4-FFF2-40B4-BE49-F238E27FC236}">
-                <a16:creationId xmlns:a16="http://schemas.microsoft.com/office/drawing/2014/main" id="{3E1B0C90-55F6-4C11-8E0B-B865F85E86A2}"/>
+                <a16:creationId xmlns:a16="http://schemas.microsoft.com/office/drawing/2014/main" id="{C4278664-8D0A-470E-ADC6-B671E415B3D2}"/>
               </a:ext>
             </a:extLst>
           </p:cNvPr>
@@ -11238,7 +11238,7 @@
           <p:cNvPr id="12" name="">
             <a:extLst xmlns:a="http://schemas.openxmlformats.org/drawingml/2006/main">
               <a:ext uri="{FF2B5EF4-FFF2-40B4-BE49-F238E27FC236}">
-                <a16:creationId xmlns:a16="http://schemas.microsoft.com/office/drawing/2014/main" id="{2BF3F1E2-9F1C-4346-B648-2B005E4B032B}"/>
+                <a16:creationId xmlns:a16="http://schemas.microsoft.com/office/drawing/2014/main" id="{B30C3531-B0B1-4109-B961-EB6377AE3D4F}"/>
               </a:ext>
             </a:extLst>
           </p:cNvPr>
@@ -11271,7 +11271,7 @@
           <p:cNvPr id="13" name="">
             <a:extLst xmlns:a="http://schemas.openxmlformats.org/drawingml/2006/main">
               <a:ext uri="{FF2B5EF4-FFF2-40B4-BE49-F238E27FC236}">
-                <a16:creationId xmlns:a16="http://schemas.microsoft.com/office/drawing/2014/main" id="{C14D19D5-451E-446C-9140-5BEAD7EA236E}"/>
+                <a16:creationId xmlns:a16="http://schemas.microsoft.com/office/drawing/2014/main" id="{BB90E1D2-CE53-4217-989E-0B1343924E05}"/>
               </a:ext>
             </a:extLst>
           </p:cNvPr>
@@ -11335,7 +11335,7 @@
           <p:cNvPr id="14" name="">
             <a:extLst xmlns:a="http://schemas.openxmlformats.org/drawingml/2006/main">
               <a:ext uri="{FF2B5EF4-FFF2-40B4-BE49-F238E27FC236}">
-                <a16:creationId xmlns:a16="http://schemas.microsoft.com/office/drawing/2014/main" id="{49020776-89EE-4A35-B397-B31892B4C53D}"/>
+                <a16:creationId xmlns:a16="http://schemas.microsoft.com/office/drawing/2014/main" id="{2AD9D661-29E2-4C61-A80C-0671447CFB5C}"/>
               </a:ext>
             </a:extLst>
           </p:cNvPr>
@@ -11368,7 +11368,7 @@
           <p:cNvPr id="15" name="">
             <a:extLst xmlns:a="http://schemas.openxmlformats.org/drawingml/2006/main">
               <a:ext uri="{FF2B5EF4-FFF2-40B4-BE49-F238E27FC236}">
-                <a16:creationId xmlns:a16="http://schemas.microsoft.com/office/drawing/2014/main" id="{8332987A-51A3-4B29-8B7E-A80D2EF7132C}"/>
+                <a16:creationId xmlns:a16="http://schemas.microsoft.com/office/drawing/2014/main" id="{8B2F8BF9-A2D9-452C-A711-972D60E54C79}"/>
               </a:ext>
             </a:extLst>
           </p:cNvPr>
@@ -11432,7 +11432,7 @@
           <p:cNvPr id="16" name="">
             <a:extLst xmlns:a="http://schemas.openxmlformats.org/drawingml/2006/main">
               <a:ext uri="{FF2B5EF4-FFF2-40B4-BE49-F238E27FC236}">
-                <a16:creationId xmlns:a16="http://schemas.microsoft.com/office/drawing/2014/main" id="{AFD15C3E-DC61-4D3A-84BD-DE3FB9FEB6C1}"/>
+                <a16:creationId xmlns:a16="http://schemas.microsoft.com/office/drawing/2014/main" id="{E85B472E-324F-4765-9062-1CCFE43E6ABB}"/>
               </a:ext>
             </a:extLst>
           </p:cNvPr>
@@ -11496,7 +11496,7 @@
           <p:cNvPr id="17" name="">
             <a:extLst xmlns:a="http://schemas.openxmlformats.org/drawingml/2006/main">
               <a:ext uri="{FF2B5EF4-FFF2-40B4-BE49-F238E27FC236}">
-                <a16:creationId xmlns:a16="http://schemas.microsoft.com/office/drawing/2014/main" id="{F5FCECBD-09B4-4F8F-ADC8-8ED754635714}"/>
+                <a16:creationId xmlns:a16="http://schemas.microsoft.com/office/drawing/2014/main" id="{A393767C-679D-40D0-8CF2-88611940CA0D}"/>
               </a:ext>
             </a:extLst>
           </p:cNvPr>
@@ -11529,7 +11529,7 @@
           <p:cNvPr id="18" name="">
             <a:extLst xmlns:a="http://schemas.openxmlformats.org/drawingml/2006/main">
               <a:ext uri="{FF2B5EF4-FFF2-40B4-BE49-F238E27FC236}">
-                <a16:creationId xmlns:a16="http://schemas.microsoft.com/office/drawing/2014/main" id="{49345A4E-6106-4F71-8DB3-85106E78642B}"/>
+                <a16:creationId xmlns:a16="http://schemas.microsoft.com/office/drawing/2014/main" id="{1B80308A-7900-46DF-98C7-8C611B07A674}"/>
               </a:ext>
             </a:extLst>
           </p:cNvPr>
@@ -11593,7 +11593,7 @@
           <p:cNvPr id="19" name="">
             <a:extLst xmlns:a="http://schemas.openxmlformats.org/drawingml/2006/main">
               <a:ext uri="{FF2B5EF4-FFF2-40B4-BE49-F238E27FC236}">
-                <a16:creationId xmlns:a16="http://schemas.microsoft.com/office/drawing/2014/main" id="{DA84B1AD-12E2-4B6E-AC74-2E7BAEF9E652}"/>
+                <a16:creationId xmlns:a16="http://schemas.microsoft.com/office/drawing/2014/main" id="{D2DEFC8A-1C36-4410-B3CA-9529F416B260}"/>
               </a:ext>
             </a:extLst>
           </p:cNvPr>
@@ -11626,7 +11626,7 @@
           <p:cNvPr id="20" name="">
             <a:extLst xmlns:a="http://schemas.openxmlformats.org/drawingml/2006/main">
               <a:ext uri="{FF2B5EF4-FFF2-40B4-BE49-F238E27FC236}">
-                <a16:creationId xmlns:a16="http://schemas.microsoft.com/office/drawing/2014/main" id="{8620600B-E995-4201-9FE7-E68474495417}"/>
+                <a16:creationId xmlns:a16="http://schemas.microsoft.com/office/drawing/2014/main" id="{DD1E5770-E1C5-42F7-B40D-421B9E8A6CFE}"/>
               </a:ext>
             </a:extLst>
           </p:cNvPr>
@@ -11690,7 +11690,7 @@
           <p:cNvPr id="21" name="">
             <a:extLst xmlns:a="http://schemas.openxmlformats.org/drawingml/2006/main">
               <a:ext uri="{FF2B5EF4-FFF2-40B4-BE49-F238E27FC236}">
-                <a16:creationId xmlns:a16="http://schemas.microsoft.com/office/drawing/2014/main" id="{252C35B4-9EC1-408C-B5F9-2813741C48A5}"/>
+                <a16:creationId xmlns:a16="http://schemas.microsoft.com/office/drawing/2014/main" id="{2F5913B6-52D3-4E50-9222-9207B47ACD27}"/>
               </a:ext>
             </a:extLst>
           </p:cNvPr>
@@ -11754,7 +11754,7 @@
           <p:cNvPr id="22" name="">
             <a:extLst xmlns:a="http://schemas.openxmlformats.org/drawingml/2006/main">
               <a:ext uri="{FF2B5EF4-FFF2-40B4-BE49-F238E27FC236}">
-                <a16:creationId xmlns:a16="http://schemas.microsoft.com/office/drawing/2014/main" id="{781375E5-6397-4DC9-BCBA-43312A6D3679}"/>
+                <a16:creationId xmlns:a16="http://schemas.microsoft.com/office/drawing/2014/main" id="{03A1A232-F20D-4017-B506-B07A1578E1F0}"/>
               </a:ext>
             </a:extLst>
           </p:cNvPr>
@@ -11787,7 +11787,7 @@
           <p:cNvPr id="23" name="">
             <a:extLst xmlns:a="http://schemas.openxmlformats.org/drawingml/2006/main">
               <a:ext uri="{FF2B5EF4-FFF2-40B4-BE49-F238E27FC236}">
-                <a16:creationId xmlns:a16="http://schemas.microsoft.com/office/drawing/2014/main" id="{E2F7D6CD-A733-46C4-9BAC-F2FDB0AD2BAC}"/>
+                <a16:creationId xmlns:a16="http://schemas.microsoft.com/office/drawing/2014/main" id="{B8E59706-F290-41FE-926D-08AF1B8FD1DC}"/>
               </a:ext>
             </a:extLst>
           </p:cNvPr>
@@ -11851,7 +11851,7 @@
           <p:cNvPr id="24" name="">
             <a:extLst xmlns:a="http://schemas.openxmlformats.org/drawingml/2006/main">
               <a:ext uri="{FF2B5EF4-FFF2-40B4-BE49-F238E27FC236}">
-                <a16:creationId xmlns:a16="http://schemas.microsoft.com/office/drawing/2014/main" id="{08D0A526-7C1C-49DF-AB6C-E30E9827560A}"/>
+                <a16:creationId xmlns:a16="http://schemas.microsoft.com/office/drawing/2014/main" id="{6D47249D-20C1-467E-B675-3D68E8675285}"/>
               </a:ext>
             </a:extLst>
           </p:cNvPr>
@@ -11884,7 +11884,7 @@
           <p:cNvPr id="25" name="">
             <a:extLst xmlns:a="http://schemas.openxmlformats.org/drawingml/2006/main">
               <a:ext uri="{FF2B5EF4-FFF2-40B4-BE49-F238E27FC236}">
-                <a16:creationId xmlns:a16="http://schemas.microsoft.com/office/drawing/2014/main" id="{AE60E716-BC66-4340-84E1-3D1C7A0E214F}"/>
+                <a16:creationId xmlns:a16="http://schemas.microsoft.com/office/drawing/2014/main" id="{C44904DD-F1A3-4554-AAF5-AF3542346697}"/>
               </a:ext>
             </a:extLst>
           </p:cNvPr>
@@ -11948,7 +11948,7 @@
           <p:cNvPr id="26" name="">
             <a:extLst xmlns:a="http://schemas.openxmlformats.org/drawingml/2006/main">
               <a:ext uri="{FF2B5EF4-FFF2-40B4-BE49-F238E27FC236}">
-                <a16:creationId xmlns:a16="http://schemas.microsoft.com/office/drawing/2014/main" id="{94F3E393-829B-444E-A524-DEBA92603136}"/>
+                <a16:creationId xmlns:a16="http://schemas.microsoft.com/office/drawing/2014/main" id="{0A48404F-D587-4C08-B1D7-7FDAF005E511}"/>
               </a:ext>
             </a:extLst>
           </p:cNvPr>
@@ -12012,7 +12012,7 @@
           <p:cNvPr id="27" name="">
             <a:extLst xmlns:a="http://schemas.openxmlformats.org/drawingml/2006/main">
               <a:ext uri="{FF2B5EF4-FFF2-40B4-BE49-F238E27FC236}">
-                <a16:creationId xmlns:a16="http://schemas.microsoft.com/office/drawing/2014/main" id="{E1DBD698-36CC-4049-B3A3-6DD626EFC716}"/>
+                <a16:creationId xmlns:a16="http://schemas.microsoft.com/office/drawing/2014/main" id="{5829D607-B078-4806-8CAE-FECEA8AC8A2A}"/>
               </a:ext>
             </a:extLst>
           </p:cNvPr>
@@ -12045,7 +12045,7 @@
           <p:cNvPr id="28" name="">
             <a:extLst xmlns:a="http://schemas.openxmlformats.org/drawingml/2006/main">
               <a:ext uri="{FF2B5EF4-FFF2-40B4-BE49-F238E27FC236}">
-                <a16:creationId xmlns:a16="http://schemas.microsoft.com/office/drawing/2014/main" id="{E547119E-9387-4F52-A816-1ADB37442C97}"/>
+                <a16:creationId xmlns:a16="http://schemas.microsoft.com/office/drawing/2014/main" id="{38008D2B-92E1-4DF7-B508-B823A8E45EF1}"/>
               </a:ext>
             </a:extLst>
           </p:cNvPr>
@@ -12109,7 +12109,7 @@
           <p:cNvPr id="29" name="">
             <a:extLst xmlns:a="http://schemas.openxmlformats.org/drawingml/2006/main">
               <a:ext uri="{FF2B5EF4-FFF2-40B4-BE49-F238E27FC236}">
-                <a16:creationId xmlns:a16="http://schemas.microsoft.com/office/drawing/2014/main" id="{A35898BF-ED3C-4FA8-8F09-885E2D0B91F4}"/>
+                <a16:creationId xmlns:a16="http://schemas.microsoft.com/office/drawing/2014/main" id="{B982475F-9B1C-42C1-AE25-23AA0EAA945D}"/>
               </a:ext>
             </a:extLst>
           </p:cNvPr>
@@ -12142,7 +12142,7 @@
           <p:cNvPr id="30" name="">
             <a:extLst xmlns:a="http://schemas.openxmlformats.org/drawingml/2006/main">
               <a:ext uri="{FF2B5EF4-FFF2-40B4-BE49-F238E27FC236}">
-                <a16:creationId xmlns:a16="http://schemas.microsoft.com/office/drawing/2014/main" id="{E6C6DC2B-2826-4EC6-99F0-3D9741911C7D}"/>
+                <a16:creationId xmlns:a16="http://schemas.microsoft.com/office/drawing/2014/main" id="{F8CAA01F-BD33-4519-BA75-D6429AE237E6}"/>
               </a:ext>
             </a:extLst>
           </p:cNvPr>
@@ -12206,7 +12206,7 @@
           <p:cNvPr id="31" name="">
             <a:extLst xmlns:a="http://schemas.openxmlformats.org/drawingml/2006/main">
               <a:ext uri="{FF2B5EF4-FFF2-40B4-BE49-F238E27FC236}">
-                <a16:creationId xmlns:a16="http://schemas.microsoft.com/office/drawing/2014/main" id="{DCA122C4-AE86-41E5-A40A-8B1BF30B032E}"/>
+                <a16:creationId xmlns:a16="http://schemas.microsoft.com/office/drawing/2014/main" id="{1CD7D5F0-0C28-4509-94BC-6C5E0100CEDA}"/>
               </a:ext>
             </a:extLst>
           </p:cNvPr>
@@ -12268,7 +12268,7 @@
     </p:spTree>
     <p:extLst>
       <p:ext uri="{BB962C8B-B14F-4D97-AF65-F5344CB8AC3E}">
-        <p14:creationId xmlns:p14="http://schemas.microsoft.com/office/powerpoint/2010/main" val="2137629795"/>
+        <p14:creationId xmlns:p14="http://schemas.microsoft.com/office/powerpoint/2010/main" val="1857177785"/>
       </p:ext>
     </p:extLst>
   </p:cSld>
@@ -12292,7 +12292,7 @@
           <p:cNvPr id="1" name="">
             <a:extLst xmlns:a="http://schemas.openxmlformats.org/drawingml/2006/main">
               <a:ext uri="{FF2B5EF4-FFF2-40B4-BE49-F238E27FC236}">
-                <a16:creationId xmlns:a16="http://schemas.microsoft.com/office/drawing/2014/main" id="{9EF0E72D-64A9-45B9-9851-F134786D0ADD}"/>
+                <a16:creationId xmlns:a16="http://schemas.microsoft.com/office/drawing/2014/main" id="{5A1010AD-F8B9-4FE4-80CA-CF6CD0F0E5DD}"/>
               </a:ext>
             </a:extLst>
           </p:cNvPr>
@@ -12327,7 +12327,7 @@
           <p:cNvPr id="2" name="">
             <a:extLst xmlns:a="http://schemas.openxmlformats.org/drawingml/2006/main">
               <a:ext uri="{FF2B5EF4-FFF2-40B4-BE49-F238E27FC236}">
-                <a16:creationId xmlns:a16="http://schemas.microsoft.com/office/drawing/2014/main" id="{05AD2E99-4D3A-4860-9338-D41B4DF25F04}"/>
+                <a16:creationId xmlns:a16="http://schemas.microsoft.com/office/drawing/2014/main" id="{00D9DAEA-15FE-4E7B-BABE-F36F8E32AA7A}"/>
               </a:ext>
             </a:extLst>
           </p:cNvPr>
@@ -12362,7 +12362,7 @@
           <p:cNvPr id="3" name="">
             <a:extLst xmlns:a="http://schemas.openxmlformats.org/drawingml/2006/main">
               <a:ext uri="{FF2B5EF4-FFF2-40B4-BE49-F238E27FC236}">
-                <a16:creationId xmlns:a16="http://schemas.microsoft.com/office/drawing/2014/main" id="{7D35E81E-028A-4A00-AF8F-66CDF550B627}"/>
+                <a16:creationId xmlns:a16="http://schemas.microsoft.com/office/drawing/2014/main" id="{A6150DE3-4C02-41A4-AE9A-4230B42A5B66}"/>
               </a:ext>
             </a:extLst>
           </p:cNvPr>
@@ -12426,7 +12426,7 @@
           <p:cNvPr id="4" name="">
             <a:extLst xmlns:a="http://schemas.openxmlformats.org/drawingml/2006/main">
               <a:ext uri="{FF2B5EF4-FFF2-40B4-BE49-F238E27FC236}">
-                <a16:creationId xmlns:a16="http://schemas.microsoft.com/office/drawing/2014/main" id="{F28AEDCA-3E68-49D3-B3FC-781341AF6B26}"/>
+                <a16:creationId xmlns:a16="http://schemas.microsoft.com/office/drawing/2014/main" id="{2583DC22-ECBB-4B7A-B584-12C99C5F281A}"/>
               </a:ext>
             </a:extLst>
           </p:cNvPr>
@@ -12490,7 +12490,7 @@
           <p:cNvPr id="5" name="">
             <a:extLst xmlns:a="http://schemas.openxmlformats.org/drawingml/2006/main">
               <a:ext uri="{FF2B5EF4-FFF2-40B4-BE49-F238E27FC236}">
-                <a16:creationId xmlns:a16="http://schemas.microsoft.com/office/drawing/2014/main" id="{4E6722AC-7DA9-4845-8473-831E51F77AC1}"/>
+                <a16:creationId xmlns:a16="http://schemas.microsoft.com/office/drawing/2014/main" id="{D1200398-34ED-40E7-9E42-75A82A5FB2F0}"/>
               </a:ext>
             </a:extLst>
           </p:cNvPr>
@@ -12554,7 +12554,7 @@
           <p:cNvPr id="6" name="">
             <a:extLst xmlns:a="http://schemas.openxmlformats.org/drawingml/2006/main">
               <a:ext uri="{FF2B5EF4-FFF2-40B4-BE49-F238E27FC236}">
-                <a16:creationId xmlns:a16="http://schemas.microsoft.com/office/drawing/2014/main" id="{34D33CB2-C7AF-4EA6-A4AE-B3F89E305CCF}"/>
+                <a16:creationId xmlns:a16="http://schemas.microsoft.com/office/drawing/2014/main" id="{814C6257-E3E4-4A2E-8990-D7D758120FDB}"/>
               </a:ext>
             </a:extLst>
           </p:cNvPr>
@@ -12622,7 +12622,7 @@
           <p:nvPr/>
         </p:nvPicPr>
         <p:blipFill>
-          <a:blip xmlns:r="http://schemas.openxmlformats.org/officeDocument/2006/relationships" xmlns:a="http://schemas.openxmlformats.org/drawingml/2006/main" r:embed="R0e3cccd574f54414"/>
+          <a:blip xmlns:r="http://schemas.openxmlformats.org/officeDocument/2006/relationships" xmlns:a="http://schemas.openxmlformats.org/drawingml/2006/main" r:embed="Rbf88ad9fa47e4617"/>
           <a:stretch xmlns:a="http://schemas.openxmlformats.org/drawingml/2006/main"/>
         </p:blipFill>
         <p:spPr>
@@ -12638,7 +12638,7 @@
     </p:spTree>
     <p:extLst>
       <p:ext uri="{BB962C8B-B14F-4D97-AF65-F5344CB8AC3E}">
-        <p14:creationId xmlns:p14="http://schemas.microsoft.com/office/powerpoint/2010/main" val="1924245882"/>
+        <p14:creationId xmlns:p14="http://schemas.microsoft.com/office/powerpoint/2010/main" val="301854620"/>
       </p:ext>
     </p:extLst>
   </p:cSld>
@@ -12662,7 +12662,7 @@
           <p:cNvPr id="1" name="">
             <a:extLst xmlns:a="http://schemas.openxmlformats.org/drawingml/2006/main">
               <a:ext uri="{FF2B5EF4-FFF2-40B4-BE49-F238E27FC236}">
-                <a16:creationId xmlns:a16="http://schemas.microsoft.com/office/drawing/2014/main" id="{D3B01D99-D10A-4D65-B2E7-A126166BB7BD}"/>
+                <a16:creationId xmlns:a16="http://schemas.microsoft.com/office/drawing/2014/main" id="{6C2749E0-F313-4A4B-9B65-27726AD5226A}"/>
               </a:ext>
             </a:extLst>
           </p:cNvPr>
@@ -12697,7 +12697,7 @@
           <p:cNvPr id="2" name="">
             <a:extLst xmlns:a="http://schemas.openxmlformats.org/drawingml/2006/main">
               <a:ext uri="{FF2B5EF4-FFF2-40B4-BE49-F238E27FC236}">
-                <a16:creationId xmlns:a16="http://schemas.microsoft.com/office/drawing/2014/main" id="{1AF1E29D-D8BA-4B50-A4A9-24A92B38537C}"/>
+                <a16:creationId xmlns:a16="http://schemas.microsoft.com/office/drawing/2014/main" id="{5F414821-35FB-4F2F-B7E7-5B2E3E0281AB}"/>
               </a:ext>
             </a:extLst>
           </p:cNvPr>
@@ -12732,7 +12732,7 @@
           <p:cNvPr id="3" name="">
             <a:extLst xmlns:a="http://schemas.openxmlformats.org/drawingml/2006/main">
               <a:ext uri="{FF2B5EF4-FFF2-40B4-BE49-F238E27FC236}">
-                <a16:creationId xmlns:a16="http://schemas.microsoft.com/office/drawing/2014/main" id="{3137FCAC-8C54-42C7-9BA1-48F6AE805B88}"/>
+                <a16:creationId xmlns:a16="http://schemas.microsoft.com/office/drawing/2014/main" id="{294DF5F1-85F2-4119-873D-F2F4436655E1}"/>
               </a:ext>
             </a:extLst>
           </p:cNvPr>
@@ -12796,7 +12796,7 @@
           <p:cNvPr id="4" name="">
             <a:extLst xmlns:a="http://schemas.openxmlformats.org/drawingml/2006/main">
               <a:ext uri="{FF2B5EF4-FFF2-40B4-BE49-F238E27FC236}">
-                <a16:creationId xmlns:a16="http://schemas.microsoft.com/office/drawing/2014/main" id="{A47DF452-8E42-4282-A021-515943AAD9DE}"/>
+                <a16:creationId xmlns:a16="http://schemas.microsoft.com/office/drawing/2014/main" id="{EC995CFC-DA41-45FC-A82B-8B10B9AFF625}"/>
               </a:ext>
             </a:extLst>
           </p:cNvPr>
@@ -12860,7 +12860,7 @@
           <p:cNvPr id="5" name="">
             <a:extLst xmlns:a="http://schemas.openxmlformats.org/drawingml/2006/main">
               <a:ext uri="{FF2B5EF4-FFF2-40B4-BE49-F238E27FC236}">
-                <a16:creationId xmlns:a16="http://schemas.microsoft.com/office/drawing/2014/main" id="{CBB8221A-4B98-4168-9CFB-3D49DFF159B6}"/>
+                <a16:creationId xmlns:a16="http://schemas.microsoft.com/office/drawing/2014/main" id="{5C05722D-75F6-4D39-83D6-A3EE7AD89C8E}"/>
               </a:ext>
             </a:extLst>
           </p:cNvPr>
@@ -12924,7 +12924,7 @@
           <p:cNvPr id="6" name="">
             <a:extLst xmlns:a="http://schemas.openxmlformats.org/drawingml/2006/main">
               <a:ext uri="{FF2B5EF4-FFF2-40B4-BE49-F238E27FC236}">
-                <a16:creationId xmlns:a16="http://schemas.microsoft.com/office/drawing/2014/main" id="{B9BB70C6-490F-4BE9-8A99-11F58C8BD5F1}"/>
+                <a16:creationId xmlns:a16="http://schemas.microsoft.com/office/drawing/2014/main" id="{565075AC-A646-42CC-A92E-FCA642448630}"/>
               </a:ext>
             </a:extLst>
           </p:cNvPr>
@@ -12988,7 +12988,7 @@
           <p:cNvPr id="7" name="">
             <a:extLst xmlns:a="http://schemas.openxmlformats.org/drawingml/2006/main">
               <a:ext uri="{FF2B5EF4-FFF2-40B4-BE49-F238E27FC236}">
-                <a16:creationId xmlns:a16="http://schemas.microsoft.com/office/drawing/2014/main" id="{CE0981C0-BB99-42ED-B1CC-E9BA69A3D057}"/>
+                <a16:creationId xmlns:a16="http://schemas.microsoft.com/office/drawing/2014/main" id="{2064462C-CA39-4075-9360-57BD9EAB3599}"/>
               </a:ext>
             </a:extLst>
           </p:cNvPr>
@@ -13021,7 +13021,7 @@
           <p:cNvPr id="8" name="">
             <a:extLst xmlns:a="http://schemas.openxmlformats.org/drawingml/2006/main">
               <a:ext uri="{FF2B5EF4-FFF2-40B4-BE49-F238E27FC236}">
-                <a16:creationId xmlns:a16="http://schemas.microsoft.com/office/drawing/2014/main" id="{A7B4DBB5-7B94-4258-AFFF-6075DA992B4D}"/>
+                <a16:creationId xmlns:a16="http://schemas.microsoft.com/office/drawing/2014/main" id="{89941974-11CA-4F56-9638-C1AEBB794418}"/>
               </a:ext>
             </a:extLst>
           </p:cNvPr>
@@ -13085,7 +13085,7 @@
           <p:cNvPr id="9" name="">
             <a:extLst xmlns:a="http://schemas.openxmlformats.org/drawingml/2006/main">
               <a:ext uri="{FF2B5EF4-FFF2-40B4-BE49-F238E27FC236}">
-                <a16:creationId xmlns:a16="http://schemas.microsoft.com/office/drawing/2014/main" id="{31614B12-0619-43AF-A413-66C37FDE9F70}"/>
+                <a16:creationId xmlns:a16="http://schemas.microsoft.com/office/drawing/2014/main" id="{CDEA0470-7089-43C1-8869-CAA9E238F695}"/>
               </a:ext>
             </a:extLst>
           </p:cNvPr>
@@ -13118,7 +13118,7 @@
           <p:cNvPr id="10" name="">
             <a:extLst xmlns:a="http://schemas.openxmlformats.org/drawingml/2006/main">
               <a:ext uri="{FF2B5EF4-FFF2-40B4-BE49-F238E27FC236}">
-                <a16:creationId xmlns:a16="http://schemas.microsoft.com/office/drawing/2014/main" id="{EFD2ADD8-161A-4B58-80E9-123CDA1E6412}"/>
+                <a16:creationId xmlns:a16="http://schemas.microsoft.com/office/drawing/2014/main" id="{E96DE9D7-65C3-4F77-BF54-3F33A8159A44}"/>
               </a:ext>
             </a:extLst>
           </p:cNvPr>
@@ -13182,7 +13182,7 @@
           <p:cNvPr id="11" name="">
             <a:extLst xmlns:a="http://schemas.openxmlformats.org/drawingml/2006/main">
               <a:ext uri="{FF2B5EF4-FFF2-40B4-BE49-F238E27FC236}">
-                <a16:creationId xmlns:a16="http://schemas.microsoft.com/office/drawing/2014/main" id="{F3E44566-A8B4-4167-958B-42BEF209667C}"/>
+                <a16:creationId xmlns:a16="http://schemas.microsoft.com/office/drawing/2014/main" id="{52C80E0D-3BA3-412B-9A02-267FC9552FB9}"/>
               </a:ext>
             </a:extLst>
           </p:cNvPr>
@@ -13215,7 +13215,7 @@
           <p:cNvPr id="12" name="">
             <a:extLst xmlns:a="http://schemas.openxmlformats.org/drawingml/2006/main">
               <a:ext uri="{FF2B5EF4-FFF2-40B4-BE49-F238E27FC236}">
-                <a16:creationId xmlns:a16="http://schemas.microsoft.com/office/drawing/2014/main" id="{087F0AD8-F564-491B-A618-79E46F0EBE32}"/>
+                <a16:creationId xmlns:a16="http://schemas.microsoft.com/office/drawing/2014/main" id="{7B7BA697-0C67-44DB-B308-2BD18D69E372}"/>
               </a:ext>
             </a:extLst>
           </p:cNvPr>
@@ -13279,7 +13279,7 @@
           <p:cNvPr id="13" name="">
             <a:extLst xmlns:a="http://schemas.openxmlformats.org/drawingml/2006/main">
               <a:ext uri="{FF2B5EF4-FFF2-40B4-BE49-F238E27FC236}">
-                <a16:creationId xmlns:a16="http://schemas.microsoft.com/office/drawing/2014/main" id="{C1D0A58E-EB74-4C54-8657-551FE082AB2B}"/>
+                <a16:creationId xmlns:a16="http://schemas.microsoft.com/office/drawing/2014/main" id="{6901D066-4C93-40BE-9E8C-FA0B5B44FCD4}"/>
               </a:ext>
             </a:extLst>
           </p:cNvPr>
@@ -13312,7 +13312,7 @@
           <p:cNvPr id="14" name="">
             <a:extLst xmlns:a="http://schemas.openxmlformats.org/drawingml/2006/main">
               <a:ext uri="{FF2B5EF4-FFF2-40B4-BE49-F238E27FC236}">
-                <a16:creationId xmlns:a16="http://schemas.microsoft.com/office/drawing/2014/main" id="{FFE810DF-EF60-4C19-A8E2-474E8619718D}"/>
+                <a16:creationId xmlns:a16="http://schemas.microsoft.com/office/drawing/2014/main" id="{C4CD1836-AFD2-433C-8857-B3F090D13B82}"/>
               </a:ext>
             </a:extLst>
           </p:cNvPr>
@@ -13376,7 +13376,7 @@
           <p:cNvPr id="15" name="">
             <a:extLst xmlns:a="http://schemas.openxmlformats.org/drawingml/2006/main">
               <a:ext uri="{FF2B5EF4-FFF2-40B4-BE49-F238E27FC236}">
-                <a16:creationId xmlns:a16="http://schemas.microsoft.com/office/drawing/2014/main" id="{C87A7337-C42A-46A2-B7B0-06A71B2F931E}"/>
+                <a16:creationId xmlns:a16="http://schemas.microsoft.com/office/drawing/2014/main" id="{DE729A2D-E996-4425-8F52-3BFE3A55C27D}"/>
               </a:ext>
             </a:extLst>
           </p:cNvPr>
@@ -13409,7 +13409,7 @@
           <p:cNvPr id="16" name="">
             <a:extLst xmlns:a="http://schemas.openxmlformats.org/drawingml/2006/main">
               <a:ext uri="{FF2B5EF4-FFF2-40B4-BE49-F238E27FC236}">
-                <a16:creationId xmlns:a16="http://schemas.microsoft.com/office/drawing/2014/main" id="{BD9F114B-A034-44CB-BE6C-F36E3756A728}"/>
+                <a16:creationId xmlns:a16="http://schemas.microsoft.com/office/drawing/2014/main" id="{DD0612B3-499E-4230-92EA-C8F8A0EC7943}"/>
               </a:ext>
             </a:extLst>
           </p:cNvPr>
@@ -13473,7 +13473,7 @@
           <p:cNvPr id="17" name="">
             <a:extLst xmlns:a="http://schemas.openxmlformats.org/drawingml/2006/main">
               <a:ext uri="{FF2B5EF4-FFF2-40B4-BE49-F238E27FC236}">
-                <a16:creationId xmlns:a16="http://schemas.microsoft.com/office/drawing/2014/main" id="{AFC1829D-D881-428A-99F6-C2626D62D4DD}"/>
+                <a16:creationId xmlns:a16="http://schemas.microsoft.com/office/drawing/2014/main" id="{AE45F82E-03AC-47B0-939F-C37B6457EF36}"/>
               </a:ext>
             </a:extLst>
           </p:cNvPr>
@@ -13506,7 +13506,7 @@
           <p:cNvPr id="18" name="">
             <a:extLst xmlns:a="http://schemas.openxmlformats.org/drawingml/2006/main">
               <a:ext uri="{FF2B5EF4-FFF2-40B4-BE49-F238E27FC236}">
-                <a16:creationId xmlns:a16="http://schemas.microsoft.com/office/drawing/2014/main" id="{5E93075F-863A-409D-9C4A-B9168954CBBC}"/>
+                <a16:creationId xmlns:a16="http://schemas.microsoft.com/office/drawing/2014/main" id="{34B8AE33-87CA-4426-9FF9-F3A63C9A45DA}"/>
               </a:ext>
             </a:extLst>
           </p:cNvPr>
@@ -13570,7 +13570,7 @@
           <p:cNvPr id="19" name="">
             <a:extLst xmlns:a="http://schemas.openxmlformats.org/drawingml/2006/main">
               <a:ext uri="{FF2B5EF4-FFF2-40B4-BE49-F238E27FC236}">
-                <a16:creationId xmlns:a16="http://schemas.microsoft.com/office/drawing/2014/main" id="{5C966658-8F3D-4938-A70F-E13C613BE03A}"/>
+                <a16:creationId xmlns:a16="http://schemas.microsoft.com/office/drawing/2014/main" id="{54C33BF0-71B0-4507-B10F-F1FF98EA3056}"/>
               </a:ext>
             </a:extLst>
           </p:cNvPr>
@@ -13603,7 +13603,7 @@
           <p:cNvPr id="20" name="">
             <a:extLst xmlns:a="http://schemas.openxmlformats.org/drawingml/2006/main">
               <a:ext uri="{FF2B5EF4-FFF2-40B4-BE49-F238E27FC236}">
-                <a16:creationId xmlns:a16="http://schemas.microsoft.com/office/drawing/2014/main" id="{B9816381-89AA-44FB-B98F-951C65B95984}"/>
+                <a16:creationId xmlns:a16="http://schemas.microsoft.com/office/drawing/2014/main" id="{2EEB8586-2AE1-4AE6-8F50-FD686AB452C3}"/>
               </a:ext>
             </a:extLst>
           </p:cNvPr>
@@ -13667,7 +13667,7 @@
           <p:cNvPr id="21" name="">
             <a:extLst xmlns:a="http://schemas.openxmlformats.org/drawingml/2006/main">
               <a:ext uri="{FF2B5EF4-FFF2-40B4-BE49-F238E27FC236}">
-                <a16:creationId xmlns:a16="http://schemas.microsoft.com/office/drawing/2014/main" id="{25257453-660D-4D21-915B-432214F4645A}"/>
+                <a16:creationId xmlns:a16="http://schemas.microsoft.com/office/drawing/2014/main" id="{B0A1DE3C-CB11-427C-B6DE-43AFDDD9DE54}"/>
               </a:ext>
             </a:extLst>
           </p:cNvPr>
@@ -13700,7 +13700,7 @@
           <p:cNvPr id="22" name="">
             <a:extLst xmlns:a="http://schemas.openxmlformats.org/drawingml/2006/main">
               <a:ext uri="{FF2B5EF4-FFF2-40B4-BE49-F238E27FC236}">
-                <a16:creationId xmlns:a16="http://schemas.microsoft.com/office/drawing/2014/main" id="{E74AA04D-2890-4E3A-8F23-CD9C85C38130}"/>
+                <a16:creationId xmlns:a16="http://schemas.microsoft.com/office/drawing/2014/main" id="{FC4EAACE-BDA6-4A2C-B153-090C7A794C9E}"/>
               </a:ext>
             </a:extLst>
           </p:cNvPr>
@@ -13764,7 +13764,7 @@
           <p:cNvPr id="23" name="">
             <a:extLst xmlns:a="http://schemas.openxmlformats.org/drawingml/2006/main">
               <a:ext uri="{FF2B5EF4-FFF2-40B4-BE49-F238E27FC236}">
-                <a16:creationId xmlns:a16="http://schemas.microsoft.com/office/drawing/2014/main" id="{B181E89F-B1E2-4957-9EB8-A5FCB9A08EAF}"/>
+                <a16:creationId xmlns:a16="http://schemas.microsoft.com/office/drawing/2014/main" id="{155C5267-0E6F-47EB-AD87-E33992F42DCC}"/>
               </a:ext>
             </a:extLst>
           </p:cNvPr>
@@ -13797,7 +13797,7 @@
           <p:cNvPr id="24" name="">
             <a:extLst xmlns:a="http://schemas.openxmlformats.org/drawingml/2006/main">
               <a:ext uri="{FF2B5EF4-FFF2-40B4-BE49-F238E27FC236}">
-                <a16:creationId xmlns:a16="http://schemas.microsoft.com/office/drawing/2014/main" id="{F43C0A9A-322A-495C-B3AF-1C3214F00617}"/>
+                <a16:creationId xmlns:a16="http://schemas.microsoft.com/office/drawing/2014/main" id="{43C4859E-57A5-4A68-875F-6A64F89CF166}"/>
               </a:ext>
             </a:extLst>
           </p:cNvPr>
@@ -13861,7 +13861,7 @@
           <p:cNvPr id="25" name="">
             <a:extLst xmlns:a="http://schemas.openxmlformats.org/drawingml/2006/main">
               <a:ext uri="{FF2B5EF4-FFF2-40B4-BE49-F238E27FC236}">
-                <a16:creationId xmlns:a16="http://schemas.microsoft.com/office/drawing/2014/main" id="{4BF728EE-471F-4F1F-AD52-4847E3D18AB5}"/>
+                <a16:creationId xmlns:a16="http://schemas.microsoft.com/office/drawing/2014/main" id="{6BF6F1A8-6500-4FFC-9A6F-4D55920DD527}"/>
               </a:ext>
             </a:extLst>
           </p:cNvPr>
@@ -13894,7 +13894,7 @@
           <p:cNvPr id="26" name="">
             <a:extLst xmlns:a="http://schemas.openxmlformats.org/drawingml/2006/main">
               <a:ext uri="{FF2B5EF4-FFF2-40B4-BE49-F238E27FC236}">
-                <a16:creationId xmlns:a16="http://schemas.microsoft.com/office/drawing/2014/main" id="{3D1C06F4-63BE-4D0D-98BB-229BA4A68F8D}"/>
+                <a16:creationId xmlns:a16="http://schemas.microsoft.com/office/drawing/2014/main" id="{B41288D1-2F57-4911-8845-676432946B5C}"/>
               </a:ext>
             </a:extLst>
           </p:cNvPr>
@@ -13958,7 +13958,7 @@
           <p:cNvPr id="27" name="">
             <a:extLst xmlns:a="http://schemas.openxmlformats.org/drawingml/2006/main">
               <a:ext uri="{FF2B5EF4-FFF2-40B4-BE49-F238E27FC236}">
-                <a16:creationId xmlns:a16="http://schemas.microsoft.com/office/drawing/2014/main" id="{54341DF6-EE41-4B3F-B109-BC3F48B8D1F5}"/>
+                <a16:creationId xmlns:a16="http://schemas.microsoft.com/office/drawing/2014/main" id="{F5D4E08D-09C8-438C-BDF4-46744B167109}"/>
               </a:ext>
             </a:extLst>
           </p:cNvPr>
@@ -14022,7 +14022,7 @@
           <p:cNvPr id="28" name="">
             <a:extLst xmlns:a="http://schemas.openxmlformats.org/drawingml/2006/main">
               <a:ext uri="{FF2B5EF4-FFF2-40B4-BE49-F238E27FC236}">
-                <a16:creationId xmlns:a16="http://schemas.microsoft.com/office/drawing/2014/main" id="{4C1380C5-4D58-4D01-8020-2B43DC651951}"/>
+                <a16:creationId xmlns:a16="http://schemas.microsoft.com/office/drawing/2014/main" id="{CA061248-9A38-4CCB-835C-6EF23A54F102}"/>
               </a:ext>
             </a:extLst>
           </p:cNvPr>
@@ -14086,7 +14086,7 @@
           <p:cNvPr id="29" name="">
             <a:extLst xmlns:a="http://schemas.openxmlformats.org/drawingml/2006/main">
               <a:ext uri="{FF2B5EF4-FFF2-40B4-BE49-F238E27FC236}">
-                <a16:creationId xmlns:a16="http://schemas.microsoft.com/office/drawing/2014/main" id="{BB46CA09-B841-4864-AB4C-A605C298377D}"/>
+                <a16:creationId xmlns:a16="http://schemas.microsoft.com/office/drawing/2014/main" id="{D386AE15-E05D-43AF-9B45-A43F5EB6C610}"/>
               </a:ext>
             </a:extLst>
           </p:cNvPr>
@@ -14150,7 +14150,7 @@
           <p:cNvPr id="30" name="">
             <a:extLst xmlns:a="http://schemas.openxmlformats.org/drawingml/2006/main">
               <a:ext uri="{FF2B5EF4-FFF2-40B4-BE49-F238E27FC236}">
-                <a16:creationId xmlns:a16="http://schemas.microsoft.com/office/drawing/2014/main" id="{86D4CC53-83CD-4004-8861-4460903959BE}"/>
+                <a16:creationId xmlns:a16="http://schemas.microsoft.com/office/drawing/2014/main" id="{327A034A-E0C2-48A3-B5BA-C2663824760B}"/>
               </a:ext>
             </a:extLst>
           </p:cNvPr>
@@ -14214,7 +14214,7 @@
           <p:cNvPr id="31" name="">
             <a:extLst xmlns:a="http://schemas.openxmlformats.org/drawingml/2006/main">
               <a:ext uri="{FF2B5EF4-FFF2-40B4-BE49-F238E27FC236}">
-                <a16:creationId xmlns:a16="http://schemas.microsoft.com/office/drawing/2014/main" id="{0D9D25E8-DCBD-4BE6-A854-B82E3D19F2DA}"/>
+                <a16:creationId xmlns:a16="http://schemas.microsoft.com/office/drawing/2014/main" id="{40DD17A1-5BDC-4AE1-BF3D-7E1BC4B052AD}"/>
               </a:ext>
             </a:extLst>
           </p:cNvPr>
@@ -14278,7 +14278,7 @@
           <p:cNvPr id="32" name="">
             <a:extLst xmlns:a="http://schemas.openxmlformats.org/drawingml/2006/main">
               <a:ext uri="{FF2B5EF4-FFF2-40B4-BE49-F238E27FC236}">
-                <a16:creationId xmlns:a16="http://schemas.microsoft.com/office/drawing/2014/main" id="{E0DEF402-5A06-426F-AAC2-BDE11641D72C}"/>
+                <a16:creationId xmlns:a16="http://schemas.microsoft.com/office/drawing/2014/main" id="{B7FDF91E-C314-42B6-A41A-99FD622C7077}"/>
               </a:ext>
             </a:extLst>
           </p:cNvPr>
@@ -14342,7 +14342,7 @@
           <p:cNvPr id="33" name="">
             <a:extLst xmlns:a="http://schemas.openxmlformats.org/drawingml/2006/main">
               <a:ext uri="{FF2B5EF4-FFF2-40B4-BE49-F238E27FC236}">
-                <a16:creationId xmlns:a16="http://schemas.microsoft.com/office/drawing/2014/main" id="{B4A92ECE-FCAD-4D9A-8B4F-480DE4F6AFA4}"/>
+                <a16:creationId xmlns:a16="http://schemas.microsoft.com/office/drawing/2014/main" id="{CE84D5ED-4A76-4F03-A04C-FFFB5721FE33}"/>
               </a:ext>
             </a:extLst>
           </p:cNvPr>
@@ -14406,7 +14406,7 @@
           <p:cNvPr id="34" name="">
             <a:extLst xmlns:a="http://schemas.openxmlformats.org/drawingml/2006/main">
               <a:ext uri="{FF2B5EF4-FFF2-40B4-BE49-F238E27FC236}">
-                <a16:creationId xmlns:a16="http://schemas.microsoft.com/office/drawing/2014/main" id="{70EAE132-E15F-4394-B8EA-18EAB2A51F7D}"/>
+                <a16:creationId xmlns:a16="http://schemas.microsoft.com/office/drawing/2014/main" id="{41B2A0EA-D1E5-43C8-89D4-6082C310FA47}"/>
               </a:ext>
             </a:extLst>
           </p:cNvPr>
@@ -14470,7 +14470,7 @@
           <p:cNvPr id="35" name="">
             <a:extLst xmlns:a="http://schemas.openxmlformats.org/drawingml/2006/main">
               <a:ext uri="{FF2B5EF4-FFF2-40B4-BE49-F238E27FC236}">
-                <a16:creationId xmlns:a16="http://schemas.microsoft.com/office/drawing/2014/main" id="{A52BA1E0-3895-4FD8-96BB-2F20F21ADBA5}"/>
+                <a16:creationId xmlns:a16="http://schemas.microsoft.com/office/drawing/2014/main" id="{EA49C83A-5D93-4852-9B48-A0C1D75B7A34}"/>
               </a:ext>
             </a:extLst>
           </p:cNvPr>
@@ -14534,7 +14534,7 @@
           <p:cNvPr id="36" name="">
             <a:extLst xmlns:a="http://schemas.openxmlformats.org/drawingml/2006/main">
               <a:ext uri="{FF2B5EF4-FFF2-40B4-BE49-F238E27FC236}">
-                <a16:creationId xmlns:a16="http://schemas.microsoft.com/office/drawing/2014/main" id="{55A911AD-E81E-41A8-BFCB-1C15AB1929D7}"/>
+                <a16:creationId xmlns:a16="http://schemas.microsoft.com/office/drawing/2014/main" id="{A176A7CB-145B-4B92-8E33-3F8BA2E33810}"/>
               </a:ext>
             </a:extLst>
           </p:cNvPr>
@@ -14598,7 +14598,7 @@
           <p:cNvPr id="37" name="">
             <a:extLst xmlns:a="http://schemas.openxmlformats.org/drawingml/2006/main">
               <a:ext uri="{FF2B5EF4-FFF2-40B4-BE49-F238E27FC236}">
-                <a16:creationId xmlns:a16="http://schemas.microsoft.com/office/drawing/2014/main" id="{5D0687AF-C2B2-416B-AA73-A37532089355}"/>
+                <a16:creationId xmlns:a16="http://schemas.microsoft.com/office/drawing/2014/main" id="{B4CF0A45-C52D-4C8B-9EF8-330C310C54B2}"/>
               </a:ext>
             </a:extLst>
           </p:cNvPr>
@@ -14662,7 +14662,7 @@
           <p:cNvPr id="38" name="">
             <a:extLst xmlns:a="http://schemas.openxmlformats.org/drawingml/2006/main">
               <a:ext uri="{FF2B5EF4-FFF2-40B4-BE49-F238E27FC236}">
-                <a16:creationId xmlns:a16="http://schemas.microsoft.com/office/drawing/2014/main" id="{7A7ADB55-7ABD-40AD-92D7-96A198DF66DB}"/>
+                <a16:creationId xmlns:a16="http://schemas.microsoft.com/office/drawing/2014/main" id="{D524AF0F-C376-42D8-821E-A2CD7C485A3F}"/>
               </a:ext>
             </a:extLst>
           </p:cNvPr>
@@ -14724,7 +14724,7 @@
     </p:spTree>
     <p:extLst>
       <p:ext uri="{BB962C8B-B14F-4D97-AF65-F5344CB8AC3E}">
-        <p14:creationId xmlns:p14="http://schemas.microsoft.com/office/powerpoint/2010/main" val="1672405468"/>
+        <p14:creationId xmlns:p14="http://schemas.microsoft.com/office/powerpoint/2010/main" val="1652605242"/>
       </p:ext>
     </p:extLst>
   </p:cSld>
@@ -14748,7 +14748,7 @@
           <p:cNvPr id="1" name="">
             <a:extLst xmlns:a="http://schemas.openxmlformats.org/drawingml/2006/main">
               <a:ext uri="{FF2B5EF4-FFF2-40B4-BE49-F238E27FC236}">
-                <a16:creationId xmlns:a16="http://schemas.microsoft.com/office/drawing/2014/main" id="{28BE2F2B-2FC0-4D7C-89D7-F9F7C5E51370}"/>
+                <a16:creationId xmlns:a16="http://schemas.microsoft.com/office/drawing/2014/main" id="{09CCCD1C-9F95-45CD-A9C7-F2E4048CE12C}"/>
               </a:ext>
             </a:extLst>
           </p:cNvPr>
@@ -14783,7 +14783,7 @@
           <p:cNvPr id="2" name="">
             <a:extLst xmlns:a="http://schemas.openxmlformats.org/drawingml/2006/main">
               <a:ext uri="{FF2B5EF4-FFF2-40B4-BE49-F238E27FC236}">
-                <a16:creationId xmlns:a16="http://schemas.microsoft.com/office/drawing/2014/main" id="{45E2436A-6E97-446D-A0A7-EBD4C0CCCB54}"/>
+                <a16:creationId xmlns:a16="http://schemas.microsoft.com/office/drawing/2014/main" id="{EF5F658B-D9FD-44E3-9831-843FA63825B3}"/>
               </a:ext>
             </a:extLst>
           </p:cNvPr>
@@ -14818,7 +14818,7 @@
           <p:cNvPr id="3" name="">
             <a:extLst xmlns:a="http://schemas.openxmlformats.org/drawingml/2006/main">
               <a:ext uri="{FF2B5EF4-FFF2-40B4-BE49-F238E27FC236}">
-                <a16:creationId xmlns:a16="http://schemas.microsoft.com/office/drawing/2014/main" id="{2BBE2599-60C0-4B23-AD4F-2270E49F3FB7}"/>
+                <a16:creationId xmlns:a16="http://schemas.microsoft.com/office/drawing/2014/main" id="{D1616C46-A678-4744-BBE2-F1C4B9D1E01A}"/>
               </a:ext>
             </a:extLst>
           </p:cNvPr>
@@ -14882,7 +14882,7 @@
           <p:cNvPr id="4" name="">
             <a:extLst xmlns:a="http://schemas.openxmlformats.org/drawingml/2006/main">
               <a:ext uri="{FF2B5EF4-FFF2-40B4-BE49-F238E27FC236}">
-                <a16:creationId xmlns:a16="http://schemas.microsoft.com/office/drawing/2014/main" id="{ED74C32A-217A-4A59-9C11-D53AE3C5AE25}"/>
+                <a16:creationId xmlns:a16="http://schemas.microsoft.com/office/drawing/2014/main" id="{7E8DAFF4-2A6F-495A-8BD8-244A1AB02AF2}"/>
               </a:ext>
             </a:extLst>
           </p:cNvPr>
@@ -14946,7 +14946,7 @@
           <p:cNvPr id="5" name="">
             <a:extLst xmlns:a="http://schemas.openxmlformats.org/drawingml/2006/main">
               <a:ext uri="{FF2B5EF4-FFF2-40B4-BE49-F238E27FC236}">
-                <a16:creationId xmlns:a16="http://schemas.microsoft.com/office/drawing/2014/main" id="{6045C994-8C43-4829-8F65-023656021BCC}"/>
+                <a16:creationId xmlns:a16="http://schemas.microsoft.com/office/drawing/2014/main" id="{BB286FDD-064B-4C23-81D0-FF8D3ED94BB3}"/>
               </a:ext>
             </a:extLst>
           </p:cNvPr>
@@ -15010,7 +15010,7 @@
           <p:cNvPr id="6" name="">
             <a:extLst xmlns:a="http://schemas.openxmlformats.org/drawingml/2006/main">
               <a:ext uri="{FF2B5EF4-FFF2-40B4-BE49-F238E27FC236}">
-                <a16:creationId xmlns:a16="http://schemas.microsoft.com/office/drawing/2014/main" id="{F62647B0-A5BB-435A-9A0C-9A8CA4B17550}"/>
+                <a16:creationId xmlns:a16="http://schemas.microsoft.com/office/drawing/2014/main" id="{3B5D99F8-E3B4-42EC-B988-88D524F059B5}"/>
               </a:ext>
             </a:extLst>
           </p:cNvPr>
@@ -15074,7 +15074,7 @@
           <p:cNvPr id="7" name="">
             <a:extLst xmlns:a="http://schemas.openxmlformats.org/drawingml/2006/main">
               <a:ext uri="{FF2B5EF4-FFF2-40B4-BE49-F238E27FC236}">
-                <a16:creationId xmlns:a16="http://schemas.microsoft.com/office/drawing/2014/main" id="{9E35BEBA-7389-45B0-B1F6-5B13CDA5A7A3}"/>
+                <a16:creationId xmlns:a16="http://schemas.microsoft.com/office/drawing/2014/main" id="{54323322-F069-453F-A2A9-DCF42437C043}"/>
               </a:ext>
             </a:extLst>
           </p:cNvPr>
@@ -15107,7 +15107,7 @@
           <p:cNvPr id="8" name="">
             <a:extLst xmlns:a="http://schemas.openxmlformats.org/drawingml/2006/main">
               <a:ext uri="{FF2B5EF4-FFF2-40B4-BE49-F238E27FC236}">
-                <a16:creationId xmlns:a16="http://schemas.microsoft.com/office/drawing/2014/main" id="{8893877C-3E12-4F3A-B588-FA6B9043E0D9}"/>
+                <a16:creationId xmlns:a16="http://schemas.microsoft.com/office/drawing/2014/main" id="{30D0C8E1-AEED-4A5F-91AB-5E2026EA9BB6}"/>
               </a:ext>
             </a:extLst>
           </p:cNvPr>
@@ -15142,7 +15142,7 @@
           <p:cNvPr id="9" name="">
             <a:extLst xmlns:a="http://schemas.openxmlformats.org/drawingml/2006/main">
               <a:ext uri="{FF2B5EF4-FFF2-40B4-BE49-F238E27FC236}">
-                <a16:creationId xmlns:a16="http://schemas.microsoft.com/office/drawing/2014/main" id="{32478819-AD69-4B84-B9A4-8D9F5DF44C40}"/>
+                <a16:creationId xmlns:a16="http://schemas.microsoft.com/office/drawing/2014/main" id="{0E3C3C01-326D-4A79-8D35-FBA46FE46FA1}"/>
               </a:ext>
             </a:extLst>
           </p:cNvPr>
@@ -15206,7 +15206,7 @@
           <p:cNvPr id="10" name="">
             <a:extLst xmlns:a="http://schemas.openxmlformats.org/drawingml/2006/main">
               <a:ext uri="{FF2B5EF4-FFF2-40B4-BE49-F238E27FC236}">
-                <a16:creationId xmlns:a16="http://schemas.microsoft.com/office/drawing/2014/main" id="{31B8CDED-9BD7-4897-8908-49F19697BA46}"/>
+                <a16:creationId xmlns:a16="http://schemas.microsoft.com/office/drawing/2014/main" id="{002B80F1-972B-4D45-98DE-B1D0BDFD73C1}"/>
               </a:ext>
             </a:extLst>
           </p:cNvPr>
@@ -15241,7 +15241,7 @@
           <p:cNvPr id="11" name="">
             <a:extLst xmlns:a="http://schemas.openxmlformats.org/drawingml/2006/main">
               <a:ext uri="{FF2B5EF4-FFF2-40B4-BE49-F238E27FC236}">
-                <a16:creationId xmlns:a16="http://schemas.microsoft.com/office/drawing/2014/main" id="{F00C5990-665C-429E-80BA-BF0B223E41AF}"/>
+                <a16:creationId xmlns:a16="http://schemas.microsoft.com/office/drawing/2014/main" id="{5F95918E-661E-4DC1-BC30-0FFCCACE6E79}"/>
               </a:ext>
             </a:extLst>
           </p:cNvPr>
@@ -15305,7 +15305,7 @@
           <p:cNvPr id="12" name="">
             <a:extLst xmlns:a="http://schemas.openxmlformats.org/drawingml/2006/main">
               <a:ext uri="{FF2B5EF4-FFF2-40B4-BE49-F238E27FC236}">
-                <a16:creationId xmlns:a16="http://schemas.microsoft.com/office/drawing/2014/main" id="{BA2DDB3D-694C-40C5-B15D-887C996ABFBB}"/>
+                <a16:creationId xmlns:a16="http://schemas.microsoft.com/office/drawing/2014/main" id="{3E1E991D-3776-4753-8A1E-F90255B13FA5}"/>
               </a:ext>
             </a:extLst>
           </p:cNvPr>
@@ -15340,7 +15340,7 @@
           <p:cNvPr id="13" name="">
             <a:extLst xmlns:a="http://schemas.openxmlformats.org/drawingml/2006/main">
               <a:ext uri="{FF2B5EF4-FFF2-40B4-BE49-F238E27FC236}">
-                <a16:creationId xmlns:a16="http://schemas.microsoft.com/office/drawing/2014/main" id="{F4F2C547-B1A6-47D7-B280-E27BA9FCCFD0}"/>
+                <a16:creationId xmlns:a16="http://schemas.microsoft.com/office/drawing/2014/main" id="{49FC7DAE-02E5-43DA-ADF6-0EDDB2E54395}"/>
               </a:ext>
             </a:extLst>
           </p:cNvPr>
@@ -15404,7 +15404,7 @@
           <p:cNvPr id="14" name="">
             <a:extLst xmlns:a="http://schemas.openxmlformats.org/drawingml/2006/main">
               <a:ext uri="{FF2B5EF4-FFF2-40B4-BE49-F238E27FC236}">
-                <a16:creationId xmlns:a16="http://schemas.microsoft.com/office/drawing/2014/main" id="{8BD719A0-B953-47E8-9234-422BF48BC27A}"/>
+                <a16:creationId xmlns:a16="http://schemas.microsoft.com/office/drawing/2014/main" id="{91BFB016-3E8C-4DDB-BB5F-A6BFF3DE8225}"/>
               </a:ext>
             </a:extLst>
           </p:cNvPr>
@@ -15439,7 +15439,7 @@
           <p:cNvPr id="15" name="">
             <a:extLst xmlns:a="http://schemas.openxmlformats.org/drawingml/2006/main">
               <a:ext uri="{FF2B5EF4-FFF2-40B4-BE49-F238E27FC236}">
-                <a16:creationId xmlns:a16="http://schemas.microsoft.com/office/drawing/2014/main" id="{F871BCE1-8F20-42E6-859D-A0650A6FB747}"/>
+                <a16:creationId xmlns:a16="http://schemas.microsoft.com/office/drawing/2014/main" id="{6F75CA49-B22B-421F-96AF-E274168878B2}"/>
               </a:ext>
             </a:extLst>
           </p:cNvPr>
@@ -15503,7 +15503,7 @@
           <p:cNvPr id="16" name="">
             <a:extLst xmlns:a="http://schemas.openxmlformats.org/drawingml/2006/main">
               <a:ext uri="{FF2B5EF4-FFF2-40B4-BE49-F238E27FC236}">
-                <a16:creationId xmlns:a16="http://schemas.microsoft.com/office/drawing/2014/main" id="{8BFDF3D0-4256-4794-8024-F936254A1B91}"/>
+                <a16:creationId xmlns:a16="http://schemas.microsoft.com/office/drawing/2014/main" id="{26D89BF6-49CA-43ED-A23D-65285D49F4A3}"/>
               </a:ext>
             </a:extLst>
           </p:cNvPr>
@@ -15538,7 +15538,7 @@
           <p:cNvPr id="17" name="">
             <a:extLst xmlns:a="http://schemas.openxmlformats.org/drawingml/2006/main">
               <a:ext uri="{FF2B5EF4-FFF2-40B4-BE49-F238E27FC236}">
-                <a16:creationId xmlns:a16="http://schemas.microsoft.com/office/drawing/2014/main" id="{AD1C4876-18D2-4AB2-8823-931DB8EB591C}"/>
+                <a16:creationId xmlns:a16="http://schemas.microsoft.com/office/drawing/2014/main" id="{CB45475F-2616-403E-94D6-F06D740F2426}"/>
               </a:ext>
             </a:extLst>
           </p:cNvPr>
@@ -15602,7 +15602,7 @@
           <p:cNvPr id="18" name="">
             <a:extLst xmlns:a="http://schemas.openxmlformats.org/drawingml/2006/main">
               <a:ext uri="{FF2B5EF4-FFF2-40B4-BE49-F238E27FC236}">
-                <a16:creationId xmlns:a16="http://schemas.microsoft.com/office/drawing/2014/main" id="{EE0C450D-5774-425A-9E86-8905D6BE7159}"/>
+                <a16:creationId xmlns:a16="http://schemas.microsoft.com/office/drawing/2014/main" id="{8939DB24-F328-401B-9EFA-7D0EB5CB515D}"/>
               </a:ext>
             </a:extLst>
           </p:cNvPr>
@@ -15635,7 +15635,7 @@
           <p:cNvPr id="19" name="">
             <a:extLst xmlns:a="http://schemas.openxmlformats.org/drawingml/2006/main">
               <a:ext uri="{FF2B5EF4-FFF2-40B4-BE49-F238E27FC236}">
-                <a16:creationId xmlns:a16="http://schemas.microsoft.com/office/drawing/2014/main" id="{B647E81F-906F-4C6E-AF98-3C190A63CD3C}"/>
+                <a16:creationId xmlns:a16="http://schemas.microsoft.com/office/drawing/2014/main" id="{934C9C7E-B4F3-4F51-8EDE-1D120805AD38}"/>
               </a:ext>
             </a:extLst>
           </p:cNvPr>
@@ -15670,7 +15670,7 @@
           <p:cNvPr id="20" name="">
             <a:extLst xmlns:a="http://schemas.openxmlformats.org/drawingml/2006/main">
               <a:ext uri="{FF2B5EF4-FFF2-40B4-BE49-F238E27FC236}">
-                <a16:creationId xmlns:a16="http://schemas.microsoft.com/office/drawing/2014/main" id="{E483B69A-8895-4C02-8447-5C20607F2C3A}"/>
+                <a16:creationId xmlns:a16="http://schemas.microsoft.com/office/drawing/2014/main" id="{CCAC7A63-D486-4F38-B7D3-7BB88F43D1A8}"/>
               </a:ext>
             </a:extLst>
           </p:cNvPr>
@@ -15734,7 +15734,7 @@
           <p:cNvPr id="21" name="">
             <a:extLst xmlns:a="http://schemas.openxmlformats.org/drawingml/2006/main">
               <a:ext uri="{FF2B5EF4-FFF2-40B4-BE49-F238E27FC236}">
-                <a16:creationId xmlns:a16="http://schemas.microsoft.com/office/drawing/2014/main" id="{9C462035-4755-4BD7-A805-6C2641CF6893}"/>
+                <a16:creationId xmlns:a16="http://schemas.microsoft.com/office/drawing/2014/main" id="{E297A74A-080D-4EC1-A816-8D69A687E2B4}"/>
               </a:ext>
             </a:extLst>
           </p:cNvPr>
@@ -15769,7 +15769,7 @@
           <p:cNvPr id="22" name="">
             <a:extLst xmlns:a="http://schemas.openxmlformats.org/drawingml/2006/main">
               <a:ext uri="{FF2B5EF4-FFF2-40B4-BE49-F238E27FC236}">
-                <a16:creationId xmlns:a16="http://schemas.microsoft.com/office/drawing/2014/main" id="{43C78B9E-F124-4523-87D0-50B856E8758F}"/>
+                <a16:creationId xmlns:a16="http://schemas.microsoft.com/office/drawing/2014/main" id="{D96EEA46-9022-4F8D-8184-B8B7137CC6E4}"/>
               </a:ext>
             </a:extLst>
           </p:cNvPr>
@@ -15833,7 +15833,7 @@
           <p:cNvPr id="23" name="">
             <a:extLst xmlns:a="http://schemas.openxmlformats.org/drawingml/2006/main">
               <a:ext uri="{FF2B5EF4-FFF2-40B4-BE49-F238E27FC236}">
-                <a16:creationId xmlns:a16="http://schemas.microsoft.com/office/drawing/2014/main" id="{0DC5DF69-C406-4085-82BF-68DB0DF1E826}"/>
+                <a16:creationId xmlns:a16="http://schemas.microsoft.com/office/drawing/2014/main" id="{773A065B-07E9-4C33-AA48-CEED9AC29DE2}"/>
               </a:ext>
             </a:extLst>
           </p:cNvPr>
@@ -15868,7 +15868,7 @@
           <p:cNvPr id="24" name="">
             <a:extLst xmlns:a="http://schemas.openxmlformats.org/drawingml/2006/main">
               <a:ext uri="{FF2B5EF4-FFF2-40B4-BE49-F238E27FC236}">
-                <a16:creationId xmlns:a16="http://schemas.microsoft.com/office/drawing/2014/main" id="{45743C5F-8E07-45AC-BF1E-1F3742A15894}"/>
+                <a16:creationId xmlns:a16="http://schemas.microsoft.com/office/drawing/2014/main" id="{5531E0D4-264D-46E7-B7A8-564EB1890F01}"/>
               </a:ext>
             </a:extLst>
           </p:cNvPr>
@@ -15932,7 +15932,7 @@
           <p:cNvPr id="25" name="">
             <a:extLst xmlns:a="http://schemas.openxmlformats.org/drawingml/2006/main">
               <a:ext uri="{FF2B5EF4-FFF2-40B4-BE49-F238E27FC236}">
-                <a16:creationId xmlns:a16="http://schemas.microsoft.com/office/drawing/2014/main" id="{E265491E-B993-49F4-9E37-546EF83D6E9A}"/>
+                <a16:creationId xmlns:a16="http://schemas.microsoft.com/office/drawing/2014/main" id="{B19CB776-191D-4A0F-B0E5-656683B50351}"/>
               </a:ext>
             </a:extLst>
           </p:cNvPr>
@@ -15967,7 +15967,7 @@
           <p:cNvPr id="26" name="">
             <a:extLst xmlns:a="http://schemas.openxmlformats.org/drawingml/2006/main">
               <a:ext uri="{FF2B5EF4-FFF2-40B4-BE49-F238E27FC236}">
-                <a16:creationId xmlns:a16="http://schemas.microsoft.com/office/drawing/2014/main" id="{0E0220DE-FAE1-4117-B53A-77FFD07A4CE4}"/>
+                <a16:creationId xmlns:a16="http://schemas.microsoft.com/office/drawing/2014/main" id="{940BD19F-1E99-4E60-8A70-5550D80CF045}"/>
               </a:ext>
             </a:extLst>
           </p:cNvPr>
@@ -16031,7 +16031,7 @@
           <p:cNvPr id="27" name="">
             <a:extLst xmlns:a="http://schemas.openxmlformats.org/drawingml/2006/main">
               <a:ext uri="{FF2B5EF4-FFF2-40B4-BE49-F238E27FC236}">
-                <a16:creationId xmlns:a16="http://schemas.microsoft.com/office/drawing/2014/main" id="{BDAD42A0-5BDC-48F5-BF1E-429F53B4CEEC}"/>
+                <a16:creationId xmlns:a16="http://schemas.microsoft.com/office/drawing/2014/main" id="{879DC6AB-70A4-49EC-98EA-B7DC152DA32E}"/>
               </a:ext>
             </a:extLst>
           </p:cNvPr>
@@ -16066,7 +16066,7 @@
           <p:cNvPr id="28" name="">
             <a:extLst xmlns:a="http://schemas.openxmlformats.org/drawingml/2006/main">
               <a:ext uri="{FF2B5EF4-FFF2-40B4-BE49-F238E27FC236}">
-                <a16:creationId xmlns:a16="http://schemas.microsoft.com/office/drawing/2014/main" id="{FC68F9AF-08F1-49C4-A4B6-AF81B767ED65}"/>
+                <a16:creationId xmlns:a16="http://schemas.microsoft.com/office/drawing/2014/main" id="{96B8D766-5019-4DCD-991F-5DB102C0F677}"/>
               </a:ext>
             </a:extLst>
           </p:cNvPr>
@@ -16130,7 +16130,7 @@
           <p:cNvPr id="29" name="">
             <a:extLst xmlns:a="http://schemas.openxmlformats.org/drawingml/2006/main">
               <a:ext uri="{FF2B5EF4-FFF2-40B4-BE49-F238E27FC236}">
-                <a16:creationId xmlns:a16="http://schemas.microsoft.com/office/drawing/2014/main" id="{DD866266-C7D5-4B45-8212-6F7E3852B35F}"/>
+                <a16:creationId xmlns:a16="http://schemas.microsoft.com/office/drawing/2014/main" id="{3F86C26C-8CAB-4178-A197-E07BF879ED5B}"/>
               </a:ext>
             </a:extLst>
           </p:cNvPr>
@@ -16163,7 +16163,7 @@
           <p:cNvPr id="30" name="">
             <a:extLst xmlns:a="http://schemas.openxmlformats.org/drawingml/2006/main">
               <a:ext uri="{FF2B5EF4-FFF2-40B4-BE49-F238E27FC236}">
-                <a16:creationId xmlns:a16="http://schemas.microsoft.com/office/drawing/2014/main" id="{F238069B-489A-4A51-92BF-14F2CFA47A37}"/>
+                <a16:creationId xmlns:a16="http://schemas.microsoft.com/office/drawing/2014/main" id="{988B8F7A-797F-4BE5-A98E-5102FBA88185}"/>
               </a:ext>
             </a:extLst>
           </p:cNvPr>
@@ -16198,7 +16198,7 @@
           <p:cNvPr id="31" name="">
             <a:extLst xmlns:a="http://schemas.openxmlformats.org/drawingml/2006/main">
               <a:ext uri="{FF2B5EF4-FFF2-40B4-BE49-F238E27FC236}">
-                <a16:creationId xmlns:a16="http://schemas.microsoft.com/office/drawing/2014/main" id="{8A6E2968-65CD-4F72-AE0A-FD0F8A887AB9}"/>
+                <a16:creationId xmlns:a16="http://schemas.microsoft.com/office/drawing/2014/main" id="{E60CDBC4-D3B6-485C-BA4F-2F79699FD953}"/>
               </a:ext>
             </a:extLst>
           </p:cNvPr>
@@ -16262,7 +16262,7 @@
           <p:cNvPr id="32" name="">
             <a:extLst xmlns:a="http://schemas.openxmlformats.org/drawingml/2006/main">
               <a:ext uri="{FF2B5EF4-FFF2-40B4-BE49-F238E27FC236}">
-                <a16:creationId xmlns:a16="http://schemas.microsoft.com/office/drawing/2014/main" id="{0FB8B0AF-55E7-4E95-8EE6-3B3A7B08A0DC}"/>
+                <a16:creationId xmlns:a16="http://schemas.microsoft.com/office/drawing/2014/main" id="{319C8B15-E6ED-4572-88D9-F30995BCEB5D}"/>
               </a:ext>
             </a:extLst>
           </p:cNvPr>
@@ -16297,7 +16297,7 @@
           <p:cNvPr id="33" name="">
             <a:extLst xmlns:a="http://schemas.openxmlformats.org/drawingml/2006/main">
               <a:ext uri="{FF2B5EF4-FFF2-40B4-BE49-F238E27FC236}">
-                <a16:creationId xmlns:a16="http://schemas.microsoft.com/office/drawing/2014/main" id="{0F3A4FAF-2518-4385-BA70-6D7B3F6717DB}"/>
+                <a16:creationId xmlns:a16="http://schemas.microsoft.com/office/drawing/2014/main" id="{0DF6785B-766A-4DC2-B715-D035A08F3930}"/>
               </a:ext>
             </a:extLst>
           </p:cNvPr>
@@ -16361,7 +16361,7 @@
           <p:cNvPr id="34" name="">
             <a:extLst xmlns:a="http://schemas.openxmlformats.org/drawingml/2006/main">
               <a:ext uri="{FF2B5EF4-FFF2-40B4-BE49-F238E27FC236}">
-                <a16:creationId xmlns:a16="http://schemas.microsoft.com/office/drawing/2014/main" id="{9EC8516A-E72F-4624-9C42-8E39DADFEA16}"/>
+                <a16:creationId xmlns:a16="http://schemas.microsoft.com/office/drawing/2014/main" id="{B3FBCE58-B657-4594-9EA0-A9F65888C586}"/>
               </a:ext>
             </a:extLst>
           </p:cNvPr>
@@ -16396,7 +16396,7 @@
           <p:cNvPr id="35" name="">
             <a:extLst xmlns:a="http://schemas.openxmlformats.org/drawingml/2006/main">
               <a:ext uri="{FF2B5EF4-FFF2-40B4-BE49-F238E27FC236}">
-                <a16:creationId xmlns:a16="http://schemas.microsoft.com/office/drawing/2014/main" id="{CA71B191-29D8-4B01-BE58-BB006D57015B}"/>
+                <a16:creationId xmlns:a16="http://schemas.microsoft.com/office/drawing/2014/main" id="{C56DDB17-2911-45CF-9CB6-37C0A21F3BE0}"/>
               </a:ext>
             </a:extLst>
           </p:cNvPr>
@@ -16460,7 +16460,7 @@
           <p:cNvPr id="36" name="">
             <a:extLst xmlns:a="http://schemas.openxmlformats.org/drawingml/2006/main">
               <a:ext uri="{FF2B5EF4-FFF2-40B4-BE49-F238E27FC236}">
-                <a16:creationId xmlns:a16="http://schemas.microsoft.com/office/drawing/2014/main" id="{E882831B-E53C-4E02-AA27-E0906197FBB2}"/>
+                <a16:creationId xmlns:a16="http://schemas.microsoft.com/office/drawing/2014/main" id="{9F69227F-E7CD-49DD-934A-D7C338DB1672}"/>
               </a:ext>
             </a:extLst>
           </p:cNvPr>
@@ -16495,7 +16495,7 @@
           <p:cNvPr id="37" name="">
             <a:extLst xmlns:a="http://schemas.openxmlformats.org/drawingml/2006/main">
               <a:ext uri="{FF2B5EF4-FFF2-40B4-BE49-F238E27FC236}">
-                <a16:creationId xmlns:a16="http://schemas.microsoft.com/office/drawing/2014/main" id="{5ADCF9C7-DDBF-47FB-AE80-C1C90F687831}"/>
+                <a16:creationId xmlns:a16="http://schemas.microsoft.com/office/drawing/2014/main" id="{D7C7EE58-B9E4-422F-8A9F-F2F6094EC0A4}"/>
               </a:ext>
             </a:extLst>
           </p:cNvPr>
@@ -16559,7 +16559,7 @@
           <p:cNvPr id="38" name="">
             <a:extLst xmlns:a="http://schemas.openxmlformats.org/drawingml/2006/main">
               <a:ext uri="{FF2B5EF4-FFF2-40B4-BE49-F238E27FC236}">
-                <a16:creationId xmlns:a16="http://schemas.microsoft.com/office/drawing/2014/main" id="{27CC6809-0195-4D92-AA03-CC60F1CCD378}"/>
+                <a16:creationId xmlns:a16="http://schemas.microsoft.com/office/drawing/2014/main" id="{46D330D3-C941-49D0-9E34-AD4C7DEEE2AF}"/>
               </a:ext>
             </a:extLst>
           </p:cNvPr>
@@ -16594,7 +16594,7 @@
           <p:cNvPr id="39" name="">
             <a:extLst xmlns:a="http://schemas.openxmlformats.org/drawingml/2006/main">
               <a:ext uri="{FF2B5EF4-FFF2-40B4-BE49-F238E27FC236}">
-                <a16:creationId xmlns:a16="http://schemas.microsoft.com/office/drawing/2014/main" id="{13039588-8AC7-429F-80A4-E003114413D4}"/>
+                <a16:creationId xmlns:a16="http://schemas.microsoft.com/office/drawing/2014/main" id="{0E175FC8-DEE1-4C08-97FC-9610EFFD5566}"/>
               </a:ext>
             </a:extLst>
           </p:cNvPr>
@@ -16658,7 +16658,7 @@
           <p:cNvPr id="40" name="">
             <a:extLst xmlns:a="http://schemas.openxmlformats.org/drawingml/2006/main">
               <a:ext uri="{FF2B5EF4-FFF2-40B4-BE49-F238E27FC236}">
-                <a16:creationId xmlns:a16="http://schemas.microsoft.com/office/drawing/2014/main" id="{9E7FA1B8-0150-4BF5-B350-B7F73A083F41}"/>
+                <a16:creationId xmlns:a16="http://schemas.microsoft.com/office/drawing/2014/main" id="{8EE26864-EEFD-4A7F-B465-A8022E0E3ADC}"/>
               </a:ext>
             </a:extLst>
           </p:cNvPr>
@@ -16691,7 +16691,7 @@
           <p:cNvPr id="41" name="">
             <a:extLst xmlns:a="http://schemas.openxmlformats.org/drawingml/2006/main">
               <a:ext uri="{FF2B5EF4-FFF2-40B4-BE49-F238E27FC236}">
-                <a16:creationId xmlns:a16="http://schemas.microsoft.com/office/drawing/2014/main" id="{8111F711-4C1E-466F-926A-B80FC5F101B8}"/>
+                <a16:creationId xmlns:a16="http://schemas.microsoft.com/office/drawing/2014/main" id="{7B3B495C-6402-4E61-913D-F1047DF317AA}"/>
               </a:ext>
             </a:extLst>
           </p:cNvPr>
@@ -16726,7 +16726,7 @@
           <p:cNvPr id="42" name="">
             <a:extLst xmlns:a="http://schemas.openxmlformats.org/drawingml/2006/main">
               <a:ext uri="{FF2B5EF4-FFF2-40B4-BE49-F238E27FC236}">
-                <a16:creationId xmlns:a16="http://schemas.microsoft.com/office/drawing/2014/main" id="{0E1DD3FB-49D8-45CA-BC65-683F618D1FF3}"/>
+                <a16:creationId xmlns:a16="http://schemas.microsoft.com/office/drawing/2014/main" id="{B1A98A19-8D86-460F-98D4-F2A3A53E531C}"/>
               </a:ext>
             </a:extLst>
           </p:cNvPr>
@@ -16790,7 +16790,7 @@
           <p:cNvPr id="43" name="">
             <a:extLst xmlns:a="http://schemas.openxmlformats.org/drawingml/2006/main">
               <a:ext uri="{FF2B5EF4-FFF2-40B4-BE49-F238E27FC236}">
-                <a16:creationId xmlns:a16="http://schemas.microsoft.com/office/drawing/2014/main" id="{96725586-931A-46D3-B4D9-8ABA43898428}"/>
+                <a16:creationId xmlns:a16="http://schemas.microsoft.com/office/drawing/2014/main" id="{4F55F63A-78CA-4847-A68E-DA4784F8CA1B}"/>
               </a:ext>
             </a:extLst>
           </p:cNvPr>
@@ -16825,7 +16825,7 @@
           <p:cNvPr id="44" name="">
             <a:extLst xmlns:a="http://schemas.openxmlformats.org/drawingml/2006/main">
               <a:ext uri="{FF2B5EF4-FFF2-40B4-BE49-F238E27FC236}">
-                <a16:creationId xmlns:a16="http://schemas.microsoft.com/office/drawing/2014/main" id="{70E36A82-B1F1-4256-9BA3-64DF16D770AB}"/>
+                <a16:creationId xmlns:a16="http://schemas.microsoft.com/office/drawing/2014/main" id="{DD7BA282-E438-4024-AE73-926043733B1C}"/>
               </a:ext>
             </a:extLst>
           </p:cNvPr>
@@ -16889,7 +16889,7 @@
           <p:cNvPr id="45" name="">
             <a:extLst xmlns:a="http://schemas.openxmlformats.org/drawingml/2006/main">
               <a:ext uri="{FF2B5EF4-FFF2-40B4-BE49-F238E27FC236}">
-                <a16:creationId xmlns:a16="http://schemas.microsoft.com/office/drawing/2014/main" id="{84B5D9FD-223D-478B-A261-71F0689039C9}"/>
+                <a16:creationId xmlns:a16="http://schemas.microsoft.com/office/drawing/2014/main" id="{E89F1FB3-965B-4A5C-BDF1-892E0685CFAA}"/>
               </a:ext>
             </a:extLst>
           </p:cNvPr>
@@ -16924,7 +16924,7 @@
           <p:cNvPr id="46" name="">
             <a:extLst xmlns:a="http://schemas.openxmlformats.org/drawingml/2006/main">
               <a:ext uri="{FF2B5EF4-FFF2-40B4-BE49-F238E27FC236}">
-                <a16:creationId xmlns:a16="http://schemas.microsoft.com/office/drawing/2014/main" id="{5EC1E761-84B7-44A6-A541-46C6E4246B47}"/>
+                <a16:creationId xmlns:a16="http://schemas.microsoft.com/office/drawing/2014/main" id="{76141869-3EBD-433A-9017-59E517C1294E}"/>
               </a:ext>
             </a:extLst>
           </p:cNvPr>
@@ -16988,7 +16988,7 @@
           <p:cNvPr id="47" name="">
             <a:extLst xmlns:a="http://schemas.openxmlformats.org/drawingml/2006/main">
               <a:ext uri="{FF2B5EF4-FFF2-40B4-BE49-F238E27FC236}">
-                <a16:creationId xmlns:a16="http://schemas.microsoft.com/office/drawing/2014/main" id="{C3A8AB34-057E-46A8-8352-66E219B5525F}"/>
+                <a16:creationId xmlns:a16="http://schemas.microsoft.com/office/drawing/2014/main" id="{7B0A6415-2081-4163-8923-D76872E8848A}"/>
               </a:ext>
             </a:extLst>
           </p:cNvPr>
@@ -17023,7 +17023,7 @@
           <p:cNvPr id="48" name="">
             <a:extLst xmlns:a="http://schemas.openxmlformats.org/drawingml/2006/main">
               <a:ext uri="{FF2B5EF4-FFF2-40B4-BE49-F238E27FC236}">
-                <a16:creationId xmlns:a16="http://schemas.microsoft.com/office/drawing/2014/main" id="{4AA8E0FF-20E5-4271-90D5-D787D73DEB39}"/>
+                <a16:creationId xmlns:a16="http://schemas.microsoft.com/office/drawing/2014/main" id="{49CF6D74-374B-45B8-9FA1-8C168945941B}"/>
               </a:ext>
             </a:extLst>
           </p:cNvPr>
@@ -17087,7 +17087,7 @@
           <p:cNvPr id="49" name="">
             <a:extLst xmlns:a="http://schemas.openxmlformats.org/drawingml/2006/main">
               <a:ext uri="{FF2B5EF4-FFF2-40B4-BE49-F238E27FC236}">
-                <a16:creationId xmlns:a16="http://schemas.microsoft.com/office/drawing/2014/main" id="{1E65E79C-B496-437E-8A25-CB9E4B3B2B74}"/>
+                <a16:creationId xmlns:a16="http://schemas.microsoft.com/office/drawing/2014/main" id="{926E065D-B198-4F4D-89E4-CA3DE3511241}"/>
               </a:ext>
             </a:extLst>
           </p:cNvPr>
@@ -17122,7 +17122,7 @@
           <p:cNvPr id="50" name="">
             <a:extLst xmlns:a="http://schemas.openxmlformats.org/drawingml/2006/main">
               <a:ext uri="{FF2B5EF4-FFF2-40B4-BE49-F238E27FC236}">
-                <a16:creationId xmlns:a16="http://schemas.microsoft.com/office/drawing/2014/main" id="{ABF467F6-DAD0-4B04-91AE-649C638CE92B}"/>
+                <a16:creationId xmlns:a16="http://schemas.microsoft.com/office/drawing/2014/main" id="{58721BC6-6011-4D70-95B3-4C799B8839D2}"/>
               </a:ext>
             </a:extLst>
           </p:cNvPr>
@@ -17184,7 +17184,7 @@
     </p:spTree>
     <p:extLst>
       <p:ext uri="{BB962C8B-B14F-4D97-AF65-F5344CB8AC3E}">
-        <p14:creationId xmlns:p14="http://schemas.microsoft.com/office/powerpoint/2010/main" val="1490922130"/>
+        <p14:creationId xmlns:p14="http://schemas.microsoft.com/office/powerpoint/2010/main" val="1111302497"/>
       </p:ext>
     </p:extLst>
   </p:cSld>
@@ -17208,7 +17208,7 @@
           <p:cNvPr id="1" name="">
             <a:extLst xmlns:a="http://schemas.openxmlformats.org/drawingml/2006/main">
               <a:ext uri="{FF2B5EF4-FFF2-40B4-BE49-F238E27FC236}">
-                <a16:creationId xmlns:a16="http://schemas.microsoft.com/office/drawing/2014/main" id="{7139A0C7-EAF9-4249-97FE-D6C27B7CA164}"/>
+                <a16:creationId xmlns:a16="http://schemas.microsoft.com/office/drawing/2014/main" id="{0A5B6C7B-51E6-4055-9591-E7CB645DFDA3}"/>
               </a:ext>
             </a:extLst>
           </p:cNvPr>
@@ -17243,7 +17243,7 @@
           <p:cNvPr id="2" name="">
             <a:extLst xmlns:a="http://schemas.openxmlformats.org/drawingml/2006/main">
               <a:ext uri="{FF2B5EF4-FFF2-40B4-BE49-F238E27FC236}">
-                <a16:creationId xmlns:a16="http://schemas.microsoft.com/office/drawing/2014/main" id="{03E70CFB-1041-4D89-936F-EB5D9F688611}"/>
+                <a16:creationId xmlns:a16="http://schemas.microsoft.com/office/drawing/2014/main" id="{060C06B4-D85D-4561-B26C-D06703AF39E9}"/>
               </a:ext>
             </a:extLst>
           </p:cNvPr>
@@ -17278,7 +17278,7 @@
           <p:cNvPr id="3" name="">
             <a:extLst xmlns:a="http://schemas.openxmlformats.org/drawingml/2006/main">
               <a:ext uri="{FF2B5EF4-FFF2-40B4-BE49-F238E27FC236}">
-                <a16:creationId xmlns:a16="http://schemas.microsoft.com/office/drawing/2014/main" id="{B4926BE2-DFD8-4CB5-A8F4-3E3175AA3139}"/>
+                <a16:creationId xmlns:a16="http://schemas.microsoft.com/office/drawing/2014/main" id="{2C1FA47C-D8F0-4E1C-BA6C-BFC3738CB0B7}"/>
               </a:ext>
             </a:extLst>
           </p:cNvPr>
@@ -17342,7 +17342,7 @@
           <p:cNvPr id="4" name="">
             <a:extLst xmlns:a="http://schemas.openxmlformats.org/drawingml/2006/main">
               <a:ext uri="{FF2B5EF4-FFF2-40B4-BE49-F238E27FC236}">
-                <a16:creationId xmlns:a16="http://schemas.microsoft.com/office/drawing/2014/main" id="{2A485D0C-1F33-46A5-A356-4F1418D2057E}"/>
+                <a16:creationId xmlns:a16="http://schemas.microsoft.com/office/drawing/2014/main" id="{D657C139-C5C5-4178-86DF-FC04B0AFB71E}"/>
               </a:ext>
             </a:extLst>
           </p:cNvPr>
@@ -17406,7 +17406,7 @@
           <p:cNvPr id="5" name="">
             <a:extLst xmlns:a="http://schemas.openxmlformats.org/drawingml/2006/main">
               <a:ext uri="{FF2B5EF4-FFF2-40B4-BE49-F238E27FC236}">
-                <a16:creationId xmlns:a16="http://schemas.microsoft.com/office/drawing/2014/main" id="{C08F44E6-8101-414E-8877-6BEDB1AD5BF3}"/>
+                <a16:creationId xmlns:a16="http://schemas.microsoft.com/office/drawing/2014/main" id="{0DDA0469-9A23-4CEE-9AD0-9022D233A704}"/>
               </a:ext>
             </a:extLst>
           </p:cNvPr>
@@ -17470,7 +17470,7 @@
           <p:cNvPr id="6" name="">
             <a:extLst xmlns:a="http://schemas.openxmlformats.org/drawingml/2006/main">
               <a:ext uri="{FF2B5EF4-FFF2-40B4-BE49-F238E27FC236}">
-                <a16:creationId xmlns:a16="http://schemas.microsoft.com/office/drawing/2014/main" id="{6CB8B754-A012-4A56-B5B0-F74B4C7AE3A9}"/>
+                <a16:creationId xmlns:a16="http://schemas.microsoft.com/office/drawing/2014/main" id="{31DE9289-5BD6-4CDF-8442-CC830E960F41}"/>
               </a:ext>
             </a:extLst>
           </p:cNvPr>
@@ -17534,7 +17534,7 @@
           <p:cNvPr id="7" name="">
             <a:extLst xmlns:a="http://schemas.openxmlformats.org/drawingml/2006/main">
               <a:ext uri="{FF2B5EF4-FFF2-40B4-BE49-F238E27FC236}">
-                <a16:creationId xmlns:a16="http://schemas.microsoft.com/office/drawing/2014/main" id="{A101F58D-4398-4281-B368-3FFB0261DBF5}"/>
+                <a16:creationId xmlns:a16="http://schemas.microsoft.com/office/drawing/2014/main" id="{F51FF04B-80CF-4CF5-93E6-709F41C62505}"/>
               </a:ext>
             </a:extLst>
           </p:cNvPr>
@@ -17567,7 +17567,7 @@
           <p:cNvPr id="8" name="">
             <a:extLst xmlns:a="http://schemas.openxmlformats.org/drawingml/2006/main">
               <a:ext uri="{FF2B5EF4-FFF2-40B4-BE49-F238E27FC236}">
-                <a16:creationId xmlns:a16="http://schemas.microsoft.com/office/drawing/2014/main" id="{FAD88207-8849-412E-B552-F560B4DC102D}"/>
+                <a16:creationId xmlns:a16="http://schemas.microsoft.com/office/drawing/2014/main" id="{1AD0B1F0-982C-437F-AA60-D583A872EC76}"/>
               </a:ext>
             </a:extLst>
           </p:cNvPr>
@@ -17602,7 +17602,7 @@
           <p:cNvPr id="9" name="">
             <a:extLst xmlns:a="http://schemas.openxmlformats.org/drawingml/2006/main">
               <a:ext uri="{FF2B5EF4-FFF2-40B4-BE49-F238E27FC236}">
-                <a16:creationId xmlns:a16="http://schemas.microsoft.com/office/drawing/2014/main" id="{566F539A-25B4-4489-ACED-0F36E641C223}"/>
+                <a16:creationId xmlns:a16="http://schemas.microsoft.com/office/drawing/2014/main" id="{3E485288-C52B-44DF-9012-50C00269B03D}"/>
               </a:ext>
             </a:extLst>
           </p:cNvPr>
@@ -17666,7 +17666,7 @@
           <p:cNvPr id="10" name="">
             <a:extLst xmlns:a="http://schemas.openxmlformats.org/drawingml/2006/main">
               <a:ext uri="{FF2B5EF4-FFF2-40B4-BE49-F238E27FC236}">
-                <a16:creationId xmlns:a16="http://schemas.microsoft.com/office/drawing/2014/main" id="{FD1823C5-AADD-4208-A8DD-8CB773D40B70}"/>
+                <a16:creationId xmlns:a16="http://schemas.microsoft.com/office/drawing/2014/main" id="{C60BF20A-4786-4AC3-9750-2152C3ECCDCB}"/>
               </a:ext>
             </a:extLst>
           </p:cNvPr>
@@ -17730,7 +17730,7 @@
           <p:cNvPr id="11" name="">
             <a:extLst xmlns:a="http://schemas.openxmlformats.org/drawingml/2006/main">
               <a:ext uri="{FF2B5EF4-FFF2-40B4-BE49-F238E27FC236}">
-                <a16:creationId xmlns:a16="http://schemas.microsoft.com/office/drawing/2014/main" id="{05F72FF5-F402-4DFB-8C61-708D76684E6B}"/>
+                <a16:creationId xmlns:a16="http://schemas.microsoft.com/office/drawing/2014/main" id="{5935BEF7-6124-473C-8ACB-B61AC48763BA}"/>
               </a:ext>
             </a:extLst>
           </p:cNvPr>
@@ -17763,7 +17763,7 @@
           <p:cNvPr id="12" name="">
             <a:extLst xmlns:a="http://schemas.openxmlformats.org/drawingml/2006/main">
               <a:ext uri="{FF2B5EF4-FFF2-40B4-BE49-F238E27FC236}">
-                <a16:creationId xmlns:a16="http://schemas.microsoft.com/office/drawing/2014/main" id="{BB67CF61-024E-497B-9FD3-CB595CC00A64}"/>
+                <a16:creationId xmlns:a16="http://schemas.microsoft.com/office/drawing/2014/main" id="{61F6BB2C-7126-4B52-BF8C-3BAA813D504B}"/>
               </a:ext>
             </a:extLst>
           </p:cNvPr>
@@ -17798,7 +17798,7 @@
           <p:cNvPr id="13" name="">
             <a:extLst xmlns:a="http://schemas.openxmlformats.org/drawingml/2006/main">
               <a:ext uri="{FF2B5EF4-FFF2-40B4-BE49-F238E27FC236}">
-                <a16:creationId xmlns:a16="http://schemas.microsoft.com/office/drawing/2014/main" id="{DB34189F-9152-424A-B739-A4C6D3E86985}"/>
+                <a16:creationId xmlns:a16="http://schemas.microsoft.com/office/drawing/2014/main" id="{6A5D0C8F-5740-48DF-9271-524902A62484}"/>
               </a:ext>
             </a:extLst>
           </p:cNvPr>
@@ -17862,7 +17862,7 @@
           <p:cNvPr id="14" name="">
             <a:extLst xmlns:a="http://schemas.openxmlformats.org/drawingml/2006/main">
               <a:ext uri="{FF2B5EF4-FFF2-40B4-BE49-F238E27FC236}">
-                <a16:creationId xmlns:a16="http://schemas.microsoft.com/office/drawing/2014/main" id="{D9744ABF-1538-48D9-B3EB-FEDB88D59EC6}"/>
+                <a16:creationId xmlns:a16="http://schemas.microsoft.com/office/drawing/2014/main" id="{881CACBA-04E0-4997-8546-8521AA32D93E}"/>
               </a:ext>
             </a:extLst>
           </p:cNvPr>
@@ -17926,7 +17926,7 @@
           <p:cNvPr id="15" name="">
             <a:extLst xmlns:a="http://schemas.openxmlformats.org/drawingml/2006/main">
               <a:ext uri="{FF2B5EF4-FFF2-40B4-BE49-F238E27FC236}">
-                <a16:creationId xmlns:a16="http://schemas.microsoft.com/office/drawing/2014/main" id="{4BC64333-DFB5-49B3-8E96-5995F5A7AF68}"/>
+                <a16:creationId xmlns:a16="http://schemas.microsoft.com/office/drawing/2014/main" id="{960AEDBD-C938-46BD-9AC5-FFA686752765}"/>
               </a:ext>
             </a:extLst>
           </p:cNvPr>
@@ -17959,7 +17959,7 @@
           <p:cNvPr id="16" name="">
             <a:extLst xmlns:a="http://schemas.openxmlformats.org/drawingml/2006/main">
               <a:ext uri="{FF2B5EF4-FFF2-40B4-BE49-F238E27FC236}">
-                <a16:creationId xmlns:a16="http://schemas.microsoft.com/office/drawing/2014/main" id="{6BCEFC69-89CE-4234-A1A7-214B73C2F85D}"/>
+                <a16:creationId xmlns:a16="http://schemas.microsoft.com/office/drawing/2014/main" id="{C9470606-A7AD-4746-A94D-D610B312BEF3}"/>
               </a:ext>
             </a:extLst>
           </p:cNvPr>
@@ -17994,7 +17994,7 @@
           <p:cNvPr id="17" name="">
             <a:extLst xmlns:a="http://schemas.openxmlformats.org/drawingml/2006/main">
               <a:ext uri="{FF2B5EF4-FFF2-40B4-BE49-F238E27FC236}">
-                <a16:creationId xmlns:a16="http://schemas.microsoft.com/office/drawing/2014/main" id="{CAD00DCC-082C-4714-ADD3-0141B8FFA24C}"/>
+                <a16:creationId xmlns:a16="http://schemas.microsoft.com/office/drawing/2014/main" id="{DBB7F7F3-EE94-4E18-9A8F-800B4AC70D69}"/>
               </a:ext>
             </a:extLst>
           </p:cNvPr>
@@ -18058,7 +18058,7 @@
           <p:cNvPr id="18" name="">
             <a:extLst xmlns:a="http://schemas.openxmlformats.org/drawingml/2006/main">
               <a:ext uri="{FF2B5EF4-FFF2-40B4-BE49-F238E27FC236}">
-                <a16:creationId xmlns:a16="http://schemas.microsoft.com/office/drawing/2014/main" id="{9A88F755-E5A0-4BEC-870A-83F7A1DA9C87}"/>
+                <a16:creationId xmlns:a16="http://schemas.microsoft.com/office/drawing/2014/main" id="{CDFB44EE-82C6-4ABD-BFFD-32378F1889CF}"/>
               </a:ext>
             </a:extLst>
           </p:cNvPr>
@@ -18122,7 +18122,7 @@
           <p:cNvPr id="19" name="">
             <a:extLst xmlns:a="http://schemas.openxmlformats.org/drawingml/2006/main">
               <a:ext uri="{FF2B5EF4-FFF2-40B4-BE49-F238E27FC236}">
-                <a16:creationId xmlns:a16="http://schemas.microsoft.com/office/drawing/2014/main" id="{D76D9E3D-B0C7-43EE-A91E-31DC29B5FABD}"/>
+                <a16:creationId xmlns:a16="http://schemas.microsoft.com/office/drawing/2014/main" id="{DF24EC03-910B-42DF-8B70-AD6BEEF62B76}"/>
               </a:ext>
             </a:extLst>
           </p:cNvPr>
@@ -18155,7 +18155,7 @@
           <p:cNvPr id="20" name="">
             <a:extLst xmlns:a="http://schemas.openxmlformats.org/drawingml/2006/main">
               <a:ext uri="{FF2B5EF4-FFF2-40B4-BE49-F238E27FC236}">
-                <a16:creationId xmlns:a16="http://schemas.microsoft.com/office/drawing/2014/main" id="{091E7904-FE58-47EB-8AF5-CA7ED28EDFB1}"/>
+                <a16:creationId xmlns:a16="http://schemas.microsoft.com/office/drawing/2014/main" id="{204D6323-F1DD-4029-9824-38390CF4EB13}"/>
               </a:ext>
             </a:extLst>
           </p:cNvPr>
@@ -18190,7 +18190,7 @@
           <p:cNvPr id="21" name="">
             <a:extLst xmlns:a="http://schemas.openxmlformats.org/drawingml/2006/main">
               <a:ext uri="{FF2B5EF4-FFF2-40B4-BE49-F238E27FC236}">
-                <a16:creationId xmlns:a16="http://schemas.microsoft.com/office/drawing/2014/main" id="{302A374D-F9F4-4F11-BDC8-C803741033B6}"/>
+                <a16:creationId xmlns:a16="http://schemas.microsoft.com/office/drawing/2014/main" id="{CA6E36FB-3ADF-40A6-9BE2-E21C238DD969}"/>
               </a:ext>
             </a:extLst>
           </p:cNvPr>
@@ -18254,7 +18254,7 @@
           <p:cNvPr id="22" name="">
             <a:extLst xmlns:a="http://schemas.openxmlformats.org/drawingml/2006/main">
               <a:ext uri="{FF2B5EF4-FFF2-40B4-BE49-F238E27FC236}">
-                <a16:creationId xmlns:a16="http://schemas.microsoft.com/office/drawing/2014/main" id="{676F1663-BB1D-4CB2-9E47-0128379496EA}"/>
+                <a16:creationId xmlns:a16="http://schemas.microsoft.com/office/drawing/2014/main" id="{77652845-00B1-4074-9BDF-346F496EEE70}"/>
               </a:ext>
             </a:extLst>
           </p:cNvPr>
@@ -18318,7 +18318,7 @@
           <p:cNvPr id="23" name="">
             <a:extLst xmlns:a="http://schemas.openxmlformats.org/drawingml/2006/main">
               <a:ext uri="{FF2B5EF4-FFF2-40B4-BE49-F238E27FC236}">
-                <a16:creationId xmlns:a16="http://schemas.microsoft.com/office/drawing/2014/main" id="{60C70FB8-02B5-410F-A010-6A0F81964C2F}"/>
+                <a16:creationId xmlns:a16="http://schemas.microsoft.com/office/drawing/2014/main" id="{D30F98DB-6817-45B6-BDE5-57C6F19434A8}"/>
               </a:ext>
             </a:extLst>
           </p:cNvPr>
@@ -18351,7 +18351,7 @@
           <p:cNvPr id="24" name="">
             <a:extLst xmlns:a="http://schemas.openxmlformats.org/drawingml/2006/main">
               <a:ext uri="{FF2B5EF4-FFF2-40B4-BE49-F238E27FC236}">
-                <a16:creationId xmlns:a16="http://schemas.microsoft.com/office/drawing/2014/main" id="{6A1BF8AE-4FAB-4DEC-B14C-A58F907082E9}"/>
+                <a16:creationId xmlns:a16="http://schemas.microsoft.com/office/drawing/2014/main" id="{504EB7E8-C922-410F-8CF1-EED97C8FBE30}"/>
               </a:ext>
             </a:extLst>
           </p:cNvPr>
@@ -18413,7 +18413,7 @@
     </p:spTree>
     <p:extLst>
       <p:ext uri="{BB962C8B-B14F-4D97-AF65-F5344CB8AC3E}">
-        <p14:creationId xmlns:p14="http://schemas.microsoft.com/office/powerpoint/2010/main" val="884251423"/>
+        <p14:creationId xmlns:p14="http://schemas.microsoft.com/office/powerpoint/2010/main" val="1049566779"/>
       </p:ext>
     </p:extLst>
   </p:cSld>
@@ -18437,7 +18437,7 @@
           <p:cNvPr id="1" name="">
             <a:extLst xmlns:a="http://schemas.openxmlformats.org/drawingml/2006/main">
               <a:ext uri="{FF2B5EF4-FFF2-40B4-BE49-F238E27FC236}">
-                <a16:creationId xmlns:a16="http://schemas.microsoft.com/office/drawing/2014/main" id="{1BCA7D92-4B1B-427E-A96F-D324C9A54013}"/>
+                <a16:creationId xmlns:a16="http://schemas.microsoft.com/office/drawing/2014/main" id="{511027D0-3A51-4D40-A376-EF8AD3C23948}"/>
               </a:ext>
             </a:extLst>
           </p:cNvPr>
@@ -18472,7 +18472,7 @@
           <p:cNvPr id="2" name="">
             <a:extLst xmlns:a="http://schemas.openxmlformats.org/drawingml/2006/main">
               <a:ext uri="{FF2B5EF4-FFF2-40B4-BE49-F238E27FC236}">
-                <a16:creationId xmlns:a16="http://schemas.microsoft.com/office/drawing/2014/main" id="{A998D442-EC46-49B7-8656-6107E89116D3}"/>
+                <a16:creationId xmlns:a16="http://schemas.microsoft.com/office/drawing/2014/main" id="{021DAFF0-6C6A-4FF1-8199-39A8259470C4}"/>
               </a:ext>
             </a:extLst>
           </p:cNvPr>
@@ -18507,7 +18507,7 @@
           <p:cNvPr id="3" name="">
             <a:extLst xmlns:a="http://schemas.openxmlformats.org/drawingml/2006/main">
               <a:ext uri="{FF2B5EF4-FFF2-40B4-BE49-F238E27FC236}">
-                <a16:creationId xmlns:a16="http://schemas.microsoft.com/office/drawing/2014/main" id="{E5989505-EADA-4B08-A76B-15B257135000}"/>
+                <a16:creationId xmlns:a16="http://schemas.microsoft.com/office/drawing/2014/main" id="{FD106014-D30E-4B79-8AE0-4B010C83A678}"/>
               </a:ext>
             </a:extLst>
           </p:cNvPr>
@@ -18571,7 +18571,7 @@
           <p:cNvPr id="4" name="">
             <a:extLst xmlns:a="http://schemas.openxmlformats.org/drawingml/2006/main">
               <a:ext uri="{FF2B5EF4-FFF2-40B4-BE49-F238E27FC236}">
-                <a16:creationId xmlns:a16="http://schemas.microsoft.com/office/drawing/2014/main" id="{D92FA1E6-9BEA-48D9-9A59-D37CA9CD9470}"/>
+                <a16:creationId xmlns:a16="http://schemas.microsoft.com/office/drawing/2014/main" id="{DC9BD161-C9AE-425B-8037-A192C4A8DF84}"/>
               </a:ext>
             </a:extLst>
           </p:cNvPr>
@@ -18635,7 +18635,7 @@
           <p:cNvPr id="5" name="">
             <a:extLst xmlns:a="http://schemas.openxmlformats.org/drawingml/2006/main">
               <a:ext uri="{FF2B5EF4-FFF2-40B4-BE49-F238E27FC236}">
-                <a16:creationId xmlns:a16="http://schemas.microsoft.com/office/drawing/2014/main" id="{B8268451-8674-48AF-880E-8D9E68CE4B7E}"/>
+                <a16:creationId xmlns:a16="http://schemas.microsoft.com/office/drawing/2014/main" id="{D5F54803-837C-42F2-9EFE-55914FEE3D2E}"/>
               </a:ext>
             </a:extLst>
           </p:cNvPr>
@@ -18699,7 +18699,7 @@
           <p:cNvPr id="6" name="">
             <a:extLst xmlns:a="http://schemas.openxmlformats.org/drawingml/2006/main">
               <a:ext uri="{FF2B5EF4-FFF2-40B4-BE49-F238E27FC236}">
-                <a16:creationId xmlns:a16="http://schemas.microsoft.com/office/drawing/2014/main" id="{1AA8D4C7-B75C-4EA2-A6B6-6A14CB5128C7}"/>
+                <a16:creationId xmlns:a16="http://schemas.microsoft.com/office/drawing/2014/main" id="{CF83D252-7B64-445A-803D-5D781B7015B9}"/>
               </a:ext>
             </a:extLst>
           </p:cNvPr>
@@ -18767,7 +18767,7 @@
           <p:nvPr/>
         </p:nvPicPr>
         <p:blipFill>
-          <a:blip xmlns:r="http://schemas.openxmlformats.org/officeDocument/2006/relationships" xmlns:a="http://schemas.openxmlformats.org/drawingml/2006/main" r:embed="Rc5eba53ea0a34314"/>
+          <a:blip xmlns:r="http://schemas.openxmlformats.org/officeDocument/2006/relationships" xmlns:a="http://schemas.openxmlformats.org/drawingml/2006/main" r:embed="Rca743736c4aa4c72"/>
           <a:stretch xmlns:a="http://schemas.openxmlformats.org/drawingml/2006/main"/>
         </p:blipFill>
         <p:spPr>
@@ -18785,7 +18785,7 @@
           <p:cNvPr id="8" name="">
             <a:extLst xmlns:a="http://schemas.openxmlformats.org/drawingml/2006/main">
               <a:ext uri="{FF2B5EF4-FFF2-40B4-BE49-F238E27FC236}">
-                <a16:creationId xmlns:a16="http://schemas.microsoft.com/office/drawing/2014/main" id="{A0979B67-BE65-4B49-858E-F8C7A8E5EDDC}"/>
+                <a16:creationId xmlns:a16="http://schemas.microsoft.com/office/drawing/2014/main" id="{2544772F-9630-4DDE-8CE7-A82818CD4C17}"/>
               </a:ext>
             </a:extLst>
           </p:cNvPr>
@@ -18818,7 +18818,7 @@
           <p:cNvPr id="9" name="">
             <a:extLst xmlns:a="http://schemas.openxmlformats.org/drawingml/2006/main">
               <a:ext uri="{FF2B5EF4-FFF2-40B4-BE49-F238E27FC236}">
-                <a16:creationId xmlns:a16="http://schemas.microsoft.com/office/drawing/2014/main" id="{DF9B8BDE-9C26-4D1D-92E3-1E4C997964FD}"/>
+                <a16:creationId xmlns:a16="http://schemas.microsoft.com/office/drawing/2014/main" id="{B794A7DE-B62C-4F59-91EA-DAF234FE6665}"/>
               </a:ext>
             </a:extLst>
           </p:cNvPr>
@@ -18882,7 +18882,7 @@
           <p:cNvPr id="10" name="">
             <a:extLst xmlns:a="http://schemas.openxmlformats.org/drawingml/2006/main">
               <a:ext uri="{FF2B5EF4-FFF2-40B4-BE49-F238E27FC236}">
-                <a16:creationId xmlns:a16="http://schemas.microsoft.com/office/drawing/2014/main" id="{8894C812-6AC1-4CC0-9CBD-F34FD569E163}"/>
+                <a16:creationId xmlns:a16="http://schemas.microsoft.com/office/drawing/2014/main" id="{63AB5A94-2AE4-43BF-A336-1CDFD9E9CEE2}"/>
               </a:ext>
             </a:extLst>
           </p:cNvPr>
@@ -18946,7 +18946,7 @@
           <p:cNvPr id="11" name="">
             <a:extLst xmlns:a="http://schemas.openxmlformats.org/drawingml/2006/main">
               <a:ext uri="{FF2B5EF4-FFF2-40B4-BE49-F238E27FC236}">
-                <a16:creationId xmlns:a16="http://schemas.microsoft.com/office/drawing/2014/main" id="{AABBE28F-A939-4CA9-8030-1EC63A4B5C88}"/>
+                <a16:creationId xmlns:a16="http://schemas.microsoft.com/office/drawing/2014/main" id="{3F653D77-79B4-4A74-A4DC-A072C5177AE6}"/>
               </a:ext>
             </a:extLst>
           </p:cNvPr>
@@ -18979,7 +18979,7 @@
           <p:cNvPr id="12" name="">
             <a:extLst xmlns:a="http://schemas.openxmlformats.org/drawingml/2006/main">
               <a:ext uri="{FF2B5EF4-FFF2-40B4-BE49-F238E27FC236}">
-                <a16:creationId xmlns:a16="http://schemas.microsoft.com/office/drawing/2014/main" id="{29B33A1B-473C-4D8F-8A01-ACAB2EC60A7D}"/>
+                <a16:creationId xmlns:a16="http://schemas.microsoft.com/office/drawing/2014/main" id="{B718C14F-B878-4F6B-BEDB-D451A20229E4}"/>
               </a:ext>
             </a:extLst>
           </p:cNvPr>
@@ -19043,7 +19043,7 @@
           <p:cNvPr id="13" name="">
             <a:extLst xmlns:a="http://schemas.openxmlformats.org/drawingml/2006/main">
               <a:ext uri="{FF2B5EF4-FFF2-40B4-BE49-F238E27FC236}">
-                <a16:creationId xmlns:a16="http://schemas.microsoft.com/office/drawing/2014/main" id="{2A061148-98DB-40AE-8812-270C7D17C0A5}"/>
+                <a16:creationId xmlns:a16="http://schemas.microsoft.com/office/drawing/2014/main" id="{D8079B22-4378-401D-9B90-8FD7AB5A65D5}"/>
               </a:ext>
             </a:extLst>
           </p:cNvPr>
@@ -19107,7 +19107,7 @@
           <p:cNvPr id="14" name="">
             <a:extLst xmlns:a="http://schemas.openxmlformats.org/drawingml/2006/main">
               <a:ext uri="{FF2B5EF4-FFF2-40B4-BE49-F238E27FC236}">
-                <a16:creationId xmlns:a16="http://schemas.microsoft.com/office/drawing/2014/main" id="{D671291D-6442-4BCF-ADAE-411D5B586482}"/>
+                <a16:creationId xmlns:a16="http://schemas.microsoft.com/office/drawing/2014/main" id="{F58F8AFB-F556-44A7-8FF2-121EB2EF1628}"/>
               </a:ext>
             </a:extLst>
           </p:cNvPr>
@@ -19140,7 +19140,7 @@
           <p:cNvPr id="15" name="">
             <a:extLst xmlns:a="http://schemas.openxmlformats.org/drawingml/2006/main">
               <a:ext uri="{FF2B5EF4-FFF2-40B4-BE49-F238E27FC236}">
-                <a16:creationId xmlns:a16="http://schemas.microsoft.com/office/drawing/2014/main" id="{7246D3C1-01B5-4595-93E0-5D6ECC483612}"/>
+                <a16:creationId xmlns:a16="http://schemas.microsoft.com/office/drawing/2014/main" id="{26D6C3BA-8F69-4FB8-9F37-5EFB26E12F6E}"/>
               </a:ext>
             </a:extLst>
           </p:cNvPr>
@@ -19194,7 +19194,7 @@
                 <a:ea typeface="Aptos"/>
                 <a:cs typeface="Aptos"/>
               </a:rPr>
-              <a:t>Video offen</a:t>
+              <a:t>Video vorbereitet</a:t>
             </a:r>
           </a:p>
         </p:txBody>
@@ -19204,7 +19204,7 @@
           <p:cNvPr id="16" name="">
             <a:extLst xmlns:a="http://schemas.openxmlformats.org/drawingml/2006/main">
               <a:ext uri="{FF2B5EF4-FFF2-40B4-BE49-F238E27FC236}">
-                <a16:creationId xmlns:a16="http://schemas.microsoft.com/office/drawing/2014/main" id="{063E4425-A124-41B7-B57D-FF82FCCF9352}"/>
+                <a16:creationId xmlns:a16="http://schemas.microsoft.com/office/drawing/2014/main" id="{9D613773-BC94-446B-B0AB-D913CC644F6F}"/>
               </a:ext>
             </a:extLst>
           </p:cNvPr>
@@ -19258,7 +19258,7 @@
                 <a:ea typeface="Aptos"/>
                 <a:cs typeface="Aptos"/>
               </a:rPr>
-              <a:t>Bewertungsraster erlaubt Video als Fehlerfrei-Nachweis.</a:t>
+              <a:t>Walkthrough liegt vor; Live-Parsesc-Aufnahme bleibt ideal.</a:t>
             </a:r>
           </a:p>
         </p:txBody>
@@ -19266,7 +19266,7 @@
     </p:spTree>
     <p:extLst>
       <p:ext uri="{BB962C8B-B14F-4D97-AF65-F5344CB8AC3E}">
-        <p14:creationId xmlns:p14="http://schemas.microsoft.com/office/powerpoint/2010/main" val="497704675"/>
+        <p14:creationId xmlns:p14="http://schemas.microsoft.com/office/powerpoint/2010/main" val="934058133"/>
       </p:ext>
     </p:extLst>
   </p:cSld>

</xml_diff>

<commit_message>
Update final RPA presentation evidence
</commit_message>
<xml_diff>
--- a/unterlagen/Moodle-to-LLM Study Planner - Schlusspräsentation.pptx
+++ b/unterlagen/Moodle-to-LLM Study Planner - Schlusspräsentation.pptx
@@ -1687,6 +1687,10 @@
             <a:prstDash val="solid"/>
           </a:ln>
         </p:spPr>
+        <p:txBody xmlns:a="http://schemas.openxmlformats.org/drawingml/2006/main">
+          <a:bodyPr/>
+          <a:p/>
+        </p:txBody>
       </p:sp>
       <p:sp>
         <p:nvSpPr>
@@ -1722,6 +1726,10 @@
             <a:prstDash val="solid"/>
           </a:ln>
         </p:spPr>
+        <p:txBody xmlns:a="http://schemas.openxmlformats.org/drawingml/2006/main">
+          <a:bodyPr/>
+          <a:p/>
+        </p:txBody>
       </p:sp>
       <p:sp>
         <p:nvSpPr>
@@ -2033,6 +2041,10 @@
             <a:prstDash val="solid"/>
           </a:ln>
         </p:spPr>
+        <p:txBody xmlns:a="http://schemas.openxmlformats.org/drawingml/2006/main">
+          <a:bodyPr/>
+          <a:p/>
+        </p:txBody>
       </p:sp>
       <p:sp>
         <p:nvSpPr>
@@ -2258,6 +2270,10 @@
             <a:prstDash val="solid"/>
           </a:ln>
         </p:spPr>
+        <p:txBody xmlns:a="http://schemas.openxmlformats.org/drawingml/2006/main">
+          <a:bodyPr/>
+          <a:p/>
+        </p:txBody>
       </p:sp>
       <p:sp>
         <p:nvSpPr>
@@ -2483,6 +2499,10 @@
             <a:prstDash val="solid"/>
           </a:ln>
         </p:spPr>
+        <p:txBody xmlns:a="http://schemas.openxmlformats.org/drawingml/2006/main">
+          <a:bodyPr/>
+          <a:p/>
+        </p:txBody>
       </p:sp>
       <p:sp>
         <p:nvSpPr>
@@ -2796,6 +2816,10 @@
             <a:prstDash val="solid"/>
           </a:ln>
         </p:spPr>
+        <p:txBody xmlns:a="http://schemas.openxmlformats.org/drawingml/2006/main">
+          <a:bodyPr/>
+          <a:p/>
+        </p:txBody>
       </p:sp>
       <p:sp>
         <p:nvSpPr>
@@ -2831,6 +2855,10 @@
             <a:prstDash val="solid"/>
           </a:ln>
         </p:spPr>
+        <p:txBody xmlns:a="http://schemas.openxmlformats.org/drawingml/2006/main">
+          <a:bodyPr/>
+          <a:p/>
+        </p:txBody>
       </p:sp>
       <p:sp>
         <p:nvSpPr>
@@ -3316,6 +3344,10 @@
             <a:prstDash val="solid"/>
           </a:ln>
         </p:spPr>
+        <p:txBody xmlns:a="http://schemas.openxmlformats.org/drawingml/2006/main">
+          <a:bodyPr/>
+          <a:p/>
+        </p:txBody>
       </p:sp>
       <p:sp>
         <p:nvSpPr>
@@ -3351,6 +3383,10 @@
             <a:prstDash val="solid"/>
           </a:ln>
         </p:spPr>
+        <p:txBody xmlns:a="http://schemas.openxmlformats.org/drawingml/2006/main">
+          <a:bodyPr/>
+          <a:p/>
+        </p:txBody>
       </p:sp>
       <p:sp>
         <p:nvSpPr>
@@ -3640,6 +3676,10 @@
             <a:prstDash val="solid"/>
           </a:ln>
         </p:spPr>
+        <p:txBody xmlns:a="http://schemas.openxmlformats.org/drawingml/2006/main">
+          <a:bodyPr/>
+          <a:p/>
+        </p:txBody>
       </p:sp>
       <p:sp>
         <p:nvSpPr>
@@ -3865,6 +3905,10 @@
             <a:prstDash val="solid"/>
           </a:ln>
         </p:spPr>
+        <p:txBody xmlns:a="http://schemas.openxmlformats.org/drawingml/2006/main">
+          <a:bodyPr/>
+          <a:p/>
+        </p:txBody>
       </p:sp>
       <p:sp>
         <p:nvSpPr>
@@ -4090,6 +4134,10 @@
             <a:prstDash val="solid"/>
           </a:ln>
         </p:spPr>
+        <p:txBody xmlns:a="http://schemas.openxmlformats.org/drawingml/2006/main">
+          <a:bodyPr/>
+          <a:p/>
+        </p:txBody>
       </p:sp>
       <p:sp>
         <p:nvSpPr>
@@ -4315,6 +4363,10 @@
             <a:prstDash val="solid"/>
           </a:ln>
         </p:spPr>
+        <p:txBody xmlns:a="http://schemas.openxmlformats.org/drawingml/2006/main">
+          <a:bodyPr/>
+          <a:p/>
+        </p:txBody>
       </p:sp>
       <p:sp>
         <p:nvSpPr>
@@ -4540,6 +4592,10 @@
             <a:prstDash val="solid"/>
           </a:ln>
         </p:spPr>
+        <p:txBody xmlns:a="http://schemas.openxmlformats.org/drawingml/2006/main">
+          <a:bodyPr/>
+          <a:p/>
+        </p:txBody>
       </p:sp>
       <p:sp>
         <p:nvSpPr>
@@ -4725,6 +4781,10 @@
             <a:prstDash val="solid"/>
           </a:ln>
         </p:spPr>
+        <p:txBody xmlns:a="http://schemas.openxmlformats.org/drawingml/2006/main">
+          <a:bodyPr/>
+          <a:p/>
+        </p:txBody>
       </p:sp>
       <p:sp>
         <p:nvSpPr>
@@ -4760,6 +4820,10 @@
             <a:prstDash val="solid"/>
           </a:ln>
         </p:spPr>
+        <p:txBody xmlns:a="http://schemas.openxmlformats.org/drawingml/2006/main">
+          <a:bodyPr/>
+          <a:p/>
+        </p:txBody>
       </p:sp>
       <p:sp>
         <p:nvSpPr>
@@ -5049,6 +5113,10 @@
             <a:prstDash val="solid"/>
           </a:ln>
         </p:spPr>
+        <p:txBody xmlns:a="http://schemas.openxmlformats.org/drawingml/2006/main">
+          <a:bodyPr/>
+          <a:p/>
+        </p:txBody>
       </p:sp>
       <p:sp>
         <p:nvSpPr>
@@ -5084,6 +5152,10 @@
             <a:prstDash val="solid"/>
           </a:ln>
         </p:spPr>
+        <p:txBody xmlns:a="http://schemas.openxmlformats.org/drawingml/2006/main">
+          <a:bodyPr/>
+          <a:p/>
+        </p:txBody>
       </p:sp>
       <p:sp>
         <p:nvSpPr>
@@ -5245,6 +5317,10 @@
             <a:prstDash val="solid"/>
           </a:ln>
         </p:spPr>
+        <p:txBody xmlns:a="http://schemas.openxmlformats.org/drawingml/2006/main">
+          <a:bodyPr/>
+          <a:p/>
+        </p:txBody>
       </p:sp>
       <p:sp>
         <p:nvSpPr>
@@ -5280,6 +5356,10 @@
             <a:prstDash val="solid"/>
           </a:ln>
         </p:spPr>
+        <p:txBody xmlns:a="http://schemas.openxmlformats.org/drawingml/2006/main">
+          <a:bodyPr/>
+          <a:p/>
+        </p:txBody>
       </p:sp>
       <p:sp>
         <p:nvSpPr>
@@ -5441,6 +5521,10 @@
             <a:prstDash val="solid"/>
           </a:ln>
         </p:spPr>
+        <p:txBody xmlns:a="http://schemas.openxmlformats.org/drawingml/2006/main">
+          <a:bodyPr/>
+          <a:p/>
+        </p:txBody>
       </p:sp>
       <p:sp>
         <p:nvSpPr>
@@ -5476,6 +5560,10 @@
             <a:prstDash val="solid"/>
           </a:ln>
         </p:spPr>
+        <p:txBody xmlns:a="http://schemas.openxmlformats.org/drawingml/2006/main">
+          <a:bodyPr/>
+          <a:p/>
+        </p:txBody>
       </p:sp>
       <p:sp>
         <p:nvSpPr>
@@ -5637,6 +5725,10 @@
             <a:prstDash val="solid"/>
           </a:ln>
         </p:spPr>
+        <p:txBody xmlns:a="http://schemas.openxmlformats.org/drawingml/2006/main">
+          <a:bodyPr/>
+          <a:p/>
+        </p:txBody>
       </p:sp>
       <p:sp>
         <p:nvSpPr>
@@ -5672,6 +5764,10 @@
             <a:prstDash val="solid"/>
           </a:ln>
         </p:spPr>
+        <p:txBody xmlns:a="http://schemas.openxmlformats.org/drawingml/2006/main">
+          <a:bodyPr/>
+          <a:p/>
+        </p:txBody>
       </p:sp>
       <p:sp>
         <p:nvSpPr>
@@ -5833,6 +5929,10 @@
             <a:prstDash val="solid"/>
           </a:ln>
         </p:spPr>
+        <p:txBody xmlns:a="http://schemas.openxmlformats.org/drawingml/2006/main">
+          <a:bodyPr/>
+          <a:p/>
+        </p:txBody>
       </p:sp>
       <p:sp>
         <p:nvSpPr>
@@ -5868,6 +5968,10 @@
             <a:prstDash val="solid"/>
           </a:ln>
         </p:spPr>
+        <p:txBody xmlns:a="http://schemas.openxmlformats.org/drawingml/2006/main">
+          <a:bodyPr/>
+          <a:p/>
+        </p:txBody>
       </p:sp>
       <p:sp>
         <p:nvSpPr>
@@ -6053,6 +6157,10 @@
             <a:prstDash val="solid"/>
           </a:ln>
         </p:spPr>
+        <p:txBody xmlns:a="http://schemas.openxmlformats.org/drawingml/2006/main">
+          <a:bodyPr/>
+          <a:p/>
+        </p:txBody>
       </p:sp>
       <p:sp>
         <p:nvSpPr>
@@ -6088,6 +6196,10 @@
             <a:prstDash val="solid"/>
           </a:ln>
         </p:spPr>
+        <p:txBody xmlns:a="http://schemas.openxmlformats.org/drawingml/2006/main">
+          <a:bodyPr/>
+          <a:p/>
+        </p:txBody>
       </p:sp>
       <p:sp>
         <p:nvSpPr>
@@ -6276,7 +6388,7 @@
                 <a:ea typeface="Aptos Display"/>
                 <a:cs typeface="Aptos Display"/>
               </a:rPr>
-              <a:t>Status und nächste Schritte</a:t>
+              <a:t>Status und Abgabehinweise</a:t>
             </a:r>
           </a:p>
         </p:txBody>
@@ -6340,7 +6452,7 @@
                 <a:ea typeface="Aptos"/>
                 <a:cs typeface="Aptos"/>
               </a:rPr>
-              <a:t>Die fachliche Story und der Output-Nachweis stehen; der finale Lauf sollte als Video aufgezeichnet werden.</a:t>
+              <a:t>Die Präsentation deckt die Bewertungskriterien ab und verweist auf Screenshots, Quellen und Prozessvideo.</a:t>
             </a:r>
           </a:p>
         </p:txBody>
@@ -6377,6 +6489,10 @@
             <a:prstDash val="solid"/>
           </a:ln>
         </p:spPr>
+        <p:txBody xmlns:a="http://schemas.openxmlformats.org/drawingml/2006/main">
+          <a:bodyPr/>
+          <a:p/>
+        </p:txBody>
       </p:sp>
       <p:sp>
         <p:nvSpPr>
@@ -6476,6 +6592,10 @@
             <a:prstDash val="solid"/>
           </a:ln>
         </p:spPr>
+        <p:txBody xmlns:a="http://schemas.openxmlformats.org/drawingml/2006/main">
+          <a:bodyPr/>
+          <a:p/>
+        </p:txBody>
       </p:sp>
       <p:sp>
         <p:nvSpPr>
@@ -6575,6 +6695,10 @@
             <a:prstDash val="solid"/>
           </a:ln>
         </p:spPr>
+        <p:txBody xmlns:a="http://schemas.openxmlformats.org/drawingml/2006/main">
+          <a:bodyPr/>
+          <a:p/>
+        </p:txBody>
       </p:sp>
       <p:sp>
         <p:nvSpPr>
@@ -6616,26 +6740,8 @@
           <a:bodyPr xmlns:a="http://schemas.openxmlformats.org/drawingml/2006/main" lIns="0" tIns="0" rIns="0" bIns="0" anchor="t"/>
           <a:lstStyle xmlns:a="http://schemas.openxmlformats.org/drawingml/2006/main"/>
           <a:p xmlns:a="http://schemas.openxmlformats.org/drawingml/2006/main">
-            <a:pPr algn="l">
-              <a:defRPr sz="1350" b="0">
-                <a:solidFill>
-                  <a:srgbClr val="111827"/>
-                </a:solidFill>
-                <a:latin typeface="Aptos"/>
-                <a:ea typeface="Aptos"/>
-                <a:cs typeface="Aptos"/>
-              </a:defRPr>
-            </a:pPr>
-            <a:r>
-              <a:rPr sz="1350" b="0">
-                <a:solidFill>
-                  <a:srgbClr val="111827"/>
-                </a:solidFill>
-                <a:latin typeface="Aptos"/>
-                <a:ea typeface="Aptos"/>
-                <a:cs typeface="Aptos"/>
-              </a:rPr>
-              <a:t>SDD/PQD-Kriterien abgedeckt</a:t>
+            <a:r>
+              <a:t>Bewertungskriterien abgedeckt</a:t>
             </a:r>
           </a:p>
         </p:txBody>
@@ -6674,6 +6780,10 @@
             <a:prstDash val="solid"/>
           </a:ln>
         </p:spPr>
+        <p:txBody xmlns:a="http://schemas.openxmlformats.org/drawingml/2006/main">
+          <a:bodyPr/>
+          <a:p/>
+        </p:txBody>
       </p:sp>
       <p:sp>
         <p:nvSpPr>
@@ -6715,26 +6825,8 @@
           <a:bodyPr xmlns:a="http://schemas.openxmlformats.org/drawingml/2006/main" lIns="0" tIns="0" rIns="0" bIns="0" anchor="t"/>
           <a:lstStyle xmlns:a="http://schemas.openxmlformats.org/drawingml/2006/main"/>
           <a:p xmlns:a="http://schemas.openxmlformats.org/drawingml/2006/main">
-            <a:pPr algn="l">
-              <a:defRPr sz="1350" b="0">
-                <a:solidFill>
-                  <a:srgbClr val="111827"/>
-                </a:solidFill>
-                <a:latin typeface="Aptos"/>
-                <a:ea typeface="Aptos"/>
-                <a:cs typeface="Aptos"/>
-              </a:defRPr>
-            </a:pPr>
-            <a:r>
-              <a:rPr sz="1350" b="0">
-                <a:solidFill>
-                  <a:srgbClr val="111827"/>
-                </a:solidFill>
-                <a:latin typeface="Aptos"/>
-                <a:ea typeface="Aptos"/>
-                <a:cs typeface="Aptos"/>
-              </a:rPr>
-              <a:t>Windows-Output kopiert</a:t>
+            <a:r>
+              <a:t>Output &amp; Quellen sichtbar</a:t>
             </a:r>
           </a:p>
         </p:txBody>
@@ -6773,6 +6865,10 @@
             <a:prstDash val="solid"/>
           </a:ln>
         </p:spPr>
+        <p:txBody xmlns:a="http://schemas.openxmlformats.org/drawingml/2006/main">
+          <a:bodyPr/>
+          <a:p/>
+        </p:txBody>
       </p:sp>
       <p:sp>
         <p:nvSpPr>
@@ -6814,26 +6910,8 @@
           <a:bodyPr xmlns:a="http://schemas.openxmlformats.org/drawingml/2006/main" lIns="0" tIns="0" rIns="0" bIns="0" anchor="t"/>
           <a:lstStyle xmlns:a="http://schemas.openxmlformats.org/drawingml/2006/main"/>
           <a:p xmlns:a="http://schemas.openxmlformats.org/drawingml/2006/main">
-            <a:pPr algn="l">
-              <a:defRPr sz="1350" b="0">
-                <a:solidFill>
-                  <a:srgbClr val="111827"/>
-                </a:solidFill>
-                <a:latin typeface="Aptos"/>
-                <a:ea typeface="Aptos"/>
-                <a:cs typeface="Aptos"/>
-              </a:defRPr>
-            </a:pPr>
-            <a:r>
-              <a:rPr sz="1350" b="0">
-                <a:solidFill>
-                  <a:srgbClr val="111827"/>
-                </a:solidFill>
-                <a:latin typeface="Aptos"/>
-                <a:ea typeface="Aptos"/>
-                <a:cs typeface="Aptos"/>
-              </a:rPr>
-              <a:t>Screenshots und Walkthrough-Video erzeugt</a:t>
+            <a:r>
+              <a:t>Real-Run-Video erzeugt</a:t>
             </a:r>
           </a:p>
         </p:txBody>
@@ -6870,6 +6948,10 @@
             <a:prstDash val="solid"/>
           </a:ln>
         </p:spPr>
+        <p:txBody xmlns:a="http://schemas.openxmlformats.org/drawingml/2006/main">
+          <a:bodyPr/>
+          <a:p/>
+        </p:txBody>
       </p:sp>
       <p:sp>
         <p:nvSpPr>
@@ -6911,26 +6993,8 @@
           <a:bodyPr xmlns:a="http://schemas.openxmlformats.org/drawingml/2006/main" lIns="0" tIns="0" rIns="0" bIns="0" anchor="t"/>
           <a:lstStyle xmlns:a="http://schemas.openxmlformats.org/drawingml/2006/main"/>
           <a:p xmlns:a="http://schemas.openxmlformats.org/drawingml/2006/main">
-            <a:pPr algn="l">
-              <a:defRPr sz="1950" b="1">
-                <a:solidFill>
-                  <a:srgbClr val="EA580C"/>
-                </a:solidFill>
-                <a:latin typeface="Aptos"/>
-                <a:ea typeface="Aptos"/>
-                <a:cs typeface="Aptos"/>
-              </a:defRPr>
-            </a:pPr>
-            <a:r>
-              <a:rPr sz="1950" b="1">
-                <a:solidFill>
-                  <a:srgbClr val="EA580C"/>
-                </a:solidFill>
-                <a:latin typeface="Aptos"/>
-                <a:ea typeface="Aptos"/>
-                <a:cs typeface="Aptos"/>
-              </a:rPr>
-              <a:t>Noch zu finalisieren</a:t>
+            <a:r>
+              <a:t>Abgabehinweise</a:t>
             </a:r>
           </a:p>
         </p:txBody>
@@ -6969,6 +7033,10 @@
             <a:prstDash val="solid"/>
           </a:ln>
         </p:spPr>
+        <p:txBody xmlns:a="http://schemas.openxmlformats.org/drawingml/2006/main">
+          <a:bodyPr/>
+          <a:p/>
+        </p:txBody>
       </p:sp>
       <p:sp>
         <p:nvSpPr>
@@ -7010,26 +7078,8 @@
           <a:bodyPr xmlns:a="http://schemas.openxmlformats.org/drawingml/2006/main" lIns="0" tIns="0" rIns="0" bIns="0" anchor="t"/>
           <a:lstStyle xmlns:a="http://schemas.openxmlformats.org/drawingml/2006/main"/>
           <a:p xmlns:a="http://schemas.openxmlformats.org/drawingml/2006/main">
-            <a:pPr algn="l">
-              <a:defRPr sz="1350" b="0">
-                <a:solidFill>
-                  <a:srgbClr val="111827"/>
-                </a:solidFill>
-                <a:latin typeface="Aptos"/>
-                <a:ea typeface="Aptos"/>
-                <a:cs typeface="Aptos"/>
-              </a:defRPr>
-            </a:pPr>
-            <a:r>
-              <a:rPr sz="1350" b="0">
-                <a:solidFill>
-                  <a:srgbClr val="111827"/>
-                </a:solidFill>
-                <a:latin typeface="Aptos"/>
-                <a:ea typeface="Aptos"/>
-                <a:cs typeface="Aptos"/>
-              </a:rPr>
-              <a:t>Docker Desktop per Parsec stabil starten</a:t>
+            <a:r>
+              <a:t>Screenshots im Bericht nutzen</a:t>
             </a:r>
           </a:p>
         </p:txBody>
@@ -7068,6 +7118,10 @@
             <a:prstDash val="solid"/>
           </a:ln>
         </p:spPr>
+        <p:txBody xmlns:a="http://schemas.openxmlformats.org/drawingml/2006/main">
+          <a:bodyPr/>
+          <a:p/>
+        </p:txBody>
       </p:sp>
       <p:sp>
         <p:nvSpPr>
@@ -7109,26 +7163,8 @@
           <a:bodyPr xmlns:a="http://schemas.openxmlformats.org/drawingml/2006/main" lIns="0" tIns="0" rIns="0" bIns="0" anchor="t"/>
           <a:lstStyle xmlns:a="http://schemas.openxmlformats.org/drawingml/2006/main"/>
           <a:p xmlns:a="http://schemas.openxmlformats.org/drawingml/2006/main">
-            <a:pPr algn="l">
-              <a:defRPr sz="1350" b="0">
-                <a:solidFill>
-                  <a:srgbClr val="111827"/>
-                </a:solidFill>
-                <a:latin typeface="Aptos"/>
-                <a:ea typeface="Aptos"/>
-                <a:cs typeface="Aptos"/>
-              </a:defRPr>
-            </a:pPr>
-            <a:r>
-              <a:rPr sz="1350" b="0">
-                <a:solidFill>
-                  <a:srgbClr val="111827"/>
-                </a:solidFill>
-                <a:latin typeface="Aptos"/>
-                <a:ea typeface="Aptos"/>
-                <a:cs typeface="Aptos"/>
-              </a:rPr>
-              <a:t>Live-Prozessvideo aufnehmen</a:t>
+            <a:r>
+              <a:t>SDD-Testing abgleichen</a:t>
             </a:r>
           </a:p>
         </p:txBody>
@@ -7167,6 +7203,10 @@
             <a:prstDash val="solid"/>
           </a:ln>
         </p:spPr>
+        <p:txBody xmlns:a="http://schemas.openxmlformats.org/drawingml/2006/main">
+          <a:bodyPr/>
+          <a:p/>
+        </p:txBody>
       </p:sp>
       <p:sp>
         <p:nvSpPr>
@@ -7208,26 +7248,8 @@
           <a:bodyPr xmlns:a="http://schemas.openxmlformats.org/drawingml/2006/main" lIns="0" tIns="0" rIns="0" bIns="0" anchor="t"/>
           <a:lstStyle xmlns:a="http://schemas.openxmlformats.org/drawingml/2006/main"/>
           <a:p xmlns:a="http://schemas.openxmlformats.org/drawingml/2006/main">
-            <a:pPr algn="l">
-              <a:defRPr sz="1350" b="0">
-                <a:solidFill>
-                  <a:srgbClr val="111827"/>
-                </a:solidFill>
-                <a:latin typeface="Aptos"/>
-                <a:ea typeface="Aptos"/>
-                <a:cs typeface="Aptos"/>
-              </a:defRPr>
-            </a:pPr>
-            <a:r>
-              <a:rPr sz="1350" b="0">
-                <a:solidFill>
-                  <a:srgbClr val="111827"/>
-                </a:solidFill>
-                <a:latin typeface="Aptos"/>
-                <a:ea typeface="Aptos"/>
-                <a:cs typeface="Aptos"/>
-              </a:rPr>
-              <a:t>Video-Link in Aufzeichnungsdatei eintragen</a:t>
+            <a:r>
+              <a:t>Keine Secrets zeigen</a:t>
             </a:r>
           </a:p>
         </p:txBody>
@@ -7266,6 +7288,10 @@
             <a:prstDash val="solid"/>
           </a:ln>
         </p:spPr>
+        <p:txBody xmlns:a="http://schemas.openxmlformats.org/drawingml/2006/main">
+          <a:bodyPr/>
+          <a:p/>
+        </p:txBody>
       </p:sp>
       <p:sp>
         <p:nvSpPr>
@@ -7307,26 +7333,8 @@
           <a:bodyPr xmlns:a="http://schemas.openxmlformats.org/drawingml/2006/main" lIns="0" tIns="0" rIns="0" bIns="0" anchor="t"/>
           <a:lstStyle xmlns:a="http://schemas.openxmlformats.org/drawingml/2006/main"/>
           <a:p xmlns:a="http://schemas.openxmlformats.org/drawingml/2006/main">
-            <a:pPr algn="l">
-              <a:defRPr sz="1350" b="0">
-                <a:solidFill>
-                  <a:srgbClr val="111827"/>
-                </a:solidFill>
-                <a:latin typeface="Aptos"/>
-                <a:ea typeface="Aptos"/>
-                <a:cs typeface="Aptos"/>
-              </a:defRPr>
-            </a:pPr>
-            <a:r>
-              <a:rPr sz="1350" b="0">
-                <a:solidFill>
-                  <a:srgbClr val="111827"/>
-                </a:solidFill>
-                <a:latin typeface="Aptos"/>
-                <a:ea typeface="Aptos"/>
-                <a:cs typeface="Aptos"/>
-              </a:rPr>
-              <a:t>Schriftliche Arbeit final bebildern</a:t>
+            <a:r>
+              <a:t>Live-Demo: Docker vorbereitet</a:t>
             </a:r>
           </a:p>
         </p:txBody>
@@ -7451,6 +7459,10 @@
             <a:prstDash val="solid"/>
           </a:ln>
         </p:spPr>
+        <p:txBody xmlns:a="http://schemas.openxmlformats.org/drawingml/2006/main">
+          <a:bodyPr/>
+          <a:p/>
+        </p:txBody>
       </p:sp>
       <p:sp>
         <p:nvSpPr>
@@ -7486,6 +7498,10 @@
             <a:prstDash val="solid"/>
           </a:ln>
         </p:spPr>
+        <p:txBody xmlns:a="http://schemas.openxmlformats.org/drawingml/2006/main">
+          <a:bodyPr/>
+          <a:p/>
+        </p:txBody>
       </p:sp>
       <p:sp>
         <p:nvSpPr>
@@ -7775,6 +7791,10 @@
             <a:prstDash val="solid"/>
           </a:ln>
         </p:spPr>
+        <p:txBody xmlns:a="http://schemas.openxmlformats.org/drawingml/2006/main">
+          <a:bodyPr/>
+          <a:p/>
+        </p:txBody>
       </p:sp>
       <p:sp>
         <p:nvSpPr>
@@ -7810,6 +7830,10 @@
             <a:prstDash val="solid"/>
           </a:ln>
         </p:spPr>
+        <p:txBody xmlns:a="http://schemas.openxmlformats.org/drawingml/2006/main">
+          <a:bodyPr/>
+          <a:p/>
+        </p:txBody>
       </p:sp>
       <p:sp>
         <p:nvSpPr>
@@ -7971,6 +7995,10 @@
             <a:prstDash val="solid"/>
           </a:ln>
         </p:spPr>
+        <p:txBody xmlns:a="http://schemas.openxmlformats.org/drawingml/2006/main">
+          <a:bodyPr/>
+          <a:p/>
+        </p:txBody>
       </p:sp>
       <p:sp>
         <p:nvSpPr>
@@ -8006,6 +8034,10 @@
             <a:prstDash val="solid"/>
           </a:ln>
         </p:spPr>
+        <p:txBody xmlns:a="http://schemas.openxmlformats.org/drawingml/2006/main">
+          <a:bodyPr/>
+          <a:p/>
+        </p:txBody>
       </p:sp>
       <p:sp>
         <p:nvSpPr>
@@ -8167,6 +8199,10 @@
             <a:prstDash val="solid"/>
           </a:ln>
         </p:spPr>
+        <p:txBody xmlns:a="http://schemas.openxmlformats.org/drawingml/2006/main">
+          <a:bodyPr/>
+          <a:p/>
+        </p:txBody>
       </p:sp>
       <p:sp>
         <p:nvSpPr>
@@ -8202,6 +8238,10 @@
             <a:prstDash val="solid"/>
           </a:ln>
         </p:spPr>
+        <p:txBody xmlns:a="http://schemas.openxmlformats.org/drawingml/2006/main">
+          <a:bodyPr/>
+          <a:p/>
+        </p:txBody>
       </p:sp>
       <p:sp>
         <p:nvSpPr>
@@ -8363,6 +8403,10 @@
             <a:prstDash val="solid"/>
           </a:ln>
         </p:spPr>
+        <p:txBody xmlns:a="http://schemas.openxmlformats.org/drawingml/2006/main">
+          <a:bodyPr/>
+          <a:p/>
+        </p:txBody>
       </p:sp>
       <p:sp>
         <p:nvSpPr>
@@ -8398,6 +8442,10 @@
             <a:prstDash val="solid"/>
           </a:ln>
         </p:spPr>
+        <p:txBody xmlns:a="http://schemas.openxmlformats.org/drawingml/2006/main">
+          <a:bodyPr/>
+          <a:p/>
+        </p:txBody>
       </p:sp>
       <p:sp>
         <p:nvSpPr>
@@ -8439,26 +8487,8 @@
           <a:bodyPr xmlns:a="http://schemas.openxmlformats.org/drawingml/2006/main" lIns="0" tIns="0" rIns="0" bIns="0" anchor="t"/>
           <a:lstStyle xmlns:a="http://schemas.openxmlformats.org/drawingml/2006/main"/>
           <a:p xmlns:a="http://schemas.openxmlformats.org/drawingml/2006/main">
-            <a:pPr algn="l">
-              <a:defRPr sz="1575" b="1">
-                <a:solidFill>
-                  <a:srgbClr val="111827"/>
-                </a:solidFill>
-                <a:latin typeface="Aptos"/>
-                <a:ea typeface="Aptos"/>
-                <a:cs typeface="Aptos"/>
-              </a:defRPr>
-            </a:pPr>
-            <a:r>
-              <a:rPr sz="1575" b="1">
-                <a:solidFill>
-                  <a:srgbClr val="111827"/>
-                </a:solidFill>
-                <a:latin typeface="Aptos"/>
-                <a:ea typeface="Aptos"/>
-                <a:cs typeface="Aptos"/>
-              </a:rPr>
-              <a:t>Fehlerfreier Durchlauf</a:t>
+            <a:r>
+              <a:t>Fehlerfreier Durchlauf / Video</a:t>
             </a:r>
           </a:p>
         </p:txBody>
@@ -8503,26 +8533,8 @@
           <a:bodyPr xmlns:a="http://schemas.openxmlformats.org/drawingml/2006/main" lIns="0" tIns="0" rIns="0" bIns="0" anchor="t"/>
           <a:lstStyle xmlns:a="http://schemas.openxmlformats.org/drawingml/2006/main"/>
           <a:p xmlns:a="http://schemas.openxmlformats.org/drawingml/2006/main">
-            <a:pPr algn="l">
-              <a:defRPr sz="1200" b="0">
-                <a:solidFill>
-                  <a:srgbClr val="475569"/>
-                </a:solidFill>
-                <a:latin typeface="Aptos"/>
-                <a:ea typeface="Aptos"/>
-                <a:cs typeface="Aptos"/>
-              </a:defRPr>
-            </a:pPr>
-            <a:r>
-              <a:rPr sz="1200" b="0">
-                <a:solidFill>
-                  <a:srgbClr val="475569"/>
-                </a:solidFill>
-                <a:latin typeface="Aptos"/>
-                <a:ea typeface="Aptos"/>
-                <a:cs typeface="Aptos"/>
-              </a:rPr>
-              <a:t>Nachweis über Video / Output-Screenshots aus Windows-Lauf</a:t>
+            <a:r>
+              <a:t>Nachweis über Real-Run-Video, Output-Screenshot und Quellen-JSON</a:t>
             </a:r>
           </a:p>
         </p:txBody>
@@ -8559,6 +8571,10 @@
             <a:prstDash val="solid"/>
           </a:ln>
         </p:spPr>
+        <p:txBody xmlns:a="http://schemas.openxmlformats.org/drawingml/2006/main">
+          <a:bodyPr/>
+          <a:p/>
+        </p:txBody>
       </p:sp>
       <p:sp>
         <p:nvSpPr>
@@ -8594,6 +8610,10 @@
             <a:prstDash val="solid"/>
           </a:ln>
         </p:spPr>
+        <p:txBody xmlns:a="http://schemas.openxmlformats.org/drawingml/2006/main">
+          <a:bodyPr/>
+          <a:p/>
+        </p:txBody>
       </p:sp>
       <p:sp>
         <p:nvSpPr>
@@ -8779,6 +8799,10 @@
             <a:prstDash val="solid"/>
           </a:ln>
         </p:spPr>
+        <p:txBody xmlns:a="http://schemas.openxmlformats.org/drawingml/2006/main">
+          <a:bodyPr/>
+          <a:p/>
+        </p:txBody>
       </p:sp>
       <p:sp>
         <p:nvSpPr>
@@ -8814,6 +8838,10 @@
             <a:prstDash val="solid"/>
           </a:ln>
         </p:spPr>
+        <p:txBody xmlns:a="http://schemas.openxmlformats.org/drawingml/2006/main">
+          <a:bodyPr/>
+          <a:p/>
+        </p:txBody>
       </p:sp>
       <p:sp>
         <p:nvSpPr>
@@ -9103,6 +9131,10 @@
             <a:prstDash val="solid"/>
           </a:ln>
         </p:spPr>
+        <p:txBody xmlns:a="http://schemas.openxmlformats.org/drawingml/2006/main">
+          <a:bodyPr/>
+          <a:p/>
+        </p:txBody>
       </p:sp>
       <p:sp>
         <p:nvSpPr>
@@ -9328,6 +9360,10 @@
             <a:prstDash val="solid"/>
           </a:ln>
         </p:spPr>
+        <p:txBody xmlns:a="http://schemas.openxmlformats.org/drawingml/2006/main">
+          <a:bodyPr/>
+          <a:p/>
+        </p:txBody>
       </p:sp>
       <p:sp>
         <p:nvSpPr>
@@ -9553,6 +9589,10 @@
             <a:prstDash val="solid"/>
           </a:ln>
         </p:spPr>
+        <p:txBody xmlns:a="http://schemas.openxmlformats.org/drawingml/2006/main">
+          <a:bodyPr/>
+          <a:p/>
+        </p:txBody>
       </p:sp>
       <p:sp>
         <p:nvSpPr>
@@ -9778,6 +9818,10 @@
             <a:prstDash val="solid"/>
           </a:ln>
         </p:spPr>
+        <p:txBody xmlns:a="http://schemas.openxmlformats.org/drawingml/2006/main">
+          <a:bodyPr/>
+          <a:p/>
+        </p:txBody>
       </p:sp>
       <p:sp>
         <p:nvSpPr>
@@ -10069,6 +10113,10 @@
             <a:prstDash val="solid"/>
           </a:ln>
         </p:spPr>
+        <p:txBody xmlns:a="http://schemas.openxmlformats.org/drawingml/2006/main">
+          <a:bodyPr/>
+          <a:p/>
+        </p:txBody>
       </p:sp>
       <p:sp>
         <p:nvSpPr>
@@ -10168,6 +10216,10 @@
             <a:prstDash val="solid"/>
           </a:ln>
         </p:spPr>
+        <p:txBody xmlns:a="http://schemas.openxmlformats.org/drawingml/2006/main">
+          <a:bodyPr/>
+          <a:p/>
+        </p:txBody>
       </p:sp>
       <p:sp>
         <p:nvSpPr>
@@ -10267,6 +10319,10 @@
             <a:prstDash val="solid"/>
           </a:ln>
         </p:spPr>
+        <p:txBody xmlns:a="http://schemas.openxmlformats.org/drawingml/2006/main">
+          <a:bodyPr/>
+          <a:p/>
+        </p:txBody>
       </p:sp>
       <p:sp>
         <p:nvSpPr>
@@ -10366,6 +10422,10 @@
             <a:prstDash val="solid"/>
           </a:ln>
         </p:spPr>
+        <p:txBody xmlns:a="http://schemas.openxmlformats.org/drawingml/2006/main">
+          <a:bodyPr/>
+          <a:p/>
+        </p:txBody>
       </p:sp>
       <p:sp>
         <p:nvSpPr>
@@ -10463,6 +10523,10 @@
             <a:prstDash val="solid"/>
           </a:ln>
         </p:spPr>
+        <p:txBody xmlns:a="http://schemas.openxmlformats.org/drawingml/2006/main">
+          <a:bodyPr/>
+          <a:p/>
+        </p:txBody>
       </p:sp>
       <p:sp>
         <p:nvSpPr>
@@ -10498,6 +10562,10 @@
             <a:prstDash val="solid"/>
           </a:ln>
         </p:spPr>
+        <p:txBody xmlns:a="http://schemas.openxmlformats.org/drawingml/2006/main">
+          <a:bodyPr/>
+          <a:p/>
+        </p:txBody>
       </p:sp>
       <p:sp>
         <p:nvSpPr>
@@ -10683,6 +10751,10 @@
             <a:prstDash val="solid"/>
           </a:ln>
         </p:spPr>
+        <p:txBody xmlns:a="http://schemas.openxmlformats.org/drawingml/2006/main">
+          <a:bodyPr/>
+          <a:p/>
+        </p:txBody>
       </p:sp>
       <p:sp>
         <p:nvSpPr>
@@ -10718,6 +10790,10 @@
             <a:prstDash val="solid"/>
           </a:ln>
         </p:spPr>
+        <p:txBody xmlns:a="http://schemas.openxmlformats.org/drawingml/2006/main">
+          <a:bodyPr/>
+          <a:p/>
+        </p:txBody>
       </p:sp>
       <p:sp>
         <p:nvSpPr>
@@ -11007,6 +11083,10 @@
             <a:prstDash val="solid"/>
           </a:ln>
         </p:spPr>
+        <p:txBody xmlns:a="http://schemas.openxmlformats.org/drawingml/2006/main">
+          <a:bodyPr/>
+          <a:p/>
+        </p:txBody>
       </p:sp>
       <p:sp>
         <p:nvSpPr>
@@ -11104,6 +11184,10 @@
             <a:prstDash val="solid"/>
           </a:ln>
         </p:spPr>
+        <p:txBody xmlns:a="http://schemas.openxmlformats.org/drawingml/2006/main">
+          <a:bodyPr/>
+          <a:p/>
+        </p:txBody>
       </p:sp>
       <p:sp>
         <p:nvSpPr>
@@ -11265,6 +11349,10 @@
             <a:prstDash val="solid"/>
           </a:ln>
         </p:spPr>
+        <p:txBody xmlns:a="http://schemas.openxmlformats.org/drawingml/2006/main">
+          <a:bodyPr/>
+          <a:p/>
+        </p:txBody>
       </p:sp>
       <p:sp>
         <p:nvSpPr>
@@ -11362,6 +11450,10 @@
             <a:prstDash val="solid"/>
           </a:ln>
         </p:spPr>
+        <p:txBody xmlns:a="http://schemas.openxmlformats.org/drawingml/2006/main">
+          <a:bodyPr/>
+          <a:p/>
+        </p:txBody>
       </p:sp>
       <p:sp>
         <p:nvSpPr>
@@ -11523,6 +11615,10 @@
             <a:prstDash val="solid"/>
           </a:ln>
         </p:spPr>
+        <p:txBody xmlns:a="http://schemas.openxmlformats.org/drawingml/2006/main">
+          <a:bodyPr/>
+          <a:p/>
+        </p:txBody>
       </p:sp>
       <p:sp>
         <p:nvSpPr>
@@ -11620,6 +11716,10 @@
             <a:prstDash val="solid"/>
           </a:ln>
         </p:spPr>
+        <p:txBody xmlns:a="http://schemas.openxmlformats.org/drawingml/2006/main">
+          <a:bodyPr/>
+          <a:p/>
+        </p:txBody>
       </p:sp>
       <p:sp>
         <p:nvSpPr>
@@ -11781,6 +11881,10 @@
             <a:prstDash val="solid"/>
           </a:ln>
         </p:spPr>
+        <p:txBody xmlns:a="http://schemas.openxmlformats.org/drawingml/2006/main">
+          <a:bodyPr/>
+          <a:p/>
+        </p:txBody>
       </p:sp>
       <p:sp>
         <p:nvSpPr>
@@ -11878,6 +11982,10 @@
             <a:prstDash val="solid"/>
           </a:ln>
         </p:spPr>
+        <p:txBody xmlns:a="http://schemas.openxmlformats.org/drawingml/2006/main">
+          <a:bodyPr/>
+          <a:p/>
+        </p:txBody>
       </p:sp>
       <p:sp>
         <p:nvSpPr>
@@ -12039,6 +12147,10 @@
             <a:prstDash val="solid"/>
           </a:ln>
         </p:spPr>
+        <p:txBody xmlns:a="http://schemas.openxmlformats.org/drawingml/2006/main">
+          <a:bodyPr/>
+          <a:p/>
+        </p:txBody>
       </p:sp>
       <p:sp>
         <p:nvSpPr>
@@ -12136,6 +12248,10 @@
             <a:prstDash val="solid"/>
           </a:ln>
         </p:spPr>
+        <p:txBody xmlns:a="http://schemas.openxmlformats.org/drawingml/2006/main">
+          <a:bodyPr/>
+          <a:p/>
+        </p:txBody>
       </p:sp>
       <p:sp>
         <p:nvSpPr>
@@ -12321,6 +12437,10 @@
             <a:prstDash val="solid"/>
           </a:ln>
         </p:spPr>
+        <p:txBody xmlns:a="http://schemas.openxmlformats.org/drawingml/2006/main">
+          <a:bodyPr/>
+          <a:p/>
+        </p:txBody>
       </p:sp>
       <p:sp>
         <p:nvSpPr>
@@ -12356,6 +12476,10 @@
             <a:prstDash val="solid"/>
           </a:ln>
         </p:spPr>
+        <p:txBody xmlns:a="http://schemas.openxmlformats.org/drawingml/2006/main">
+          <a:bodyPr/>
+          <a:p/>
+        </p:txBody>
       </p:sp>
       <p:sp>
         <p:nvSpPr>
@@ -12691,6 +12815,10 @@
             <a:prstDash val="solid"/>
           </a:ln>
         </p:spPr>
+        <p:txBody xmlns:a="http://schemas.openxmlformats.org/drawingml/2006/main">
+          <a:bodyPr/>
+          <a:p/>
+        </p:txBody>
       </p:sp>
       <p:sp>
         <p:nvSpPr>
@@ -12726,6 +12854,10 @@
             <a:prstDash val="solid"/>
           </a:ln>
         </p:spPr>
+        <p:txBody xmlns:a="http://schemas.openxmlformats.org/drawingml/2006/main">
+          <a:bodyPr/>
+          <a:p/>
+        </p:txBody>
       </p:sp>
       <p:sp>
         <p:nvSpPr>
@@ -13015,6 +13147,10 @@
             <a:prstDash val="solid"/>
           </a:ln>
         </p:spPr>
+        <p:txBody xmlns:a="http://schemas.openxmlformats.org/drawingml/2006/main">
+          <a:bodyPr/>
+          <a:p/>
+        </p:txBody>
       </p:sp>
       <p:sp>
         <p:nvSpPr>
@@ -13112,6 +13248,10 @@
             <a:prstDash val="solid"/>
           </a:ln>
         </p:spPr>
+        <p:txBody xmlns:a="http://schemas.openxmlformats.org/drawingml/2006/main">
+          <a:bodyPr/>
+          <a:p/>
+        </p:txBody>
       </p:sp>
       <p:sp>
         <p:nvSpPr>
@@ -13209,6 +13349,10 @@
             <a:prstDash val="solid"/>
           </a:ln>
         </p:spPr>
+        <p:txBody xmlns:a="http://schemas.openxmlformats.org/drawingml/2006/main">
+          <a:bodyPr/>
+          <a:p/>
+        </p:txBody>
       </p:sp>
       <p:sp>
         <p:nvSpPr>
@@ -13306,6 +13450,10 @@
             <a:prstDash val="solid"/>
           </a:ln>
         </p:spPr>
+        <p:txBody xmlns:a="http://schemas.openxmlformats.org/drawingml/2006/main">
+          <a:bodyPr/>
+          <a:p/>
+        </p:txBody>
       </p:sp>
       <p:sp>
         <p:nvSpPr>
@@ -13403,6 +13551,10 @@
             <a:prstDash val="solid"/>
           </a:ln>
         </p:spPr>
+        <p:txBody xmlns:a="http://schemas.openxmlformats.org/drawingml/2006/main">
+          <a:bodyPr/>
+          <a:p/>
+        </p:txBody>
       </p:sp>
       <p:sp>
         <p:nvSpPr>
@@ -13500,6 +13652,10 @@
             <a:prstDash val="solid"/>
           </a:ln>
         </p:spPr>
+        <p:txBody xmlns:a="http://schemas.openxmlformats.org/drawingml/2006/main">
+          <a:bodyPr/>
+          <a:p/>
+        </p:txBody>
       </p:sp>
       <p:sp>
         <p:nvSpPr>
@@ -13597,6 +13753,10 @@
             <a:prstDash val="solid"/>
           </a:ln>
         </p:spPr>
+        <p:txBody xmlns:a="http://schemas.openxmlformats.org/drawingml/2006/main">
+          <a:bodyPr/>
+          <a:p/>
+        </p:txBody>
       </p:sp>
       <p:sp>
         <p:nvSpPr>
@@ -13694,6 +13854,10 @@
             <a:prstDash val="solid"/>
           </a:ln>
         </p:spPr>
+        <p:txBody xmlns:a="http://schemas.openxmlformats.org/drawingml/2006/main">
+          <a:bodyPr/>
+          <a:p/>
+        </p:txBody>
       </p:sp>
       <p:sp>
         <p:nvSpPr>
@@ -13791,6 +13955,10 @@
             <a:prstDash val="solid"/>
           </a:ln>
         </p:spPr>
+        <p:txBody xmlns:a="http://schemas.openxmlformats.org/drawingml/2006/main">
+          <a:bodyPr/>
+          <a:p/>
+        </p:txBody>
       </p:sp>
       <p:sp>
         <p:nvSpPr>
@@ -13888,6 +14056,10 @@
             <a:prstDash val="solid"/>
           </a:ln>
         </p:spPr>
+        <p:txBody xmlns:a="http://schemas.openxmlformats.org/drawingml/2006/main">
+          <a:bodyPr/>
+          <a:p/>
+        </p:txBody>
       </p:sp>
       <p:sp>
         <p:nvSpPr>
@@ -14777,6 +14949,10 @@
             <a:prstDash val="solid"/>
           </a:ln>
         </p:spPr>
+        <p:txBody xmlns:a="http://schemas.openxmlformats.org/drawingml/2006/main">
+          <a:bodyPr/>
+          <a:p/>
+        </p:txBody>
       </p:sp>
       <p:sp>
         <p:nvSpPr>
@@ -14812,6 +14988,10 @@
             <a:prstDash val="solid"/>
           </a:ln>
         </p:spPr>
+        <p:txBody xmlns:a="http://schemas.openxmlformats.org/drawingml/2006/main">
+          <a:bodyPr/>
+          <a:p/>
+        </p:txBody>
       </p:sp>
       <p:sp>
         <p:nvSpPr>
@@ -15101,6 +15281,10 @@
             <a:prstDash val="solid"/>
           </a:ln>
         </p:spPr>
+        <p:txBody xmlns:a="http://schemas.openxmlformats.org/drawingml/2006/main">
+          <a:bodyPr/>
+          <a:p/>
+        </p:txBody>
       </p:sp>
       <p:sp>
         <p:nvSpPr>
@@ -15136,6 +15320,10 @@
             <a:prstDash val="solid"/>
           </a:ln>
         </p:spPr>
+        <p:txBody xmlns:a="http://schemas.openxmlformats.org/drawingml/2006/main">
+          <a:bodyPr/>
+          <a:p/>
+        </p:txBody>
       </p:sp>
       <p:sp>
         <p:nvSpPr>
@@ -15235,6 +15423,10 @@
             <a:prstDash val="solid"/>
           </a:ln>
         </p:spPr>
+        <p:txBody xmlns:a="http://schemas.openxmlformats.org/drawingml/2006/main">
+          <a:bodyPr/>
+          <a:p/>
+        </p:txBody>
       </p:sp>
       <p:sp>
         <p:nvSpPr>
@@ -15334,6 +15526,10 @@
             <a:prstDash val="solid"/>
           </a:ln>
         </p:spPr>
+        <p:txBody xmlns:a="http://schemas.openxmlformats.org/drawingml/2006/main">
+          <a:bodyPr/>
+          <a:p/>
+        </p:txBody>
       </p:sp>
       <p:sp>
         <p:nvSpPr>
@@ -15433,6 +15629,10 @@
             <a:prstDash val="solid"/>
           </a:ln>
         </p:spPr>
+        <p:txBody xmlns:a="http://schemas.openxmlformats.org/drawingml/2006/main">
+          <a:bodyPr/>
+          <a:p/>
+        </p:txBody>
       </p:sp>
       <p:sp>
         <p:nvSpPr>
@@ -15532,6 +15732,10 @@
             <a:prstDash val="solid"/>
           </a:ln>
         </p:spPr>
+        <p:txBody xmlns:a="http://schemas.openxmlformats.org/drawingml/2006/main">
+          <a:bodyPr/>
+          <a:p/>
+        </p:txBody>
       </p:sp>
       <p:sp>
         <p:nvSpPr>
@@ -15629,6 +15833,10 @@
             <a:prstDash val="solid"/>
           </a:ln>
         </p:spPr>
+        <p:txBody xmlns:a="http://schemas.openxmlformats.org/drawingml/2006/main">
+          <a:bodyPr/>
+          <a:p/>
+        </p:txBody>
       </p:sp>
       <p:sp>
         <p:nvSpPr>
@@ -15664,6 +15872,10 @@
             <a:prstDash val="solid"/>
           </a:ln>
         </p:spPr>
+        <p:txBody xmlns:a="http://schemas.openxmlformats.org/drawingml/2006/main">
+          <a:bodyPr/>
+          <a:p/>
+        </p:txBody>
       </p:sp>
       <p:sp>
         <p:nvSpPr>
@@ -15763,6 +15975,10 @@
             <a:prstDash val="solid"/>
           </a:ln>
         </p:spPr>
+        <p:txBody xmlns:a="http://schemas.openxmlformats.org/drawingml/2006/main">
+          <a:bodyPr/>
+          <a:p/>
+        </p:txBody>
       </p:sp>
       <p:sp>
         <p:nvSpPr>
@@ -15862,6 +16078,10 @@
             <a:prstDash val="solid"/>
           </a:ln>
         </p:spPr>
+        <p:txBody xmlns:a="http://schemas.openxmlformats.org/drawingml/2006/main">
+          <a:bodyPr/>
+          <a:p/>
+        </p:txBody>
       </p:sp>
       <p:sp>
         <p:nvSpPr>
@@ -15961,6 +16181,10 @@
             <a:prstDash val="solid"/>
           </a:ln>
         </p:spPr>
+        <p:txBody xmlns:a="http://schemas.openxmlformats.org/drawingml/2006/main">
+          <a:bodyPr/>
+          <a:p/>
+        </p:txBody>
       </p:sp>
       <p:sp>
         <p:nvSpPr>
@@ -16060,6 +16284,10 @@
             <a:prstDash val="solid"/>
           </a:ln>
         </p:spPr>
+        <p:txBody xmlns:a="http://schemas.openxmlformats.org/drawingml/2006/main">
+          <a:bodyPr/>
+          <a:p/>
+        </p:txBody>
       </p:sp>
       <p:sp>
         <p:nvSpPr>
@@ -16157,6 +16385,10 @@
             <a:prstDash val="solid"/>
           </a:ln>
         </p:spPr>
+        <p:txBody xmlns:a="http://schemas.openxmlformats.org/drawingml/2006/main">
+          <a:bodyPr/>
+          <a:p/>
+        </p:txBody>
       </p:sp>
       <p:sp>
         <p:nvSpPr>
@@ -16192,6 +16424,10 @@
             <a:prstDash val="solid"/>
           </a:ln>
         </p:spPr>
+        <p:txBody xmlns:a="http://schemas.openxmlformats.org/drawingml/2006/main">
+          <a:bodyPr/>
+          <a:p/>
+        </p:txBody>
       </p:sp>
       <p:sp>
         <p:nvSpPr>
@@ -16291,6 +16527,10 @@
             <a:prstDash val="solid"/>
           </a:ln>
         </p:spPr>
+        <p:txBody xmlns:a="http://schemas.openxmlformats.org/drawingml/2006/main">
+          <a:bodyPr/>
+          <a:p/>
+        </p:txBody>
       </p:sp>
       <p:sp>
         <p:nvSpPr>
@@ -16390,6 +16630,10 @@
             <a:prstDash val="solid"/>
           </a:ln>
         </p:spPr>
+        <p:txBody xmlns:a="http://schemas.openxmlformats.org/drawingml/2006/main">
+          <a:bodyPr/>
+          <a:p/>
+        </p:txBody>
       </p:sp>
       <p:sp>
         <p:nvSpPr>
@@ -16489,6 +16733,10 @@
             <a:prstDash val="solid"/>
           </a:ln>
         </p:spPr>
+        <p:txBody xmlns:a="http://schemas.openxmlformats.org/drawingml/2006/main">
+          <a:bodyPr/>
+          <a:p/>
+        </p:txBody>
       </p:sp>
       <p:sp>
         <p:nvSpPr>
@@ -16588,6 +16836,10 @@
             <a:prstDash val="solid"/>
           </a:ln>
         </p:spPr>
+        <p:txBody xmlns:a="http://schemas.openxmlformats.org/drawingml/2006/main">
+          <a:bodyPr/>
+          <a:p/>
+        </p:txBody>
       </p:sp>
       <p:sp>
         <p:nvSpPr>
@@ -16685,6 +16937,10 @@
             <a:prstDash val="solid"/>
           </a:ln>
         </p:spPr>
+        <p:txBody xmlns:a="http://schemas.openxmlformats.org/drawingml/2006/main">
+          <a:bodyPr/>
+          <a:p/>
+        </p:txBody>
       </p:sp>
       <p:sp>
         <p:nvSpPr>
@@ -16720,6 +16976,10 @@
             <a:prstDash val="solid"/>
           </a:ln>
         </p:spPr>
+        <p:txBody xmlns:a="http://schemas.openxmlformats.org/drawingml/2006/main">
+          <a:bodyPr/>
+          <a:p/>
+        </p:txBody>
       </p:sp>
       <p:sp>
         <p:nvSpPr>
@@ -16819,6 +17079,10 @@
             <a:prstDash val="solid"/>
           </a:ln>
         </p:spPr>
+        <p:txBody xmlns:a="http://schemas.openxmlformats.org/drawingml/2006/main">
+          <a:bodyPr/>
+          <a:p/>
+        </p:txBody>
       </p:sp>
       <p:sp>
         <p:nvSpPr>
@@ -16918,6 +17182,10 @@
             <a:prstDash val="solid"/>
           </a:ln>
         </p:spPr>
+        <p:txBody xmlns:a="http://schemas.openxmlformats.org/drawingml/2006/main">
+          <a:bodyPr/>
+          <a:p/>
+        </p:txBody>
       </p:sp>
       <p:sp>
         <p:nvSpPr>
@@ -17017,6 +17285,10 @@
             <a:prstDash val="solid"/>
           </a:ln>
         </p:spPr>
+        <p:txBody xmlns:a="http://schemas.openxmlformats.org/drawingml/2006/main">
+          <a:bodyPr/>
+          <a:p/>
+        </p:txBody>
       </p:sp>
       <p:sp>
         <p:nvSpPr>
@@ -17116,6 +17388,10 @@
             <a:prstDash val="solid"/>
           </a:ln>
         </p:spPr>
+        <p:txBody xmlns:a="http://schemas.openxmlformats.org/drawingml/2006/main">
+          <a:bodyPr/>
+          <a:p/>
+        </p:txBody>
       </p:sp>
       <p:sp>
         <p:nvSpPr>
@@ -17237,6 +17513,10 @@
             <a:prstDash val="solid"/>
           </a:ln>
         </p:spPr>
+        <p:txBody xmlns:a="http://schemas.openxmlformats.org/drawingml/2006/main">
+          <a:bodyPr/>
+          <a:p/>
+        </p:txBody>
       </p:sp>
       <p:sp>
         <p:nvSpPr>
@@ -17272,6 +17552,10 @@
             <a:prstDash val="solid"/>
           </a:ln>
         </p:spPr>
+        <p:txBody xmlns:a="http://schemas.openxmlformats.org/drawingml/2006/main">
+          <a:bodyPr/>
+          <a:p/>
+        </p:txBody>
       </p:sp>
       <p:sp>
         <p:nvSpPr>
@@ -17561,6 +17845,10 @@
             <a:prstDash val="solid"/>
           </a:ln>
         </p:spPr>
+        <p:txBody xmlns:a="http://schemas.openxmlformats.org/drawingml/2006/main">
+          <a:bodyPr/>
+          <a:p/>
+        </p:txBody>
       </p:sp>
       <p:sp>
         <p:nvSpPr>
@@ -17596,6 +17884,10 @@
             <a:prstDash val="solid"/>
           </a:ln>
         </p:spPr>
+        <p:txBody xmlns:a="http://schemas.openxmlformats.org/drawingml/2006/main">
+          <a:bodyPr/>
+          <a:p/>
+        </p:txBody>
       </p:sp>
       <p:sp>
         <p:nvSpPr>
@@ -17757,6 +18049,10 @@
             <a:prstDash val="solid"/>
           </a:ln>
         </p:spPr>
+        <p:txBody xmlns:a="http://schemas.openxmlformats.org/drawingml/2006/main">
+          <a:bodyPr/>
+          <a:p/>
+        </p:txBody>
       </p:sp>
       <p:sp>
         <p:nvSpPr>
@@ -17792,6 +18088,10 @@
             <a:prstDash val="solid"/>
           </a:ln>
         </p:spPr>
+        <p:txBody xmlns:a="http://schemas.openxmlformats.org/drawingml/2006/main">
+          <a:bodyPr/>
+          <a:p/>
+        </p:txBody>
       </p:sp>
       <p:sp>
         <p:nvSpPr>
@@ -17953,6 +18253,10 @@
             <a:prstDash val="solid"/>
           </a:ln>
         </p:spPr>
+        <p:txBody xmlns:a="http://schemas.openxmlformats.org/drawingml/2006/main">
+          <a:bodyPr/>
+          <a:p/>
+        </p:txBody>
       </p:sp>
       <p:sp>
         <p:nvSpPr>
@@ -17988,6 +18292,10 @@
             <a:prstDash val="solid"/>
           </a:ln>
         </p:spPr>
+        <p:txBody xmlns:a="http://schemas.openxmlformats.org/drawingml/2006/main">
+          <a:bodyPr/>
+          <a:p/>
+        </p:txBody>
       </p:sp>
       <p:sp>
         <p:nvSpPr>
@@ -18149,6 +18457,10 @@
             <a:prstDash val="solid"/>
           </a:ln>
         </p:spPr>
+        <p:txBody xmlns:a="http://schemas.openxmlformats.org/drawingml/2006/main">
+          <a:bodyPr/>
+          <a:p/>
+        </p:txBody>
       </p:sp>
       <p:sp>
         <p:nvSpPr>
@@ -18184,6 +18496,10 @@
             <a:prstDash val="solid"/>
           </a:ln>
         </p:spPr>
+        <p:txBody xmlns:a="http://schemas.openxmlformats.org/drawingml/2006/main">
+          <a:bodyPr/>
+          <a:p/>
+        </p:txBody>
       </p:sp>
       <p:sp>
         <p:nvSpPr>
@@ -18345,6 +18661,10 @@
             <a:prstDash val="solid"/>
           </a:ln>
         </p:spPr>
+        <p:txBody xmlns:a="http://schemas.openxmlformats.org/drawingml/2006/main">
+          <a:bodyPr/>
+          <a:p/>
+        </p:txBody>
       </p:sp>
       <p:sp>
         <p:nvSpPr>
@@ -18466,6 +18786,10 @@
             <a:prstDash val="solid"/>
           </a:ln>
         </p:spPr>
+        <p:txBody xmlns:a="http://schemas.openxmlformats.org/drawingml/2006/main">
+          <a:bodyPr/>
+          <a:p/>
+        </p:txBody>
       </p:sp>
       <p:sp>
         <p:nvSpPr>
@@ -18501,6 +18825,10 @@
             <a:prstDash val="solid"/>
           </a:ln>
         </p:spPr>
+        <p:txBody xmlns:a="http://schemas.openxmlformats.org/drawingml/2006/main">
+          <a:bodyPr/>
+          <a:p/>
+        </p:txBody>
       </p:sp>
       <p:sp>
         <p:nvSpPr>
@@ -18670,26 +18998,11 @@
           <a:bodyPr xmlns:a="http://schemas.openxmlformats.org/drawingml/2006/main" lIns="0" tIns="0" rIns="0" bIns="0" anchor="t"/>
           <a:lstStyle xmlns:a="http://schemas.openxmlformats.org/drawingml/2006/main"/>
           <a:p xmlns:a="http://schemas.openxmlformats.org/drawingml/2006/main">
-            <a:pPr algn="l">
-              <a:defRPr sz="2700" b="1">
-                <a:solidFill>
-                  <a:srgbClr val="111827"/>
-                </a:solidFill>
+            <a:r>
+              <a:rPr b="1" sz="3000">
                 <a:latin typeface="Aptos Display"/>
-                <a:ea typeface="Aptos Display"/>
-                <a:cs typeface="Aptos Display"/>
-              </a:defRPr>
-            </a:pPr>
-            <a:r>
-              <a:rPr sz="2700" b="1">
-                <a:solidFill>
-                  <a:srgbClr val="111827"/>
-                </a:solidFill>
-                <a:latin typeface="Aptos Display"/>
-                <a:ea typeface="Aptos Display"/>
-                <a:cs typeface="Aptos Display"/>
               </a:rPr>
-              <a:t>Durchlaufnachweis: Windows-Run erzeugt Output</a:t>
+              <a:t>Durchlaufnachweis: UiPath-Run</a:t>
             </a:r>
           </a:p>
         </p:txBody>
@@ -18733,29 +19046,7 @@
         <p:txBody>
           <a:bodyPr xmlns:a="http://schemas.openxmlformats.org/drawingml/2006/main" lIns="0" tIns="0" rIns="0" bIns="0" anchor="t"/>
           <a:lstStyle xmlns:a="http://schemas.openxmlformats.org/drawingml/2006/main"/>
-          <a:p xmlns:a="http://schemas.openxmlformats.org/drawingml/2006/main">
-            <a:pPr algn="l">
-              <a:defRPr sz="1350" b="0">
-                <a:solidFill>
-                  <a:srgbClr val="475569"/>
-                </a:solidFill>
-                <a:latin typeface="Aptos"/>
-                <a:ea typeface="Aptos"/>
-                <a:cs typeface="Aptos"/>
-              </a:defRPr>
-            </a:pPr>
-            <a:r>
-              <a:rPr sz="1350" b="0">
-                <a:solidFill>
-                  <a:srgbClr val="475569"/>
-                </a:solidFill>
-                <a:latin typeface="Aptos"/>
-                <a:ea typeface="Aptos"/>
-                <a:cs typeface="Aptos"/>
-              </a:rPr>
-              <a:t>Der erfolgreiche Lauf hat HTML und Sources JSON erzeugt; die finale Abgabe sollte zusätzlich das Prozessvideo verlinken.</a:t>
-            </a:r>
-          </a:p>
+          <a:p xmlns:a="http://schemas.openxmlformats.org/drawingml/2006/main"/>
         </p:txBody>
       </p:sp>
       <p:pic>
@@ -18812,6 +19103,10 @@
             <a:prstDash val="solid"/>
           </a:ln>
         </p:spPr>
+        <p:txBody xmlns:a="http://schemas.openxmlformats.org/drawingml/2006/main">
+          <a:bodyPr/>
+          <a:p/>
+        </p:txBody>
       </p:sp>
       <p:sp>
         <p:nvSpPr>
@@ -18973,6 +19268,10 @@
             <a:prstDash val="solid"/>
           </a:ln>
         </p:spPr>
+        <p:txBody xmlns:a="http://schemas.openxmlformats.org/drawingml/2006/main">
+          <a:bodyPr/>
+          <a:p/>
+        </p:txBody>
       </p:sp>
       <p:sp>
         <p:nvSpPr>
@@ -19014,26 +19313,8 @@
           <a:bodyPr xmlns:a="http://schemas.openxmlformats.org/drawingml/2006/main" lIns="0" tIns="0" rIns="0" bIns="0" anchor="t"/>
           <a:lstStyle xmlns:a="http://schemas.openxmlformats.org/drawingml/2006/main"/>
           <a:p xmlns:a="http://schemas.openxmlformats.org/drawingml/2006/main">
-            <a:pPr algn="l">
-              <a:defRPr sz="1650" b="1">
-                <a:solidFill>
-                  <a:srgbClr val="2563EB"/>
-                </a:solidFill>
-                <a:latin typeface="Aptos"/>
-                <a:ea typeface="Aptos"/>
-                <a:cs typeface="Aptos"/>
-              </a:defRPr>
-            </a:pPr>
-            <a:r>
-              <a:rPr sz="1650" b="1">
-                <a:solidFill>
-                  <a:srgbClr val="2563EB"/>
-                </a:solidFill>
-                <a:latin typeface="Aptos"/>
-                <a:ea typeface="Aptos"/>
-                <a:cs typeface="Aptos"/>
-              </a:rPr>
-              <a:t>Keine Secrets sichtbar</a:t>
+            <a:r>
+              <a:t>Secrets geschützt</a:t>
             </a:r>
           </a:p>
         </p:txBody>
@@ -19078,25 +19359,7 @@
           <a:bodyPr xmlns:a="http://schemas.openxmlformats.org/drawingml/2006/main" lIns="0" tIns="0" rIns="0" bIns="0" anchor="t"/>
           <a:lstStyle xmlns:a="http://schemas.openxmlformats.org/drawingml/2006/main"/>
           <a:p xmlns:a="http://schemas.openxmlformats.org/drawingml/2006/main">
-            <a:pPr algn="l">
-              <a:defRPr sz="1350" b="0">
-                <a:solidFill>
-                  <a:srgbClr val="111827"/>
-                </a:solidFill>
-                <a:latin typeface="Aptos"/>
-                <a:ea typeface="Aptos"/>
-                <a:cs typeface="Aptos"/>
-              </a:defRPr>
-            </a:pPr>
-            <a:r>
-              <a:rPr sz="1350" b="0">
-                <a:solidFill>
-                  <a:srgbClr val="111827"/>
-                </a:solidFill>
-                <a:latin typeface="Aptos"/>
-                <a:ea typeface="Aptos"/>
-                <a:cs typeface="Aptos"/>
-              </a:rPr>
+            <a:r>
               <a:t>.env bleibt lokal</a:t>
             </a:r>
           </a:p>
@@ -19134,6 +19397,10 @@
             <a:prstDash val="solid"/>
           </a:ln>
         </p:spPr>
+        <p:txBody xmlns:a="http://schemas.openxmlformats.org/drawingml/2006/main">
+          <a:bodyPr/>
+          <a:p/>
+        </p:txBody>
       </p:sp>
       <p:sp>
         <p:nvSpPr>
@@ -19175,26 +19442,8 @@
           <a:bodyPr xmlns:a="http://schemas.openxmlformats.org/drawingml/2006/main" lIns="0" tIns="0" rIns="0" bIns="0" anchor="t"/>
           <a:lstStyle xmlns:a="http://schemas.openxmlformats.org/drawingml/2006/main"/>
           <a:p xmlns:a="http://schemas.openxmlformats.org/drawingml/2006/main">
-            <a:pPr algn="l">
-              <a:defRPr sz="1650" b="1">
-                <a:solidFill>
-                  <a:srgbClr val="EA580C"/>
-                </a:solidFill>
-                <a:latin typeface="Aptos"/>
-                <a:ea typeface="Aptos"/>
-                <a:cs typeface="Aptos"/>
-              </a:defRPr>
-            </a:pPr>
-            <a:r>
-              <a:rPr sz="1650" b="1">
-                <a:solidFill>
-                  <a:srgbClr val="EA580C"/>
-                </a:solidFill>
-                <a:latin typeface="Aptos"/>
-                <a:ea typeface="Aptos"/>
-                <a:cs typeface="Aptos"/>
-              </a:rPr>
-              <a:t>Video vorbereitet</a:t>
+            <a:r>
+              <a:t>Video vorhanden</a:t>
             </a:r>
           </a:p>
         </p:txBody>
@@ -19239,26 +19488,8 @@
           <a:bodyPr xmlns:a="http://schemas.openxmlformats.org/drawingml/2006/main" lIns="0" tIns="0" rIns="0" bIns="0" anchor="t"/>
           <a:lstStyle xmlns:a="http://schemas.openxmlformats.org/drawingml/2006/main"/>
           <a:p xmlns:a="http://schemas.openxmlformats.org/drawingml/2006/main">
-            <a:pPr algn="l">
-              <a:defRPr sz="1275" b="0">
-                <a:solidFill>
-                  <a:srgbClr val="111827"/>
-                </a:solidFill>
-                <a:latin typeface="Aptos"/>
-                <a:ea typeface="Aptos"/>
-                <a:cs typeface="Aptos"/>
-              </a:defRPr>
-            </a:pPr>
-            <a:r>
-              <a:rPr sz="1275" b="0">
-                <a:solidFill>
-                  <a:srgbClr val="111827"/>
-                </a:solidFill>
-                <a:latin typeface="Aptos"/>
-                <a:ea typeface="Aptos"/>
-                <a:cs typeface="Aptos"/>
-              </a:rPr>
-              <a:t>Walkthrough liegt vor; Live-Parsesc-Aufnahme bleibt ideal.</a:t>
+            <a:r>
+              <a:t>Real-Run-Video im Repo; Exit Code 0.</a:t>
             </a:r>
           </a:p>
         </p:txBody>

</xml_diff>